<commit_message>
fix: adapt AI-Startklar exercises to focus
</commit_message>
<xml_diff>
--- a/deliverables/ai-startklar/schulung/06-trainerfolien.pptx
+++ b/deliverables/ai-startklar/schulung/06-trainerfolien.pptx
@@ -2,52 +2,52 @@
 <file path=ppt/presentation.xml><?xml version="1.0" encoding="utf-8"?>
 <p:presentation xmlns:p="http://schemas.openxmlformats.org/presentationml/2006/main">
   <p:sldMasterIdLst>
-    <p:sldMasterId xmlns:r="http://schemas.openxmlformats.org/officeDocument/2006/relationships" id="2147483648" r:id="Rc36aad4dd86a4c8f"/>
+    <p:sldMasterId xmlns:r="http://schemas.openxmlformats.org/officeDocument/2006/relationships" id="2147483648" r:id="R8177b670910c4016"/>
   </p:sldMasterIdLst>
   <p:notesMasterIdLst>
-    <p:notesMasterId xmlns:r="http://schemas.openxmlformats.org/officeDocument/2006/relationships" r:id="R1282fd808b804274"/>
+    <p:notesMasterId xmlns:r="http://schemas.openxmlformats.org/officeDocument/2006/relationships" r:id="R3ef40b02da544cb7"/>
   </p:notesMasterIdLst>
   <p:sldIdLst>
-    <p:sldId xmlns:r="http://schemas.openxmlformats.org/officeDocument/2006/relationships" id="256" r:id="R3e33458ebee24f52"/>
-    <p:sldId xmlns:r="http://schemas.openxmlformats.org/officeDocument/2006/relationships" id="257" r:id="Rfce4595ac8414d37"/>
-    <p:sldId xmlns:r="http://schemas.openxmlformats.org/officeDocument/2006/relationships" id="258" r:id="R49f9948e63274bde"/>
-    <p:sldId xmlns:r="http://schemas.openxmlformats.org/officeDocument/2006/relationships" id="259" r:id="Rbf90a442711b4b10"/>
-    <p:sldId xmlns:r="http://schemas.openxmlformats.org/officeDocument/2006/relationships" id="260" r:id="R8037e0d347214d9b"/>
-    <p:sldId xmlns:r="http://schemas.openxmlformats.org/officeDocument/2006/relationships" id="261" r:id="R0f4c76ce51fc4d2e"/>
-    <p:sldId xmlns:r="http://schemas.openxmlformats.org/officeDocument/2006/relationships" id="262" r:id="Rfdf421823f67485a"/>
-    <p:sldId xmlns:r="http://schemas.openxmlformats.org/officeDocument/2006/relationships" id="263" r:id="R7e440cced3764ff6"/>
-    <p:sldId xmlns:r="http://schemas.openxmlformats.org/officeDocument/2006/relationships" id="264" r:id="R97139654f60647e9"/>
-    <p:sldId xmlns:r="http://schemas.openxmlformats.org/officeDocument/2006/relationships" id="265" r:id="Rdec03b93b079427d"/>
-    <p:sldId xmlns:r="http://schemas.openxmlformats.org/officeDocument/2006/relationships" id="266" r:id="R5d7990e3646f491a"/>
-    <p:sldId xmlns:r="http://schemas.openxmlformats.org/officeDocument/2006/relationships" id="267" r:id="R9df3ec959ae8411c"/>
-    <p:sldId xmlns:r="http://schemas.openxmlformats.org/officeDocument/2006/relationships" id="268" r:id="R414f64200b874bf3"/>
-    <p:sldId xmlns:r="http://schemas.openxmlformats.org/officeDocument/2006/relationships" id="269" r:id="R3cf8c344e6894241"/>
-    <p:sldId xmlns:r="http://schemas.openxmlformats.org/officeDocument/2006/relationships" id="270" r:id="R37fab2b5f5014856"/>
-    <p:sldId xmlns:r="http://schemas.openxmlformats.org/officeDocument/2006/relationships" id="271" r:id="R27c522987f0e4589"/>
-    <p:sldId xmlns:r="http://schemas.openxmlformats.org/officeDocument/2006/relationships" id="272" r:id="R4eb3131ab3c0459b"/>
-    <p:sldId xmlns:r="http://schemas.openxmlformats.org/officeDocument/2006/relationships" id="273" r:id="R77d93b5453a44d5e"/>
-    <p:sldId xmlns:r="http://schemas.openxmlformats.org/officeDocument/2006/relationships" id="274" r:id="Rfbba88a354e642c7"/>
-    <p:sldId xmlns:r="http://schemas.openxmlformats.org/officeDocument/2006/relationships" id="275" r:id="R464a24b5bff4413e"/>
-    <p:sldId xmlns:r="http://schemas.openxmlformats.org/officeDocument/2006/relationships" id="276" r:id="Rc21a8d4bca9945bc"/>
-    <p:sldId xmlns:r="http://schemas.openxmlformats.org/officeDocument/2006/relationships" id="277" r:id="R17b56da990954c85"/>
-    <p:sldId xmlns:r="http://schemas.openxmlformats.org/officeDocument/2006/relationships" id="278" r:id="Rfbab58b9015c46f6"/>
-    <p:sldId xmlns:r="http://schemas.openxmlformats.org/officeDocument/2006/relationships" id="279" r:id="Rd80336f0152b41b6"/>
-    <p:sldId xmlns:r="http://schemas.openxmlformats.org/officeDocument/2006/relationships" id="280" r:id="R71928714cedc464d"/>
-    <p:sldId xmlns:r="http://schemas.openxmlformats.org/officeDocument/2006/relationships" id="281" r:id="Rded75d053d024973"/>
-    <p:sldId xmlns:r="http://schemas.openxmlformats.org/officeDocument/2006/relationships" id="282" r:id="R7d459da06b034bde"/>
-    <p:sldId xmlns:r="http://schemas.openxmlformats.org/officeDocument/2006/relationships" id="283" r:id="R50badb23b9a94447"/>
-    <p:sldId xmlns:r="http://schemas.openxmlformats.org/officeDocument/2006/relationships" id="284" r:id="Rca603d89d2254cc5"/>
-    <p:sldId xmlns:r="http://schemas.openxmlformats.org/officeDocument/2006/relationships" id="285" r:id="Rd38f8c37e31d4b90"/>
-    <p:sldId xmlns:r="http://schemas.openxmlformats.org/officeDocument/2006/relationships" id="286" r:id="R827f487937874ffb"/>
-    <p:sldId xmlns:r="http://schemas.openxmlformats.org/officeDocument/2006/relationships" id="287" r:id="R259a5813116146e7"/>
-    <p:sldId xmlns:r="http://schemas.openxmlformats.org/officeDocument/2006/relationships" id="288" r:id="R5734d0a3fd8f4858"/>
-    <p:sldId xmlns:r="http://schemas.openxmlformats.org/officeDocument/2006/relationships" id="289" r:id="Re174c81ecb754fbf"/>
-    <p:sldId xmlns:r="http://schemas.openxmlformats.org/officeDocument/2006/relationships" id="290" r:id="Rf0faf2c29cd249f9"/>
-    <p:sldId xmlns:r="http://schemas.openxmlformats.org/officeDocument/2006/relationships" id="291" r:id="R009cf35e8ec54df4"/>
-    <p:sldId xmlns:r="http://schemas.openxmlformats.org/officeDocument/2006/relationships" id="292" r:id="R7279b7f1a22143c1"/>
-    <p:sldId xmlns:r="http://schemas.openxmlformats.org/officeDocument/2006/relationships" id="293" r:id="R78e330797fd44795"/>
-    <p:sldId xmlns:r="http://schemas.openxmlformats.org/officeDocument/2006/relationships" id="294" r:id="R1322006d2c324a2a"/>
-    <p:sldId xmlns:r="http://schemas.openxmlformats.org/officeDocument/2006/relationships" id="295" r:id="R9b25912dbcde4735"/>
+    <p:sldId xmlns:r="http://schemas.openxmlformats.org/officeDocument/2006/relationships" id="256" r:id="Rf088f940569b42a9"/>
+    <p:sldId xmlns:r="http://schemas.openxmlformats.org/officeDocument/2006/relationships" id="257" r:id="R7bcfd20a962f46c5"/>
+    <p:sldId xmlns:r="http://schemas.openxmlformats.org/officeDocument/2006/relationships" id="258" r:id="Rf2e27a4ae03b4c38"/>
+    <p:sldId xmlns:r="http://schemas.openxmlformats.org/officeDocument/2006/relationships" id="259" r:id="R47317ad9ace543a5"/>
+    <p:sldId xmlns:r="http://schemas.openxmlformats.org/officeDocument/2006/relationships" id="260" r:id="R87c147c58aaa48d3"/>
+    <p:sldId xmlns:r="http://schemas.openxmlformats.org/officeDocument/2006/relationships" id="261" r:id="R5b7954b43c0b4d84"/>
+    <p:sldId xmlns:r="http://schemas.openxmlformats.org/officeDocument/2006/relationships" id="262" r:id="R7825e2217ed94e66"/>
+    <p:sldId xmlns:r="http://schemas.openxmlformats.org/officeDocument/2006/relationships" id="263" r:id="R94be1598a7a24224"/>
+    <p:sldId xmlns:r="http://schemas.openxmlformats.org/officeDocument/2006/relationships" id="264" r:id="R107b5075ca4f454e"/>
+    <p:sldId xmlns:r="http://schemas.openxmlformats.org/officeDocument/2006/relationships" id="265" r:id="Rf499de33a40847e3"/>
+    <p:sldId xmlns:r="http://schemas.openxmlformats.org/officeDocument/2006/relationships" id="266" r:id="R5aa4acd096b943ec"/>
+    <p:sldId xmlns:r="http://schemas.openxmlformats.org/officeDocument/2006/relationships" id="267" r:id="R4c35f44aeb9541ab"/>
+    <p:sldId xmlns:r="http://schemas.openxmlformats.org/officeDocument/2006/relationships" id="268" r:id="Rd7b5e6d50fcf40f8"/>
+    <p:sldId xmlns:r="http://schemas.openxmlformats.org/officeDocument/2006/relationships" id="269" r:id="R94aa259eb3e34cd7"/>
+    <p:sldId xmlns:r="http://schemas.openxmlformats.org/officeDocument/2006/relationships" id="270" r:id="R73c245bdb2db4eae"/>
+    <p:sldId xmlns:r="http://schemas.openxmlformats.org/officeDocument/2006/relationships" id="271" r:id="R78ad69030071455c"/>
+    <p:sldId xmlns:r="http://schemas.openxmlformats.org/officeDocument/2006/relationships" id="272" r:id="R1403673472d64c9e"/>
+    <p:sldId xmlns:r="http://schemas.openxmlformats.org/officeDocument/2006/relationships" id="273" r:id="Rb8db8390e91d4fd2"/>
+    <p:sldId xmlns:r="http://schemas.openxmlformats.org/officeDocument/2006/relationships" id="274" r:id="R422067cd824e4b95"/>
+    <p:sldId xmlns:r="http://schemas.openxmlformats.org/officeDocument/2006/relationships" id="275" r:id="R33db265865ec42eb"/>
+    <p:sldId xmlns:r="http://schemas.openxmlformats.org/officeDocument/2006/relationships" id="276" r:id="R3ab6f70073e54c49"/>
+    <p:sldId xmlns:r="http://schemas.openxmlformats.org/officeDocument/2006/relationships" id="277" r:id="R12d45b6ee85246bf"/>
+    <p:sldId xmlns:r="http://schemas.openxmlformats.org/officeDocument/2006/relationships" id="278" r:id="Recff764960114a58"/>
+    <p:sldId xmlns:r="http://schemas.openxmlformats.org/officeDocument/2006/relationships" id="279" r:id="R22d9695ed0254d08"/>
+    <p:sldId xmlns:r="http://schemas.openxmlformats.org/officeDocument/2006/relationships" id="280" r:id="R7f3ea343a6fb4698"/>
+    <p:sldId xmlns:r="http://schemas.openxmlformats.org/officeDocument/2006/relationships" id="281" r:id="Rbb1f175bb5354c53"/>
+    <p:sldId xmlns:r="http://schemas.openxmlformats.org/officeDocument/2006/relationships" id="282" r:id="R769bc14aa45d4fe1"/>
+    <p:sldId xmlns:r="http://schemas.openxmlformats.org/officeDocument/2006/relationships" id="283" r:id="Rcfe84c6c1f614c06"/>
+    <p:sldId xmlns:r="http://schemas.openxmlformats.org/officeDocument/2006/relationships" id="284" r:id="R8c2fe7d6a7ef42f2"/>
+    <p:sldId xmlns:r="http://schemas.openxmlformats.org/officeDocument/2006/relationships" id="285" r:id="R7a00c754c80f434d"/>
+    <p:sldId xmlns:r="http://schemas.openxmlformats.org/officeDocument/2006/relationships" id="286" r:id="Rabe7384c9cea446d"/>
+    <p:sldId xmlns:r="http://schemas.openxmlformats.org/officeDocument/2006/relationships" id="287" r:id="R6909d198e91b43e5"/>
+    <p:sldId xmlns:r="http://schemas.openxmlformats.org/officeDocument/2006/relationships" id="288" r:id="Rc700524f316b458b"/>
+    <p:sldId xmlns:r="http://schemas.openxmlformats.org/officeDocument/2006/relationships" id="289" r:id="Rfb4721bbdac74673"/>
+    <p:sldId xmlns:r="http://schemas.openxmlformats.org/officeDocument/2006/relationships" id="290" r:id="Ra97416c2431c4c8c"/>
+    <p:sldId xmlns:r="http://schemas.openxmlformats.org/officeDocument/2006/relationships" id="291" r:id="R7e62998eb8714622"/>
+    <p:sldId xmlns:r="http://schemas.openxmlformats.org/officeDocument/2006/relationships" id="292" r:id="R0f1c0aa9ab684dad"/>
+    <p:sldId xmlns:r="http://schemas.openxmlformats.org/officeDocument/2006/relationships" id="293" r:id="R6072e459f1084000"/>
+    <p:sldId xmlns:r="http://schemas.openxmlformats.org/officeDocument/2006/relationships" id="294" r:id="R7d85115a66744c27"/>
+    <p:sldId xmlns:r="http://schemas.openxmlformats.org/officeDocument/2006/relationships" id="295" r:id="R6c8bc89ace95466b"/>
   </p:sldIdLst>
   <p:sldSz cx="12192000" cy="6858000"/>
   <p:notesSz cx="6858000" cy="9144000"/>
@@ -1896,7 +1896,7 @@
           </a:p>
           <a:p xmlns:a="http://schemas.openxmlformats.org/drawingml/2006/main">
             <a:r>
-              <a:t>Sprechhinweis: Geben Sie nur den synthetischen Kundenfall aus dem Material frei. Lassen Sie Paare fehlende Informationen benennen, bevor sie formulieren.</a:t>
+              <a:t>Sprechhinweis: Geben Sie nur den vorbereiteten synthetischen Kurzfall A aus dem gewählten Praxisfokus frei. Lassen Sie Paare fehlende Informationen benennen, bevor sie formulieren.</a:t>
             </a:r>
           </a:p>
           <a:p xmlns:a="http://schemas.openxmlformats.org/drawingml/2006/main">
@@ -4654,7 +4654,7 @@
   </p:cSld>
   <p:clrMap bg1="lt1" tx1="dk1" bg2="lt2" tx2="dk2" accent1="accent1" accent2="accent2" accent3="accent3" accent4="accent4" accent5="accent5" accent6="accent6" hlink="hlink" folHlink="folHlink"/>
   <p:sldLayoutIdLst>
-    <p:sldLayoutId xmlns:r="http://schemas.openxmlformats.org/officeDocument/2006/relationships" id="2147483649" r:id="Raf97c611bfe64fac"/>
+    <p:sldLayoutId xmlns:r="http://schemas.openxmlformats.org/officeDocument/2006/relationships" id="2147483649" r:id="R2bba2ba0033d4d93"/>
   </p:sldLayoutIdLst>
   <p:txStyles>
     <p:titleStyle>
@@ -5266,6 +5266,7 @@
           <a:lstStyle xmlns:a="http://schemas.openxmlformats.org/drawingml/2006/main"/>
           <a:p xmlns:a="http://schemas.openxmlformats.org/drawingml/2006/main">
             <a:pPr algn="l">
+              <a:buNone/>
               <a:defRPr sz="1650" b="1">
                 <a:solidFill>
                   <a:srgbClr val="1F4FC9"/>
@@ -5324,6 +5325,7 @@
           <a:lstStyle xmlns:a="http://schemas.openxmlformats.org/drawingml/2006/main"/>
           <a:p xmlns:a="http://schemas.openxmlformats.org/drawingml/2006/main">
             <a:pPr algn="l">
+              <a:buNone/>
               <a:defRPr sz="5100" b="1">
                 <a:solidFill>
                   <a:srgbClr val="1F2A2A"/>
@@ -5382,6 +5384,7 @@
           <a:lstStyle xmlns:a="http://schemas.openxmlformats.org/drawingml/2006/main"/>
           <a:p xmlns:a="http://schemas.openxmlformats.org/drawingml/2006/main">
             <a:pPr algn="l">
+              <a:buNone/>
               <a:defRPr sz="2400" b="0">
                 <a:solidFill>
                   <a:srgbClr val="5A5E55"/>
@@ -5471,6 +5474,7 @@
           <a:lstStyle xmlns:a="http://schemas.openxmlformats.org/drawingml/2006/main"/>
           <a:p xmlns:a="http://schemas.openxmlformats.org/drawingml/2006/main">
             <a:pPr algn="l">
+              <a:buNone/>
               <a:defRPr sz="1650" b="1">
                 <a:solidFill>
                   <a:srgbClr val="1F4FC9"/>
@@ -5529,6 +5533,7 @@
           <a:lstStyle xmlns:a="http://schemas.openxmlformats.org/drawingml/2006/main"/>
           <a:p xmlns:a="http://schemas.openxmlformats.org/drawingml/2006/main">
             <a:pPr algn="l">
+              <a:buNone/>
               <a:defRPr sz="1650" b="1">
                 <a:solidFill>
                   <a:srgbClr val="1F2A2A"/>
@@ -5587,6 +5592,7 @@
           <a:lstStyle xmlns:a="http://schemas.openxmlformats.org/drawingml/2006/main"/>
           <a:p xmlns:a="http://schemas.openxmlformats.org/drawingml/2006/main">
             <a:pPr algn="l">
+              <a:buNone/>
               <a:defRPr sz="1650" b="1">
                 <a:solidFill>
                   <a:srgbClr val="1F4FC9"/>
@@ -5645,6 +5651,7 @@
           <a:lstStyle xmlns:a="http://schemas.openxmlformats.org/drawingml/2006/main"/>
           <a:p xmlns:a="http://schemas.openxmlformats.org/drawingml/2006/main">
             <a:pPr algn="l">
+              <a:buNone/>
               <a:defRPr sz="1650" b="1">
                 <a:solidFill>
                   <a:srgbClr val="1F2A2A"/>
@@ -5703,6 +5710,7 @@
           <a:lstStyle xmlns:a="http://schemas.openxmlformats.org/drawingml/2006/main"/>
           <a:p xmlns:a="http://schemas.openxmlformats.org/drawingml/2006/main">
             <a:pPr algn="l">
+              <a:buNone/>
               <a:defRPr sz="1650" b="1">
                 <a:solidFill>
                   <a:srgbClr val="1F4FC9"/>
@@ -5761,6 +5769,7 @@
           <a:lstStyle xmlns:a="http://schemas.openxmlformats.org/drawingml/2006/main"/>
           <a:p xmlns:a="http://schemas.openxmlformats.org/drawingml/2006/main">
             <a:pPr algn="l">
+              <a:buNone/>
               <a:defRPr sz="1650" b="1">
                 <a:solidFill>
                   <a:srgbClr val="1F2A2A"/>
@@ -5819,6 +5828,7 @@
           <a:lstStyle xmlns:a="http://schemas.openxmlformats.org/drawingml/2006/main"/>
           <a:p xmlns:a="http://schemas.openxmlformats.org/drawingml/2006/main">
             <a:pPr algn="l">
+              <a:buNone/>
               <a:defRPr sz="900" b="0">
                 <a:solidFill>
                   <a:srgbClr val="5A5E55"/>
@@ -5873,14 +5883,14 @@
       </p:grpSpPr>
       <p:pic>
         <p:nvPicPr>
-          <p:cNvPr id="23" name=""/>
+          <p:cNvPr id="25" name=""/>
           <p:cNvPicPr>
             <a:picLocks xmlns:a="http://schemas.openxmlformats.org/drawingml/2006/main" noChangeAspect="1"/>
           </p:cNvPicPr>
           <p:nvPr/>
         </p:nvPicPr>
         <p:blipFill>
-          <a:blip xmlns:r="http://schemas.openxmlformats.org/officeDocument/2006/relationships" xmlns:a="http://schemas.openxmlformats.org/drawingml/2006/main" r:embed="R7699bc2307b34251"/>
+          <a:blip xmlns:r="http://schemas.openxmlformats.org/officeDocument/2006/relationships" xmlns:a="http://schemas.openxmlformats.org/drawingml/2006/main" r:embed="Rccf84c026356437f"/>
           <a:stretch xmlns:a="http://schemas.openxmlformats.org/drawingml/2006/main"/>
         </p:blipFill>
         <p:spPr>
@@ -5895,14 +5905,14 @@
       </p:pic>
       <p:pic>
         <p:nvPicPr>
-          <p:cNvPr id="24" name=""/>
+          <p:cNvPr id="26" name=""/>
           <p:cNvPicPr>
             <a:picLocks xmlns:a="http://schemas.openxmlformats.org/drawingml/2006/main" noChangeAspect="1"/>
           </p:cNvPicPr>
           <p:nvPr/>
         </p:nvPicPr>
         <p:blipFill>
-          <a:blip xmlns:r="http://schemas.openxmlformats.org/officeDocument/2006/relationships" xmlns:a="http://schemas.openxmlformats.org/drawingml/2006/main" r:embed="Re331466c89a04c40"/>
+          <a:blip xmlns:r="http://schemas.openxmlformats.org/officeDocument/2006/relationships" xmlns:a="http://schemas.openxmlformats.org/drawingml/2006/main" r:embed="Raaa71c09aa184404"/>
           <a:stretch xmlns:a="http://schemas.openxmlformats.org/drawingml/2006/main"/>
         </p:blipFill>
         <p:spPr>
@@ -5950,6 +5960,7 @@
           <a:lstStyle xmlns:a="http://schemas.openxmlformats.org/drawingml/2006/main"/>
           <a:p xmlns:a="http://schemas.openxmlformats.org/drawingml/2006/main">
             <a:pPr algn="l">
+              <a:buNone/>
               <a:defRPr sz="3600" b="1">
                 <a:solidFill>
                   <a:srgbClr val="1F2A2A"/>
@@ -6008,6 +6019,7 @@
           <a:lstStyle xmlns:a="http://schemas.openxmlformats.org/drawingml/2006/main"/>
           <a:p xmlns:a="http://schemas.openxmlformats.org/drawingml/2006/main">
             <a:pPr algn="l">
+              <a:buNone/>
               <a:defRPr sz="2400" b="1">
                 <a:solidFill>
                   <a:srgbClr val="5A5E55"/>
@@ -6066,6 +6078,7 @@
           <a:lstStyle xmlns:a="http://schemas.openxmlformats.org/drawingml/2006/main"/>
           <a:p xmlns:a="http://schemas.openxmlformats.org/drawingml/2006/main">
             <a:pPr algn="l">
+              <a:buNone/>
               <a:defRPr sz="1650" b="1">
                 <a:solidFill>
                   <a:srgbClr val="1F4FC9"/>
@@ -6155,6 +6168,7 @@
           <a:lstStyle xmlns:a="http://schemas.openxmlformats.org/drawingml/2006/main"/>
           <a:p xmlns:a="http://schemas.openxmlformats.org/drawingml/2006/main">
             <a:pPr algn="l">
+              <a:buNone/>
               <a:defRPr sz="1650" b="1">
                 <a:solidFill>
                   <a:srgbClr val="1F2A2A"/>
@@ -6213,6 +6227,7 @@
           <a:lstStyle xmlns:a="http://schemas.openxmlformats.org/drawingml/2006/main"/>
           <a:p xmlns:a="http://schemas.openxmlformats.org/drawingml/2006/main">
             <a:pPr algn="l">
+              <a:buNone/>
               <a:defRPr sz="1650" b="1">
                 <a:solidFill>
                   <a:srgbClr val="1F4FC9"/>
@@ -6302,6 +6317,7 @@
           <a:lstStyle xmlns:a="http://schemas.openxmlformats.org/drawingml/2006/main"/>
           <a:p xmlns:a="http://schemas.openxmlformats.org/drawingml/2006/main">
             <a:pPr algn="l">
+              <a:buNone/>
               <a:defRPr sz="1650" b="1">
                 <a:solidFill>
                   <a:srgbClr val="1F2A2A"/>
@@ -6360,6 +6376,7 @@
           <a:lstStyle xmlns:a="http://schemas.openxmlformats.org/drawingml/2006/main"/>
           <a:p xmlns:a="http://schemas.openxmlformats.org/drawingml/2006/main">
             <a:pPr algn="l">
+              <a:buNone/>
               <a:defRPr sz="1650" b="1">
                 <a:solidFill>
                   <a:srgbClr val="1F4FC9"/>
@@ -6449,6 +6466,7 @@
           <a:lstStyle xmlns:a="http://schemas.openxmlformats.org/drawingml/2006/main"/>
           <a:p xmlns:a="http://schemas.openxmlformats.org/drawingml/2006/main">
             <a:pPr algn="l">
+              <a:buNone/>
               <a:defRPr sz="1650" b="0">
                 <a:solidFill>
                   <a:srgbClr val="1F2A2A"/>
@@ -6507,6 +6525,7 @@
           <a:lstStyle xmlns:a="http://schemas.openxmlformats.org/drawingml/2006/main"/>
           <a:p xmlns:a="http://schemas.openxmlformats.org/drawingml/2006/main">
             <a:pPr algn="l">
+              <a:buNone/>
               <a:defRPr sz="1650" b="1">
                 <a:solidFill>
                   <a:srgbClr val="1F4FC9"/>
@@ -6596,6 +6615,7 @@
           <a:lstStyle xmlns:a="http://schemas.openxmlformats.org/drawingml/2006/main"/>
           <a:p xmlns:a="http://schemas.openxmlformats.org/drawingml/2006/main">
             <a:pPr algn="l">
+              <a:buNone/>
               <a:defRPr sz="1650" b="1">
                 <a:solidFill>
                   <a:srgbClr val="1F2A2A"/>
@@ -6654,6 +6674,7 @@
           <a:lstStyle xmlns:a="http://schemas.openxmlformats.org/drawingml/2006/main"/>
           <a:p xmlns:a="http://schemas.openxmlformats.org/drawingml/2006/main">
             <a:pPr algn="l">
+              <a:buNone/>
               <a:defRPr sz="1650" b="1">
                 <a:solidFill>
                   <a:srgbClr val="1F4FC9"/>
@@ -6743,6 +6764,7 @@
           <a:lstStyle xmlns:a="http://schemas.openxmlformats.org/drawingml/2006/main"/>
           <a:p xmlns:a="http://schemas.openxmlformats.org/drawingml/2006/main">
             <a:pPr algn="l">
+              <a:buNone/>
               <a:defRPr sz="1650" b="1">
                 <a:solidFill>
                   <a:srgbClr val="1F2A2A"/>
@@ -6801,6 +6823,7 @@
           <a:lstStyle xmlns:a="http://schemas.openxmlformats.org/drawingml/2006/main"/>
           <a:p xmlns:a="http://schemas.openxmlformats.org/drawingml/2006/main">
             <a:pPr algn="l">
+              <a:buNone/>
               <a:defRPr sz="1650" b="1">
                 <a:solidFill>
                   <a:srgbClr val="1F4FC9"/>
@@ -6890,6 +6913,7 @@
           <a:lstStyle xmlns:a="http://schemas.openxmlformats.org/drawingml/2006/main"/>
           <a:p xmlns:a="http://schemas.openxmlformats.org/drawingml/2006/main">
             <a:pPr algn="l">
+              <a:buNone/>
               <a:defRPr sz="1650" b="1">
                 <a:solidFill>
                   <a:srgbClr val="1F2A2A"/>
@@ -6944,14 +6968,14 @@
       </p:grpSpPr>
       <p:pic>
         <p:nvPicPr>
-          <p:cNvPr id="14" name=""/>
+          <p:cNvPr id="16" name=""/>
           <p:cNvPicPr>
             <a:picLocks xmlns:a="http://schemas.openxmlformats.org/drawingml/2006/main" noChangeAspect="1"/>
           </p:cNvPicPr>
           <p:nvPr/>
         </p:nvPicPr>
         <p:blipFill>
-          <a:blip xmlns:r="http://schemas.openxmlformats.org/officeDocument/2006/relationships" xmlns:a="http://schemas.openxmlformats.org/drawingml/2006/main" r:embed="R5d28182d213a4d88"/>
+          <a:blip xmlns:r="http://schemas.openxmlformats.org/officeDocument/2006/relationships" xmlns:a="http://schemas.openxmlformats.org/drawingml/2006/main" r:embed="Re9efc63aca374a2b"/>
           <a:stretch xmlns:a="http://schemas.openxmlformats.org/drawingml/2006/main"/>
         </p:blipFill>
         <p:spPr>
@@ -6966,14 +6990,14 @@
       </p:pic>
       <p:pic>
         <p:nvPicPr>
-          <p:cNvPr id="15" name=""/>
+          <p:cNvPr id="17" name=""/>
           <p:cNvPicPr>
             <a:picLocks xmlns:a="http://schemas.openxmlformats.org/drawingml/2006/main" noChangeAspect="1"/>
           </p:cNvPicPr>
           <p:nvPr/>
         </p:nvPicPr>
         <p:blipFill>
-          <a:blip xmlns:r="http://schemas.openxmlformats.org/officeDocument/2006/relationships" xmlns:a="http://schemas.openxmlformats.org/drawingml/2006/main" r:embed="R94014b3fc68847fe"/>
+          <a:blip xmlns:r="http://schemas.openxmlformats.org/officeDocument/2006/relationships" xmlns:a="http://schemas.openxmlformats.org/drawingml/2006/main" r:embed="Re08be055b6924b53"/>
           <a:stretch xmlns:a="http://schemas.openxmlformats.org/drawingml/2006/main"/>
         </p:blipFill>
         <p:spPr>
@@ -7021,6 +7045,7 @@
           <a:lstStyle xmlns:a="http://schemas.openxmlformats.org/drawingml/2006/main"/>
           <a:p xmlns:a="http://schemas.openxmlformats.org/drawingml/2006/main">
             <a:pPr algn="l">
+              <a:buNone/>
               <a:defRPr sz="3600" b="1">
                 <a:solidFill>
                   <a:srgbClr val="1F2A2A"/>
@@ -7079,6 +7104,7 @@
           <a:lstStyle xmlns:a="http://schemas.openxmlformats.org/drawingml/2006/main"/>
           <a:p xmlns:a="http://schemas.openxmlformats.org/drawingml/2006/main">
             <a:pPr algn="l">
+              <a:buNone/>
               <a:defRPr sz="2400" b="1">
                 <a:solidFill>
                   <a:srgbClr val="5A5E55"/>
@@ -7137,6 +7163,7 @@
           <a:lstStyle xmlns:a="http://schemas.openxmlformats.org/drawingml/2006/main"/>
           <a:p xmlns:a="http://schemas.openxmlformats.org/drawingml/2006/main">
             <a:pPr algn="l">
+              <a:buNone/>
               <a:defRPr sz="1650" b="1">
                 <a:solidFill>
                   <a:srgbClr val="1F4FC9"/>
@@ -7226,6 +7253,7 @@
           <a:lstStyle xmlns:a="http://schemas.openxmlformats.org/drawingml/2006/main"/>
           <a:p xmlns:a="http://schemas.openxmlformats.org/drawingml/2006/main">
             <a:pPr algn="l">
+              <a:buNone/>
               <a:defRPr sz="1650" b="1">
                 <a:solidFill>
                   <a:srgbClr val="1F2A2A"/>
@@ -7284,6 +7312,7 @@
           <a:lstStyle xmlns:a="http://schemas.openxmlformats.org/drawingml/2006/main"/>
           <a:p xmlns:a="http://schemas.openxmlformats.org/drawingml/2006/main">
             <a:pPr algn="l">
+              <a:buNone/>
               <a:defRPr sz="1650" b="1">
                 <a:solidFill>
                   <a:srgbClr val="1F4FC9"/>
@@ -7373,6 +7402,7 @@
           <a:lstStyle xmlns:a="http://schemas.openxmlformats.org/drawingml/2006/main"/>
           <a:p xmlns:a="http://schemas.openxmlformats.org/drawingml/2006/main">
             <a:pPr algn="l">
+              <a:buNone/>
               <a:defRPr sz="1650" b="0">
                 <a:solidFill>
                   <a:srgbClr val="1F2A2A"/>
@@ -7431,6 +7461,7 @@
           <a:lstStyle xmlns:a="http://schemas.openxmlformats.org/drawingml/2006/main"/>
           <a:p xmlns:a="http://schemas.openxmlformats.org/drawingml/2006/main">
             <a:pPr algn="l">
+              <a:buNone/>
               <a:defRPr sz="1650" b="1">
                 <a:solidFill>
                   <a:srgbClr val="1F4FC9"/>
@@ -7520,6 +7551,7 @@
           <a:lstStyle xmlns:a="http://schemas.openxmlformats.org/drawingml/2006/main"/>
           <a:p xmlns:a="http://schemas.openxmlformats.org/drawingml/2006/main">
             <a:pPr algn="l">
+              <a:buNone/>
               <a:defRPr sz="1650" b="0">
                 <a:solidFill>
                   <a:srgbClr val="1F2A2A"/>
@@ -7574,14 +7606,14 @@
       </p:grpSpPr>
       <p:pic>
         <p:nvPicPr>
-          <p:cNvPr id="8" name=""/>
+          <p:cNvPr id="10" name=""/>
           <p:cNvPicPr>
             <a:picLocks xmlns:a="http://schemas.openxmlformats.org/drawingml/2006/main" noChangeAspect="1"/>
           </p:cNvPicPr>
           <p:nvPr/>
         </p:nvPicPr>
         <p:blipFill>
-          <a:blip xmlns:r="http://schemas.openxmlformats.org/officeDocument/2006/relationships" xmlns:a="http://schemas.openxmlformats.org/drawingml/2006/main" r:embed="R6571963bceae4de9"/>
+          <a:blip xmlns:r="http://schemas.openxmlformats.org/officeDocument/2006/relationships" xmlns:a="http://schemas.openxmlformats.org/drawingml/2006/main" r:embed="Rf54eb221325547bf"/>
           <a:stretch xmlns:a="http://schemas.openxmlformats.org/drawingml/2006/main"/>
         </p:blipFill>
         <p:spPr>
@@ -7596,14 +7628,14 @@
       </p:pic>
       <p:pic>
         <p:nvPicPr>
-          <p:cNvPr id="9" name=""/>
+          <p:cNvPr id="11" name=""/>
           <p:cNvPicPr>
             <a:picLocks xmlns:a="http://schemas.openxmlformats.org/drawingml/2006/main" noChangeAspect="1"/>
           </p:cNvPicPr>
           <p:nvPr/>
         </p:nvPicPr>
         <p:blipFill>
-          <a:blip xmlns:r="http://schemas.openxmlformats.org/officeDocument/2006/relationships" xmlns:a="http://schemas.openxmlformats.org/drawingml/2006/main" r:embed="R1405ce2a075e4b06"/>
+          <a:blip xmlns:r="http://schemas.openxmlformats.org/officeDocument/2006/relationships" xmlns:a="http://schemas.openxmlformats.org/drawingml/2006/main" r:embed="Raa3bcbf3a2974888"/>
           <a:stretch xmlns:a="http://schemas.openxmlformats.org/drawingml/2006/main"/>
         </p:blipFill>
         <p:spPr>
@@ -7651,6 +7683,7 @@
           <a:lstStyle xmlns:a="http://schemas.openxmlformats.org/drawingml/2006/main"/>
           <a:p xmlns:a="http://schemas.openxmlformats.org/drawingml/2006/main">
             <a:pPr algn="l">
+              <a:buNone/>
               <a:defRPr sz="3600" b="1">
                 <a:solidFill>
                   <a:srgbClr val="F6F2EA"/>
@@ -7709,6 +7742,7 @@
           <a:lstStyle xmlns:a="http://schemas.openxmlformats.org/drawingml/2006/main"/>
           <a:p xmlns:a="http://schemas.openxmlformats.org/drawingml/2006/main">
             <a:pPr algn="l">
+              <a:buNone/>
               <a:defRPr sz="3300" b="1">
                 <a:solidFill>
                   <a:srgbClr val="F6F2EA"/>
@@ -7767,6 +7801,7 @@
           <a:lstStyle xmlns:a="http://schemas.openxmlformats.org/drawingml/2006/main"/>
           <a:p xmlns:a="http://schemas.openxmlformats.org/drawingml/2006/main">
             <a:pPr algn="l">
+              <a:buNone/>
               <a:defRPr sz="1650" b="0">
                 <a:solidFill>
                   <a:srgbClr val="D9DDD5"/>
@@ -7790,6 +7825,7 @@
           </a:p>
           <a:p xmlns:a="http://schemas.openxmlformats.org/drawingml/2006/main">
             <a:pPr algn="l">
+              <a:buNone/>
               <a:defRPr sz="1650" b="0">
                 <a:solidFill>
                   <a:srgbClr val="D9DDD5"/>
@@ -7813,6 +7849,7 @@
           </a:p>
           <a:p xmlns:a="http://schemas.openxmlformats.org/drawingml/2006/main">
             <a:pPr algn="l">
+              <a:buNone/>
               <a:defRPr sz="1650" b="0">
                 <a:solidFill>
                   <a:srgbClr val="D9DDD5"/>
@@ -7836,6 +7873,7 @@
           </a:p>
           <a:p xmlns:a="http://schemas.openxmlformats.org/drawingml/2006/main">
             <a:pPr algn="l">
+              <a:buNone/>
               <a:defRPr sz="1650" b="0">
                 <a:solidFill>
                   <a:srgbClr val="D9DDD5"/>
@@ -7859,6 +7897,7 @@
           </a:p>
           <a:p xmlns:a="http://schemas.openxmlformats.org/drawingml/2006/main">
             <a:pPr algn="l">
+              <a:buNone/>
               <a:defRPr sz="1650" b="0">
                 <a:solidFill>
                   <a:srgbClr val="D9DDD5"/>
@@ -7882,6 +7921,7 @@
           </a:p>
           <a:p xmlns:a="http://schemas.openxmlformats.org/drawingml/2006/main">
             <a:pPr algn="l">
+              <a:buNone/>
               <a:defRPr sz="1650" b="0">
                 <a:solidFill>
                   <a:srgbClr val="D9DDD5"/>
@@ -7971,6 +8011,7 @@
           <a:lstStyle xmlns:a="http://schemas.openxmlformats.org/drawingml/2006/main"/>
           <a:p xmlns:a="http://schemas.openxmlformats.org/drawingml/2006/main">
             <a:pPr algn="l">
+              <a:buNone/>
               <a:defRPr sz="2400" b="1">
                 <a:solidFill>
                   <a:srgbClr val="FFFFFF"/>
@@ -8025,14 +8066,14 @@
       </p:grpSpPr>
       <p:pic>
         <p:nvPicPr>
-          <p:cNvPr id="8" name=""/>
+          <p:cNvPr id="10" name=""/>
           <p:cNvPicPr>
             <a:picLocks xmlns:a="http://schemas.openxmlformats.org/drawingml/2006/main" noChangeAspect="1"/>
           </p:cNvPicPr>
           <p:nvPr/>
         </p:nvPicPr>
         <p:blipFill>
-          <a:blip xmlns:r="http://schemas.openxmlformats.org/officeDocument/2006/relationships" xmlns:a="http://schemas.openxmlformats.org/drawingml/2006/main" r:embed="Rdb6d98cf3c7d4df7"/>
+          <a:blip xmlns:r="http://schemas.openxmlformats.org/officeDocument/2006/relationships" xmlns:a="http://schemas.openxmlformats.org/drawingml/2006/main" r:embed="R1cb4ffbdbb414777"/>
           <a:stretch xmlns:a="http://schemas.openxmlformats.org/drawingml/2006/main"/>
         </p:blipFill>
         <p:spPr>
@@ -8047,14 +8088,14 @@
       </p:pic>
       <p:pic>
         <p:nvPicPr>
-          <p:cNvPr id="9" name=""/>
+          <p:cNvPr id="11" name=""/>
           <p:cNvPicPr>
             <a:picLocks xmlns:a="http://schemas.openxmlformats.org/drawingml/2006/main" noChangeAspect="1"/>
           </p:cNvPicPr>
           <p:nvPr/>
         </p:nvPicPr>
         <p:blipFill>
-          <a:blip xmlns:r="http://schemas.openxmlformats.org/officeDocument/2006/relationships" xmlns:a="http://schemas.openxmlformats.org/drawingml/2006/main" r:embed="R2d2a3cbb24a8429c"/>
+          <a:blip xmlns:r="http://schemas.openxmlformats.org/officeDocument/2006/relationships" xmlns:a="http://schemas.openxmlformats.org/drawingml/2006/main" r:embed="Reed40111f7924dc7"/>
           <a:stretch xmlns:a="http://schemas.openxmlformats.org/drawingml/2006/main"/>
         </p:blipFill>
         <p:spPr>
@@ -8102,6 +8143,7 @@
           <a:lstStyle xmlns:a="http://schemas.openxmlformats.org/drawingml/2006/main"/>
           <a:p xmlns:a="http://schemas.openxmlformats.org/drawingml/2006/main">
             <a:pPr algn="l">
+              <a:buNone/>
               <a:defRPr sz="3600" b="1">
                 <a:solidFill>
                   <a:srgbClr val="1F2A2A"/>
@@ -8160,6 +8202,7 @@
           <a:lstStyle xmlns:a="http://schemas.openxmlformats.org/drawingml/2006/main"/>
           <a:p xmlns:a="http://schemas.openxmlformats.org/drawingml/2006/main">
             <a:pPr algn="l">
+              <a:buNone/>
               <a:defRPr sz="3300" b="1">
                 <a:solidFill>
                   <a:srgbClr val="1F2A2A"/>
@@ -8218,6 +8261,7 @@
           <a:lstStyle xmlns:a="http://schemas.openxmlformats.org/drawingml/2006/main"/>
           <a:p xmlns:a="http://schemas.openxmlformats.org/drawingml/2006/main">
             <a:pPr algn="l">
+              <a:buNone/>
               <a:defRPr sz="1650" b="0">
                 <a:solidFill>
                   <a:srgbClr val="5A5E55"/>
@@ -8307,6 +8351,7 @@
           <a:lstStyle xmlns:a="http://schemas.openxmlformats.org/drawingml/2006/main"/>
           <a:p xmlns:a="http://schemas.openxmlformats.org/drawingml/2006/main">
             <a:pPr algn="l">
+              <a:buNone/>
               <a:defRPr sz="2400" b="1">
                 <a:solidFill>
                   <a:srgbClr val="1F2A2A"/>
@@ -8361,14 +8406,14 @@
       </p:grpSpPr>
       <p:pic>
         <p:nvPicPr>
-          <p:cNvPr id="8" name=""/>
+          <p:cNvPr id="10" name=""/>
           <p:cNvPicPr>
             <a:picLocks xmlns:a="http://schemas.openxmlformats.org/drawingml/2006/main" noChangeAspect="1"/>
           </p:cNvPicPr>
           <p:nvPr/>
         </p:nvPicPr>
         <p:blipFill>
-          <a:blip xmlns:r="http://schemas.openxmlformats.org/officeDocument/2006/relationships" xmlns:a="http://schemas.openxmlformats.org/drawingml/2006/main" r:embed="R158a2c8eecdc40c6"/>
+          <a:blip xmlns:r="http://schemas.openxmlformats.org/officeDocument/2006/relationships" xmlns:a="http://schemas.openxmlformats.org/drawingml/2006/main" r:embed="R986639e4f7114fa6"/>
           <a:stretch xmlns:a="http://schemas.openxmlformats.org/drawingml/2006/main"/>
         </p:blipFill>
         <p:spPr>
@@ -8383,14 +8428,14 @@
       </p:pic>
       <p:pic>
         <p:nvPicPr>
-          <p:cNvPr id="9" name=""/>
+          <p:cNvPr id="11" name=""/>
           <p:cNvPicPr>
             <a:picLocks xmlns:a="http://schemas.openxmlformats.org/drawingml/2006/main" noChangeAspect="1"/>
           </p:cNvPicPr>
           <p:nvPr/>
         </p:nvPicPr>
         <p:blipFill>
-          <a:blip xmlns:r="http://schemas.openxmlformats.org/officeDocument/2006/relationships" xmlns:a="http://schemas.openxmlformats.org/drawingml/2006/main" r:embed="Rb15d06b5078d4905"/>
+          <a:blip xmlns:r="http://schemas.openxmlformats.org/officeDocument/2006/relationships" xmlns:a="http://schemas.openxmlformats.org/drawingml/2006/main" r:embed="Rb00f39d81be244b1"/>
           <a:stretch xmlns:a="http://schemas.openxmlformats.org/drawingml/2006/main"/>
         </p:blipFill>
         <p:spPr>
@@ -8438,6 +8483,7 @@
           <a:lstStyle xmlns:a="http://schemas.openxmlformats.org/drawingml/2006/main"/>
           <a:p xmlns:a="http://schemas.openxmlformats.org/drawingml/2006/main">
             <a:pPr algn="l">
+              <a:buNone/>
               <a:defRPr sz="3600" b="1">
                 <a:solidFill>
                   <a:srgbClr val="1F2A2A"/>
@@ -8496,6 +8542,7 @@
           <a:lstStyle xmlns:a="http://schemas.openxmlformats.org/drawingml/2006/main"/>
           <a:p xmlns:a="http://schemas.openxmlformats.org/drawingml/2006/main">
             <a:pPr algn="l">
+              <a:buNone/>
               <a:defRPr sz="2400" b="1">
                 <a:solidFill>
                   <a:srgbClr val="5A5E55"/>
@@ -8554,6 +8601,7 @@
           <a:lstStyle xmlns:a="http://schemas.openxmlformats.org/drawingml/2006/main"/>
           <a:p xmlns:a="http://schemas.openxmlformats.org/drawingml/2006/main">
             <a:pPr algn="l">
+              <a:buNone/>
               <a:defRPr sz="1650" b="1">
                 <a:solidFill>
                   <a:srgbClr val="1F4FC9"/>
@@ -8643,6 +8691,7 @@
           <a:lstStyle xmlns:a="http://schemas.openxmlformats.org/drawingml/2006/main"/>
           <a:p xmlns:a="http://schemas.openxmlformats.org/drawingml/2006/main">
             <a:pPr algn="l">
+              <a:buNone/>
               <a:defRPr sz="1650" b="0">
                 <a:solidFill>
                   <a:srgbClr val="1F2A2A"/>
@@ -8697,14 +8746,14 @@
       </p:grpSpPr>
       <p:pic>
         <p:nvPicPr>
-          <p:cNvPr id="8" name=""/>
+          <p:cNvPr id="10" name=""/>
           <p:cNvPicPr>
             <a:picLocks xmlns:a="http://schemas.openxmlformats.org/drawingml/2006/main" noChangeAspect="1"/>
           </p:cNvPicPr>
           <p:nvPr/>
         </p:nvPicPr>
         <p:blipFill>
-          <a:blip xmlns:r="http://schemas.openxmlformats.org/officeDocument/2006/relationships" xmlns:a="http://schemas.openxmlformats.org/drawingml/2006/main" r:embed="R619020d3e6de4c25"/>
+          <a:blip xmlns:r="http://schemas.openxmlformats.org/officeDocument/2006/relationships" xmlns:a="http://schemas.openxmlformats.org/drawingml/2006/main" r:embed="Ra654bf1bfa734d80"/>
           <a:stretch xmlns:a="http://schemas.openxmlformats.org/drawingml/2006/main"/>
         </p:blipFill>
         <p:spPr>
@@ -8719,14 +8768,14 @@
       </p:pic>
       <p:pic>
         <p:nvPicPr>
-          <p:cNvPr id="9" name=""/>
+          <p:cNvPr id="11" name=""/>
           <p:cNvPicPr>
             <a:picLocks xmlns:a="http://schemas.openxmlformats.org/drawingml/2006/main" noChangeAspect="1"/>
           </p:cNvPicPr>
           <p:nvPr/>
         </p:nvPicPr>
         <p:blipFill>
-          <a:blip xmlns:r="http://schemas.openxmlformats.org/officeDocument/2006/relationships" xmlns:a="http://schemas.openxmlformats.org/drawingml/2006/main" r:embed="Rc7c90036e97b438a"/>
+          <a:blip xmlns:r="http://schemas.openxmlformats.org/officeDocument/2006/relationships" xmlns:a="http://schemas.openxmlformats.org/drawingml/2006/main" r:embed="R904b89dfd0614836"/>
           <a:stretch xmlns:a="http://schemas.openxmlformats.org/drawingml/2006/main"/>
         </p:blipFill>
         <p:spPr>
@@ -8774,6 +8823,7 @@
           <a:lstStyle xmlns:a="http://schemas.openxmlformats.org/drawingml/2006/main"/>
           <a:p xmlns:a="http://schemas.openxmlformats.org/drawingml/2006/main">
             <a:pPr algn="l">
+              <a:buNone/>
               <a:defRPr sz="3600" b="1">
                 <a:solidFill>
                   <a:srgbClr val="1F2A2A"/>
@@ -8832,6 +8882,7 @@
           <a:lstStyle xmlns:a="http://schemas.openxmlformats.org/drawingml/2006/main"/>
           <a:p xmlns:a="http://schemas.openxmlformats.org/drawingml/2006/main">
             <a:pPr algn="l">
+              <a:buNone/>
               <a:defRPr sz="2400" b="1">
                 <a:solidFill>
                   <a:srgbClr val="5A5E55"/>
@@ -8890,6 +8941,7 @@
           <a:lstStyle xmlns:a="http://schemas.openxmlformats.org/drawingml/2006/main"/>
           <a:p xmlns:a="http://schemas.openxmlformats.org/drawingml/2006/main">
             <a:pPr algn="l">
+              <a:buNone/>
               <a:defRPr sz="1650" b="1">
                 <a:solidFill>
                   <a:srgbClr val="1F4FC9"/>
@@ -8979,6 +9031,7 @@
           <a:lstStyle xmlns:a="http://schemas.openxmlformats.org/drawingml/2006/main"/>
           <a:p xmlns:a="http://schemas.openxmlformats.org/drawingml/2006/main">
             <a:pPr algn="l">
+              <a:buNone/>
               <a:defRPr sz="1650" b="0">
                 <a:solidFill>
                   <a:srgbClr val="1F2A2A"/>
@@ -9033,14 +9086,14 @@
       </p:grpSpPr>
       <p:pic>
         <p:nvPicPr>
-          <p:cNvPr id="8" name=""/>
+          <p:cNvPr id="10" name=""/>
           <p:cNvPicPr>
             <a:picLocks xmlns:a="http://schemas.openxmlformats.org/drawingml/2006/main" noChangeAspect="1"/>
           </p:cNvPicPr>
           <p:nvPr/>
         </p:nvPicPr>
         <p:blipFill>
-          <a:blip xmlns:r="http://schemas.openxmlformats.org/officeDocument/2006/relationships" xmlns:a="http://schemas.openxmlformats.org/drawingml/2006/main" r:embed="R2c77ad9db6a54a3a"/>
+          <a:blip xmlns:r="http://schemas.openxmlformats.org/officeDocument/2006/relationships" xmlns:a="http://schemas.openxmlformats.org/drawingml/2006/main" r:embed="Ra09c1061a3dc419e"/>
           <a:stretch xmlns:a="http://schemas.openxmlformats.org/drawingml/2006/main"/>
         </p:blipFill>
         <p:spPr>
@@ -9055,14 +9108,14 @@
       </p:pic>
       <p:pic>
         <p:nvPicPr>
-          <p:cNvPr id="9" name=""/>
+          <p:cNvPr id="11" name=""/>
           <p:cNvPicPr>
             <a:picLocks xmlns:a="http://schemas.openxmlformats.org/drawingml/2006/main" noChangeAspect="1"/>
           </p:cNvPicPr>
           <p:nvPr/>
         </p:nvPicPr>
         <p:blipFill>
-          <a:blip xmlns:r="http://schemas.openxmlformats.org/officeDocument/2006/relationships" xmlns:a="http://schemas.openxmlformats.org/drawingml/2006/main" r:embed="R5b608ec260df41b5"/>
+          <a:blip xmlns:r="http://schemas.openxmlformats.org/officeDocument/2006/relationships" xmlns:a="http://schemas.openxmlformats.org/drawingml/2006/main" r:embed="R011b5a0d0be04d64"/>
           <a:stretch xmlns:a="http://schemas.openxmlformats.org/drawingml/2006/main"/>
         </p:blipFill>
         <p:spPr>
@@ -9110,6 +9163,7 @@
           <a:lstStyle xmlns:a="http://schemas.openxmlformats.org/drawingml/2006/main"/>
           <a:p xmlns:a="http://schemas.openxmlformats.org/drawingml/2006/main">
             <a:pPr algn="l">
+              <a:buNone/>
               <a:defRPr sz="3600" b="1">
                 <a:solidFill>
                   <a:srgbClr val="F6F2EA"/>
@@ -9168,6 +9222,7 @@
           <a:lstStyle xmlns:a="http://schemas.openxmlformats.org/drawingml/2006/main"/>
           <a:p xmlns:a="http://schemas.openxmlformats.org/drawingml/2006/main">
             <a:pPr algn="l">
+              <a:buNone/>
               <a:defRPr sz="3300" b="1">
                 <a:solidFill>
                   <a:srgbClr val="F6F2EA"/>
@@ -9226,6 +9281,7 @@
           <a:lstStyle xmlns:a="http://schemas.openxmlformats.org/drawingml/2006/main"/>
           <a:p xmlns:a="http://schemas.openxmlformats.org/drawingml/2006/main">
             <a:pPr algn="l">
+              <a:buNone/>
               <a:defRPr sz="1650" b="0">
                 <a:solidFill>
                   <a:srgbClr val="D9DDD5"/>
@@ -9315,6 +9371,7 @@
           <a:lstStyle xmlns:a="http://schemas.openxmlformats.org/drawingml/2006/main"/>
           <a:p xmlns:a="http://schemas.openxmlformats.org/drawingml/2006/main">
             <a:pPr algn="l">
+              <a:buNone/>
               <a:defRPr sz="2400" b="1">
                 <a:solidFill>
                   <a:srgbClr val="FFFFFF"/>
@@ -9369,14 +9426,14 @@
       </p:grpSpPr>
       <p:pic>
         <p:nvPicPr>
-          <p:cNvPr id="8" name=""/>
+          <p:cNvPr id="10" name=""/>
           <p:cNvPicPr>
             <a:picLocks xmlns:a="http://schemas.openxmlformats.org/drawingml/2006/main" noChangeAspect="1"/>
           </p:cNvPicPr>
           <p:nvPr/>
         </p:nvPicPr>
         <p:blipFill>
-          <a:blip xmlns:r="http://schemas.openxmlformats.org/officeDocument/2006/relationships" xmlns:a="http://schemas.openxmlformats.org/drawingml/2006/main" r:embed="R87510fde589748df"/>
+          <a:blip xmlns:r="http://schemas.openxmlformats.org/officeDocument/2006/relationships" xmlns:a="http://schemas.openxmlformats.org/drawingml/2006/main" r:embed="R5c9ee1e9d6df454e"/>
           <a:stretch xmlns:a="http://schemas.openxmlformats.org/drawingml/2006/main"/>
         </p:blipFill>
         <p:spPr>
@@ -9391,14 +9448,14 @@
       </p:pic>
       <p:pic>
         <p:nvPicPr>
-          <p:cNvPr id="9" name=""/>
+          <p:cNvPr id="11" name=""/>
           <p:cNvPicPr>
             <a:picLocks xmlns:a="http://schemas.openxmlformats.org/drawingml/2006/main" noChangeAspect="1"/>
           </p:cNvPicPr>
           <p:nvPr/>
         </p:nvPicPr>
         <p:blipFill>
-          <a:blip xmlns:r="http://schemas.openxmlformats.org/officeDocument/2006/relationships" xmlns:a="http://schemas.openxmlformats.org/drawingml/2006/main" r:embed="R63c90408d3d04ba5"/>
+          <a:blip xmlns:r="http://schemas.openxmlformats.org/officeDocument/2006/relationships" xmlns:a="http://schemas.openxmlformats.org/drawingml/2006/main" r:embed="R6db68f03582b48bf"/>
           <a:stretch xmlns:a="http://schemas.openxmlformats.org/drawingml/2006/main"/>
         </p:blipFill>
         <p:spPr>
@@ -9446,6 +9503,7 @@
           <a:lstStyle xmlns:a="http://schemas.openxmlformats.org/drawingml/2006/main"/>
           <a:p xmlns:a="http://schemas.openxmlformats.org/drawingml/2006/main">
             <a:pPr algn="l">
+              <a:buNone/>
               <a:defRPr sz="3600" b="1">
                 <a:solidFill>
                   <a:srgbClr val="1F2A2A"/>
@@ -9535,6 +9593,7 @@
           <a:lstStyle xmlns:a="http://schemas.openxmlformats.org/drawingml/2006/main"/>
           <a:p xmlns:a="http://schemas.openxmlformats.org/drawingml/2006/main">
             <a:pPr algn="l">
+              <a:buNone/>
               <a:defRPr sz="1650" b="1">
                 <a:solidFill>
                   <a:srgbClr val="1F4FC9"/>
@@ -9593,6 +9652,7 @@
           <a:lstStyle xmlns:a="http://schemas.openxmlformats.org/drawingml/2006/main"/>
           <a:p xmlns:a="http://schemas.openxmlformats.org/drawingml/2006/main">
             <a:pPr algn="l">
+              <a:buNone/>
               <a:defRPr sz="3300" b="1">
                 <a:solidFill>
                   <a:srgbClr val="1F2A2A"/>
@@ -9651,6 +9711,7 @@
           <a:lstStyle xmlns:a="http://schemas.openxmlformats.org/drawingml/2006/main"/>
           <a:p xmlns:a="http://schemas.openxmlformats.org/drawingml/2006/main">
             <a:pPr algn="l">
+              <a:buNone/>
               <a:defRPr sz="1650" b="0">
                 <a:solidFill>
                   <a:srgbClr val="5A5E55"/>
@@ -9674,6 +9735,7 @@
           </a:p>
           <a:p xmlns:a="http://schemas.openxmlformats.org/drawingml/2006/main">
             <a:pPr algn="l">
+              <a:buNone/>
               <a:defRPr sz="1650" b="0">
                 <a:solidFill>
                   <a:srgbClr val="5A5E55"/>
@@ -9697,6 +9759,7 @@
           </a:p>
           <a:p xmlns:a="http://schemas.openxmlformats.org/drawingml/2006/main">
             <a:pPr algn="l">
+              <a:buNone/>
               <a:defRPr sz="1650" b="0">
                 <a:solidFill>
                   <a:srgbClr val="5A5E55"/>
@@ -9751,14 +9814,14 @@
       </p:grpSpPr>
       <p:pic>
         <p:nvPicPr>
-          <p:cNvPr id="8" name=""/>
+          <p:cNvPr id="10" name=""/>
           <p:cNvPicPr>
             <a:picLocks xmlns:a="http://schemas.openxmlformats.org/drawingml/2006/main" noChangeAspect="1"/>
           </p:cNvPicPr>
           <p:nvPr/>
         </p:nvPicPr>
         <p:blipFill>
-          <a:blip xmlns:r="http://schemas.openxmlformats.org/officeDocument/2006/relationships" xmlns:a="http://schemas.openxmlformats.org/drawingml/2006/main" r:embed="Rb2ce76c09b234699"/>
+          <a:blip xmlns:r="http://schemas.openxmlformats.org/officeDocument/2006/relationships" xmlns:a="http://schemas.openxmlformats.org/drawingml/2006/main" r:embed="R1222dd53d04d4c47"/>
           <a:stretch xmlns:a="http://schemas.openxmlformats.org/drawingml/2006/main"/>
         </p:blipFill>
         <p:spPr>
@@ -9773,14 +9836,14 @@
       </p:pic>
       <p:pic>
         <p:nvPicPr>
-          <p:cNvPr id="9" name=""/>
+          <p:cNvPr id="11" name=""/>
           <p:cNvPicPr>
             <a:picLocks xmlns:a="http://schemas.openxmlformats.org/drawingml/2006/main" noChangeAspect="1"/>
           </p:cNvPicPr>
           <p:nvPr/>
         </p:nvPicPr>
         <p:blipFill>
-          <a:blip xmlns:r="http://schemas.openxmlformats.org/officeDocument/2006/relationships" xmlns:a="http://schemas.openxmlformats.org/drawingml/2006/main" r:embed="Rc39328418c34411f"/>
+          <a:blip xmlns:r="http://schemas.openxmlformats.org/officeDocument/2006/relationships" xmlns:a="http://schemas.openxmlformats.org/drawingml/2006/main" r:embed="Rada753b3ce9e4e06"/>
           <a:stretch xmlns:a="http://schemas.openxmlformats.org/drawingml/2006/main"/>
         </p:blipFill>
         <p:spPr>
@@ -9828,6 +9891,7 @@
           <a:lstStyle xmlns:a="http://schemas.openxmlformats.org/drawingml/2006/main"/>
           <a:p xmlns:a="http://schemas.openxmlformats.org/drawingml/2006/main">
             <a:pPr algn="l">
+              <a:buNone/>
               <a:defRPr sz="3600" b="1">
                 <a:solidFill>
                   <a:srgbClr val="1F2A2A"/>
@@ -9886,6 +9950,7 @@
           <a:lstStyle xmlns:a="http://schemas.openxmlformats.org/drawingml/2006/main"/>
           <a:p xmlns:a="http://schemas.openxmlformats.org/drawingml/2006/main">
             <a:pPr algn="l">
+              <a:buNone/>
               <a:defRPr sz="2400" b="1">
                 <a:solidFill>
                   <a:srgbClr val="5A5E55"/>
@@ -9944,6 +10009,7 @@
           <a:lstStyle xmlns:a="http://schemas.openxmlformats.org/drawingml/2006/main"/>
           <a:p xmlns:a="http://schemas.openxmlformats.org/drawingml/2006/main">
             <a:pPr algn="l">
+              <a:buNone/>
               <a:defRPr sz="1650" b="1">
                 <a:solidFill>
                   <a:srgbClr val="1F4FC9"/>
@@ -10033,6 +10099,7 @@
           <a:lstStyle xmlns:a="http://schemas.openxmlformats.org/drawingml/2006/main"/>
           <a:p xmlns:a="http://schemas.openxmlformats.org/drawingml/2006/main">
             <a:pPr algn="l">
+              <a:buNone/>
               <a:defRPr sz="1650" b="0">
                 <a:solidFill>
                   <a:srgbClr val="1F2A2A"/>
@@ -10087,14 +10154,14 @@
       </p:grpSpPr>
       <p:pic>
         <p:nvPicPr>
-          <p:cNvPr id="11" name=""/>
+          <p:cNvPr id="13" name=""/>
           <p:cNvPicPr>
             <a:picLocks xmlns:a="http://schemas.openxmlformats.org/drawingml/2006/main" noChangeAspect="1"/>
           </p:cNvPicPr>
           <p:nvPr/>
         </p:nvPicPr>
         <p:blipFill>
-          <a:blip xmlns:r="http://schemas.openxmlformats.org/officeDocument/2006/relationships" xmlns:a="http://schemas.openxmlformats.org/drawingml/2006/main" r:embed="R1d6cfeaeebbb4eb6"/>
+          <a:blip xmlns:r="http://schemas.openxmlformats.org/officeDocument/2006/relationships" xmlns:a="http://schemas.openxmlformats.org/drawingml/2006/main" r:embed="R607715c1ea4a4117"/>
           <a:stretch xmlns:a="http://schemas.openxmlformats.org/drawingml/2006/main"/>
         </p:blipFill>
         <p:spPr>
@@ -10109,14 +10176,14 @@
       </p:pic>
       <p:pic>
         <p:nvPicPr>
-          <p:cNvPr id="12" name=""/>
+          <p:cNvPr id="14" name=""/>
           <p:cNvPicPr>
             <a:picLocks xmlns:a="http://schemas.openxmlformats.org/drawingml/2006/main" noChangeAspect="1"/>
           </p:cNvPicPr>
           <p:nvPr/>
         </p:nvPicPr>
         <p:blipFill>
-          <a:blip xmlns:r="http://schemas.openxmlformats.org/officeDocument/2006/relationships" xmlns:a="http://schemas.openxmlformats.org/drawingml/2006/main" r:embed="R62d81b8025be4970"/>
+          <a:blip xmlns:r="http://schemas.openxmlformats.org/officeDocument/2006/relationships" xmlns:a="http://schemas.openxmlformats.org/drawingml/2006/main" r:embed="Rc6c9e3963d48469a"/>
           <a:stretch xmlns:a="http://schemas.openxmlformats.org/drawingml/2006/main"/>
         </p:blipFill>
         <p:spPr>
@@ -10164,6 +10231,7 @@
           <a:lstStyle xmlns:a="http://schemas.openxmlformats.org/drawingml/2006/main"/>
           <a:p xmlns:a="http://schemas.openxmlformats.org/drawingml/2006/main">
             <a:pPr algn="l">
+              <a:buNone/>
               <a:defRPr sz="3600" b="1">
                 <a:solidFill>
                   <a:srgbClr val="1F2A2A"/>
@@ -10222,6 +10290,7 @@
           <a:lstStyle xmlns:a="http://schemas.openxmlformats.org/drawingml/2006/main"/>
           <a:p xmlns:a="http://schemas.openxmlformats.org/drawingml/2006/main">
             <a:pPr algn="l">
+              <a:buNone/>
               <a:defRPr sz="2400" b="1">
                 <a:solidFill>
                   <a:srgbClr val="5A5E55"/>
@@ -10280,6 +10349,7 @@
           <a:lstStyle xmlns:a="http://schemas.openxmlformats.org/drawingml/2006/main"/>
           <a:p xmlns:a="http://schemas.openxmlformats.org/drawingml/2006/main">
             <a:pPr algn="l">
+              <a:buNone/>
               <a:defRPr sz="1650" b="1">
                 <a:solidFill>
                   <a:srgbClr val="1F4FC9"/>
@@ -10369,6 +10439,7 @@
           <a:lstStyle xmlns:a="http://schemas.openxmlformats.org/drawingml/2006/main"/>
           <a:p xmlns:a="http://schemas.openxmlformats.org/drawingml/2006/main">
             <a:pPr algn="l">
+              <a:buNone/>
               <a:defRPr sz="1650" b="1">
                 <a:solidFill>
                   <a:srgbClr val="1F2A2A"/>
@@ -10427,6 +10498,7 @@
           <a:lstStyle xmlns:a="http://schemas.openxmlformats.org/drawingml/2006/main"/>
           <a:p xmlns:a="http://schemas.openxmlformats.org/drawingml/2006/main">
             <a:pPr algn="l">
+              <a:buNone/>
               <a:defRPr sz="1650" b="1">
                 <a:solidFill>
                   <a:srgbClr val="1F4FC9"/>
@@ -10516,6 +10588,7 @@
           <a:lstStyle xmlns:a="http://schemas.openxmlformats.org/drawingml/2006/main"/>
           <a:p xmlns:a="http://schemas.openxmlformats.org/drawingml/2006/main">
             <a:pPr algn="l">
+              <a:buNone/>
               <a:defRPr sz="1650" b="0">
                 <a:solidFill>
                   <a:srgbClr val="1F2A2A"/>
@@ -10570,14 +10643,14 @@
       </p:grpSpPr>
       <p:pic>
         <p:nvPicPr>
-          <p:cNvPr id="8" name=""/>
+          <p:cNvPr id="10" name=""/>
           <p:cNvPicPr>
             <a:picLocks xmlns:a="http://schemas.openxmlformats.org/drawingml/2006/main" noChangeAspect="1"/>
           </p:cNvPicPr>
           <p:nvPr/>
         </p:nvPicPr>
         <p:blipFill>
-          <a:blip xmlns:r="http://schemas.openxmlformats.org/officeDocument/2006/relationships" xmlns:a="http://schemas.openxmlformats.org/drawingml/2006/main" r:embed="R41b04d27818c4c7f"/>
+          <a:blip xmlns:r="http://schemas.openxmlformats.org/officeDocument/2006/relationships" xmlns:a="http://schemas.openxmlformats.org/drawingml/2006/main" r:embed="R7ac4e40f6171423c"/>
           <a:stretch xmlns:a="http://schemas.openxmlformats.org/drawingml/2006/main"/>
         </p:blipFill>
         <p:spPr>
@@ -10592,14 +10665,14 @@
       </p:pic>
       <p:pic>
         <p:nvPicPr>
-          <p:cNvPr id="9" name=""/>
+          <p:cNvPr id="11" name=""/>
           <p:cNvPicPr>
             <a:picLocks xmlns:a="http://schemas.openxmlformats.org/drawingml/2006/main" noChangeAspect="1"/>
           </p:cNvPicPr>
           <p:nvPr/>
         </p:nvPicPr>
         <p:blipFill>
-          <a:blip xmlns:r="http://schemas.openxmlformats.org/officeDocument/2006/relationships" xmlns:a="http://schemas.openxmlformats.org/drawingml/2006/main" r:embed="R1db88c456e404da6"/>
+          <a:blip xmlns:r="http://schemas.openxmlformats.org/officeDocument/2006/relationships" xmlns:a="http://schemas.openxmlformats.org/drawingml/2006/main" r:embed="R58cf42a55c4e4977"/>
           <a:stretch xmlns:a="http://schemas.openxmlformats.org/drawingml/2006/main"/>
         </p:blipFill>
         <p:spPr>
@@ -10647,6 +10720,7 @@
           <a:lstStyle xmlns:a="http://schemas.openxmlformats.org/drawingml/2006/main"/>
           <a:p xmlns:a="http://schemas.openxmlformats.org/drawingml/2006/main">
             <a:pPr algn="l">
+              <a:buNone/>
               <a:defRPr sz="3600" b="1">
                 <a:solidFill>
                   <a:srgbClr val="1F2A2A"/>
@@ -10705,6 +10779,7 @@
           <a:lstStyle xmlns:a="http://schemas.openxmlformats.org/drawingml/2006/main"/>
           <a:p xmlns:a="http://schemas.openxmlformats.org/drawingml/2006/main">
             <a:pPr algn="l">
+              <a:buNone/>
               <a:defRPr sz="3300" b="1">
                 <a:solidFill>
                   <a:srgbClr val="1F2A2A"/>
@@ -10763,6 +10838,7 @@
           <a:lstStyle xmlns:a="http://schemas.openxmlformats.org/drawingml/2006/main"/>
           <a:p xmlns:a="http://schemas.openxmlformats.org/drawingml/2006/main">
             <a:pPr algn="l">
+              <a:buNone/>
               <a:defRPr sz="1650" b="0">
                 <a:solidFill>
                   <a:srgbClr val="5A5E55"/>
@@ -10786,6 +10862,7 @@
           </a:p>
           <a:p xmlns:a="http://schemas.openxmlformats.org/drawingml/2006/main">
             <a:pPr algn="l">
+              <a:buNone/>
               <a:defRPr sz="1650" b="0">
                 <a:solidFill>
                   <a:srgbClr val="5A5E55"/>
@@ -10809,6 +10886,7 @@
           </a:p>
           <a:p xmlns:a="http://schemas.openxmlformats.org/drawingml/2006/main">
             <a:pPr algn="l">
+              <a:buNone/>
               <a:defRPr sz="1650" b="0">
                 <a:solidFill>
                   <a:srgbClr val="5A5E55"/>
@@ -10832,6 +10910,7 @@
           </a:p>
           <a:p xmlns:a="http://schemas.openxmlformats.org/drawingml/2006/main">
             <a:pPr algn="l">
+              <a:buNone/>
               <a:defRPr sz="1650" b="0">
                 <a:solidFill>
                   <a:srgbClr val="5A5E55"/>
@@ -10855,6 +10934,7 @@
           </a:p>
           <a:p xmlns:a="http://schemas.openxmlformats.org/drawingml/2006/main">
             <a:pPr algn="l">
+              <a:buNone/>
               <a:defRPr sz="1650" b="0">
                 <a:solidFill>
                   <a:srgbClr val="5A5E55"/>
@@ -10944,6 +11024,7 @@
           <a:lstStyle xmlns:a="http://schemas.openxmlformats.org/drawingml/2006/main"/>
           <a:p xmlns:a="http://schemas.openxmlformats.org/drawingml/2006/main">
             <a:pPr algn="l">
+              <a:buNone/>
               <a:defRPr sz="2400" b="1">
                 <a:solidFill>
                   <a:srgbClr val="1F2A2A"/>
@@ -10998,14 +11079,14 @@
       </p:grpSpPr>
       <p:pic>
         <p:nvPicPr>
-          <p:cNvPr id="23" name=""/>
+          <p:cNvPr id="25" name=""/>
           <p:cNvPicPr>
             <a:picLocks xmlns:a="http://schemas.openxmlformats.org/drawingml/2006/main" noChangeAspect="1"/>
           </p:cNvPicPr>
           <p:nvPr/>
         </p:nvPicPr>
         <p:blipFill>
-          <a:blip xmlns:r="http://schemas.openxmlformats.org/officeDocument/2006/relationships" xmlns:a="http://schemas.openxmlformats.org/drawingml/2006/main" r:embed="R0e71ba301fa34e94"/>
+          <a:blip xmlns:r="http://schemas.openxmlformats.org/officeDocument/2006/relationships" xmlns:a="http://schemas.openxmlformats.org/drawingml/2006/main" r:embed="R9e09a5923b8e4a2c"/>
           <a:stretch xmlns:a="http://schemas.openxmlformats.org/drawingml/2006/main"/>
         </p:blipFill>
         <p:spPr>
@@ -11020,14 +11101,14 @@
       </p:pic>
       <p:pic>
         <p:nvPicPr>
-          <p:cNvPr id="24" name=""/>
+          <p:cNvPr id="26" name=""/>
           <p:cNvPicPr>
             <a:picLocks xmlns:a="http://schemas.openxmlformats.org/drawingml/2006/main" noChangeAspect="1"/>
           </p:cNvPicPr>
           <p:nvPr/>
         </p:nvPicPr>
         <p:blipFill>
-          <a:blip xmlns:r="http://schemas.openxmlformats.org/officeDocument/2006/relationships" xmlns:a="http://schemas.openxmlformats.org/drawingml/2006/main" r:embed="R188b8eca4ba1473d"/>
+          <a:blip xmlns:r="http://schemas.openxmlformats.org/officeDocument/2006/relationships" xmlns:a="http://schemas.openxmlformats.org/drawingml/2006/main" r:embed="Rb33b754a3ea241b4"/>
           <a:stretch xmlns:a="http://schemas.openxmlformats.org/drawingml/2006/main"/>
         </p:blipFill>
         <p:spPr>
@@ -11075,6 +11156,7 @@
           <a:lstStyle xmlns:a="http://schemas.openxmlformats.org/drawingml/2006/main"/>
           <a:p xmlns:a="http://schemas.openxmlformats.org/drawingml/2006/main">
             <a:pPr algn="l">
+              <a:buNone/>
               <a:defRPr sz="3600" b="1">
                 <a:solidFill>
                   <a:srgbClr val="1F2A2A"/>
@@ -11133,6 +11215,7 @@
           <a:lstStyle xmlns:a="http://schemas.openxmlformats.org/drawingml/2006/main"/>
           <a:p xmlns:a="http://schemas.openxmlformats.org/drawingml/2006/main">
             <a:pPr algn="l">
+              <a:buNone/>
               <a:defRPr sz="2400" b="1">
                 <a:solidFill>
                   <a:srgbClr val="5A5E55"/>
@@ -11191,6 +11274,7 @@
           <a:lstStyle xmlns:a="http://schemas.openxmlformats.org/drawingml/2006/main"/>
           <a:p xmlns:a="http://schemas.openxmlformats.org/drawingml/2006/main">
             <a:pPr algn="ctr">
+              <a:buNone/>
               <a:defRPr sz="2400" b="1">
                 <a:solidFill>
                   <a:srgbClr val="1F4FC9"/>
@@ -11280,6 +11364,7 @@
           <a:lstStyle xmlns:a="http://schemas.openxmlformats.org/drawingml/2006/main"/>
           <a:p xmlns:a="http://schemas.openxmlformats.org/drawingml/2006/main">
             <a:pPr algn="l">
+              <a:buNone/>
               <a:defRPr sz="2400" b="1">
                 <a:solidFill>
                   <a:srgbClr val="1F2A2A"/>
@@ -11338,6 +11423,7 @@
           <a:lstStyle xmlns:a="http://schemas.openxmlformats.org/drawingml/2006/main"/>
           <a:p xmlns:a="http://schemas.openxmlformats.org/drawingml/2006/main">
             <a:pPr algn="ctr">
+              <a:buNone/>
               <a:defRPr sz="2400" b="1">
                 <a:solidFill>
                   <a:srgbClr val="1F4FC9"/>
@@ -11427,6 +11513,7 @@
           <a:lstStyle xmlns:a="http://schemas.openxmlformats.org/drawingml/2006/main"/>
           <a:p xmlns:a="http://schemas.openxmlformats.org/drawingml/2006/main">
             <a:pPr algn="l">
+              <a:buNone/>
               <a:defRPr sz="2400" b="1">
                 <a:solidFill>
                   <a:srgbClr val="1F2A2A"/>
@@ -11485,6 +11572,7 @@
           <a:lstStyle xmlns:a="http://schemas.openxmlformats.org/drawingml/2006/main"/>
           <a:p xmlns:a="http://schemas.openxmlformats.org/drawingml/2006/main">
             <a:pPr algn="ctr">
+              <a:buNone/>
               <a:defRPr sz="2400" b="1">
                 <a:solidFill>
                   <a:srgbClr val="1F4FC9"/>
@@ -11574,6 +11662,7 @@
           <a:lstStyle xmlns:a="http://schemas.openxmlformats.org/drawingml/2006/main"/>
           <a:p xmlns:a="http://schemas.openxmlformats.org/drawingml/2006/main">
             <a:pPr algn="l">
+              <a:buNone/>
               <a:defRPr sz="2400" b="1">
                 <a:solidFill>
                   <a:srgbClr val="1F2A2A"/>
@@ -11632,6 +11721,7 @@
           <a:lstStyle xmlns:a="http://schemas.openxmlformats.org/drawingml/2006/main"/>
           <a:p xmlns:a="http://schemas.openxmlformats.org/drawingml/2006/main">
             <a:pPr algn="ctr">
+              <a:buNone/>
               <a:defRPr sz="2400" b="1">
                 <a:solidFill>
                   <a:srgbClr val="1F4FC9"/>
@@ -11721,6 +11811,7 @@
           <a:lstStyle xmlns:a="http://schemas.openxmlformats.org/drawingml/2006/main"/>
           <a:p xmlns:a="http://schemas.openxmlformats.org/drawingml/2006/main">
             <a:pPr algn="l">
+              <a:buNone/>
               <a:defRPr sz="2400" b="1">
                 <a:solidFill>
                   <a:srgbClr val="1F2A2A"/>
@@ -11779,6 +11870,7 @@
           <a:lstStyle xmlns:a="http://schemas.openxmlformats.org/drawingml/2006/main"/>
           <a:p xmlns:a="http://schemas.openxmlformats.org/drawingml/2006/main">
             <a:pPr algn="ctr">
+              <a:buNone/>
               <a:defRPr sz="2400" b="1">
                 <a:solidFill>
                   <a:srgbClr val="1F4FC9"/>
@@ -11868,6 +11960,7 @@
           <a:lstStyle xmlns:a="http://schemas.openxmlformats.org/drawingml/2006/main"/>
           <a:p xmlns:a="http://schemas.openxmlformats.org/drawingml/2006/main">
             <a:pPr algn="l">
+              <a:buNone/>
               <a:defRPr sz="2400" b="1">
                 <a:solidFill>
                   <a:srgbClr val="1F2A2A"/>
@@ -11926,6 +12019,7 @@
           <a:lstStyle xmlns:a="http://schemas.openxmlformats.org/drawingml/2006/main"/>
           <a:p xmlns:a="http://schemas.openxmlformats.org/drawingml/2006/main">
             <a:pPr algn="ctr">
+              <a:buNone/>
               <a:defRPr sz="2400" b="1">
                 <a:solidFill>
                   <a:srgbClr val="1F4FC9"/>
@@ -12015,6 +12109,7 @@
           <a:lstStyle xmlns:a="http://schemas.openxmlformats.org/drawingml/2006/main"/>
           <a:p xmlns:a="http://schemas.openxmlformats.org/drawingml/2006/main">
             <a:pPr algn="l">
+              <a:buNone/>
               <a:defRPr sz="2400" b="1">
                 <a:solidFill>
                   <a:srgbClr val="1F2A2A"/>
@@ -12069,14 +12164,14 @@
       </p:grpSpPr>
       <p:pic>
         <p:nvPicPr>
-          <p:cNvPr id="8" name=""/>
+          <p:cNvPr id="10" name=""/>
           <p:cNvPicPr>
             <a:picLocks xmlns:a="http://schemas.openxmlformats.org/drawingml/2006/main" noChangeAspect="1"/>
           </p:cNvPicPr>
           <p:nvPr/>
         </p:nvPicPr>
         <p:blipFill>
-          <a:blip xmlns:r="http://schemas.openxmlformats.org/officeDocument/2006/relationships" xmlns:a="http://schemas.openxmlformats.org/drawingml/2006/main" r:embed="Rf5b825814fb745bb"/>
+          <a:blip xmlns:r="http://schemas.openxmlformats.org/officeDocument/2006/relationships" xmlns:a="http://schemas.openxmlformats.org/drawingml/2006/main" r:embed="R57083f7fbdbf404d"/>
           <a:stretch xmlns:a="http://schemas.openxmlformats.org/drawingml/2006/main"/>
         </p:blipFill>
         <p:spPr>
@@ -12091,14 +12186,14 @@
       </p:pic>
       <p:pic>
         <p:nvPicPr>
-          <p:cNvPr id="9" name=""/>
+          <p:cNvPr id="11" name=""/>
           <p:cNvPicPr>
             <a:picLocks xmlns:a="http://schemas.openxmlformats.org/drawingml/2006/main" noChangeAspect="1"/>
           </p:cNvPicPr>
           <p:nvPr/>
         </p:nvPicPr>
         <p:blipFill>
-          <a:blip xmlns:r="http://schemas.openxmlformats.org/officeDocument/2006/relationships" xmlns:a="http://schemas.openxmlformats.org/drawingml/2006/main" r:embed="Re48a5eca360c40e2"/>
+          <a:blip xmlns:r="http://schemas.openxmlformats.org/officeDocument/2006/relationships" xmlns:a="http://schemas.openxmlformats.org/drawingml/2006/main" r:embed="Rfe3ddade07574b09"/>
           <a:stretch xmlns:a="http://schemas.openxmlformats.org/drawingml/2006/main"/>
         </p:blipFill>
         <p:spPr>
@@ -12146,6 +12241,7 @@
           <a:lstStyle xmlns:a="http://schemas.openxmlformats.org/drawingml/2006/main"/>
           <a:p xmlns:a="http://schemas.openxmlformats.org/drawingml/2006/main">
             <a:pPr algn="l">
+              <a:buNone/>
               <a:defRPr sz="3600" b="1">
                 <a:solidFill>
                   <a:srgbClr val="1F2A2A"/>
@@ -12235,6 +12331,7 @@
           <a:lstStyle xmlns:a="http://schemas.openxmlformats.org/drawingml/2006/main"/>
           <a:p xmlns:a="http://schemas.openxmlformats.org/drawingml/2006/main">
             <a:pPr algn="l">
+              <a:buNone/>
               <a:defRPr sz="1650" b="1">
                 <a:solidFill>
                   <a:srgbClr val="1F4FC9"/>
@@ -12293,6 +12390,7 @@
           <a:lstStyle xmlns:a="http://schemas.openxmlformats.org/drawingml/2006/main"/>
           <a:p xmlns:a="http://schemas.openxmlformats.org/drawingml/2006/main">
             <a:pPr algn="l">
+              <a:buNone/>
               <a:defRPr sz="3300" b="1">
                 <a:solidFill>
                   <a:srgbClr val="1F2A2A"/>
@@ -12351,6 +12449,7 @@
           <a:lstStyle xmlns:a="http://schemas.openxmlformats.org/drawingml/2006/main"/>
           <a:p xmlns:a="http://schemas.openxmlformats.org/drawingml/2006/main">
             <a:pPr algn="l">
+              <a:buNone/>
               <a:defRPr sz="1650" b="0">
                 <a:solidFill>
                   <a:srgbClr val="5A5E55"/>
@@ -12369,7 +12468,7 @@
                 <a:ea typeface="Arial"/>
                 <a:cs typeface="Arial"/>
               </a:rPr>
-              <a:t>Verbessern Sie: „Schreib eine Antwort an den Kunden.“ Nutzen Sie alle sechs Bausteine.</a:t>
+              <a:t>Verbessern Sie den schwachen Startprompt aus Kurzfall A. Nutzen Sie alle sechs Bausteine.</a:t>
             </a:r>
           </a:p>
         </p:txBody>
@@ -12405,14 +12504,14 @@
       </p:grpSpPr>
       <p:pic>
         <p:nvPicPr>
-          <p:cNvPr id="8" name=""/>
+          <p:cNvPr id="10" name=""/>
           <p:cNvPicPr>
             <a:picLocks xmlns:a="http://schemas.openxmlformats.org/drawingml/2006/main" noChangeAspect="1"/>
           </p:cNvPicPr>
           <p:nvPr/>
         </p:nvPicPr>
         <p:blipFill>
-          <a:blip xmlns:r="http://schemas.openxmlformats.org/officeDocument/2006/relationships" xmlns:a="http://schemas.openxmlformats.org/drawingml/2006/main" r:embed="Rdc632cdbdeb34500"/>
+          <a:blip xmlns:r="http://schemas.openxmlformats.org/officeDocument/2006/relationships" xmlns:a="http://schemas.openxmlformats.org/drawingml/2006/main" r:embed="R4c9cfb3d854e4321"/>
           <a:stretch xmlns:a="http://schemas.openxmlformats.org/drawingml/2006/main"/>
         </p:blipFill>
         <p:spPr>
@@ -12427,14 +12526,14 @@
       </p:pic>
       <p:pic>
         <p:nvPicPr>
-          <p:cNvPr id="9" name=""/>
+          <p:cNvPr id="11" name=""/>
           <p:cNvPicPr>
             <a:picLocks xmlns:a="http://schemas.openxmlformats.org/drawingml/2006/main" noChangeAspect="1"/>
           </p:cNvPicPr>
           <p:nvPr/>
         </p:nvPicPr>
         <p:blipFill>
-          <a:blip xmlns:r="http://schemas.openxmlformats.org/officeDocument/2006/relationships" xmlns:a="http://schemas.openxmlformats.org/drawingml/2006/main" r:embed="R77c59082dbf34ac7"/>
+          <a:blip xmlns:r="http://schemas.openxmlformats.org/officeDocument/2006/relationships" xmlns:a="http://schemas.openxmlformats.org/drawingml/2006/main" r:embed="R44affe6cb55542d3"/>
           <a:stretch xmlns:a="http://schemas.openxmlformats.org/drawingml/2006/main"/>
         </p:blipFill>
         <p:spPr>
@@ -12482,6 +12581,7 @@
           <a:lstStyle xmlns:a="http://schemas.openxmlformats.org/drawingml/2006/main"/>
           <a:p xmlns:a="http://schemas.openxmlformats.org/drawingml/2006/main">
             <a:pPr algn="l">
+              <a:buNone/>
               <a:defRPr sz="3600" b="1">
                 <a:solidFill>
                   <a:srgbClr val="1F2A2A"/>
@@ -12571,6 +12671,7 @@
           <a:lstStyle xmlns:a="http://schemas.openxmlformats.org/drawingml/2006/main"/>
           <a:p xmlns:a="http://schemas.openxmlformats.org/drawingml/2006/main">
             <a:pPr algn="l">
+              <a:buNone/>
               <a:defRPr sz="1650" b="1">
                 <a:solidFill>
                   <a:srgbClr val="1F4FC9"/>
@@ -12629,6 +12730,7 @@
           <a:lstStyle xmlns:a="http://schemas.openxmlformats.org/drawingml/2006/main"/>
           <a:p xmlns:a="http://schemas.openxmlformats.org/drawingml/2006/main">
             <a:pPr algn="l">
+              <a:buNone/>
               <a:defRPr sz="3300" b="1">
                 <a:solidFill>
                   <a:srgbClr val="1F2A2A"/>
@@ -12687,6 +12789,7 @@
           <a:lstStyle xmlns:a="http://schemas.openxmlformats.org/drawingml/2006/main"/>
           <a:p xmlns:a="http://schemas.openxmlformats.org/drawingml/2006/main">
             <a:pPr algn="l">
+              <a:buNone/>
               <a:defRPr sz="1650" b="0">
                 <a:solidFill>
                   <a:srgbClr val="5A5E55"/>
@@ -12710,6 +12813,7 @@
           </a:p>
           <a:p xmlns:a="http://schemas.openxmlformats.org/drawingml/2006/main">
             <a:pPr algn="l">
+              <a:buNone/>
               <a:defRPr sz="1650" b="0">
                 <a:solidFill>
                   <a:srgbClr val="5A5E55"/>
@@ -12733,6 +12837,7 @@
           </a:p>
           <a:p xmlns:a="http://schemas.openxmlformats.org/drawingml/2006/main">
             <a:pPr algn="l">
+              <a:buNone/>
               <a:defRPr sz="1650" b="0">
                 <a:solidFill>
                   <a:srgbClr val="5A5E55"/>
@@ -12756,6 +12861,7 @@
           </a:p>
           <a:p xmlns:a="http://schemas.openxmlformats.org/drawingml/2006/main">
             <a:pPr algn="l">
+              <a:buNone/>
               <a:defRPr sz="1650" b="0">
                 <a:solidFill>
                   <a:srgbClr val="5A5E55"/>
@@ -12779,6 +12885,7 @@
           </a:p>
           <a:p xmlns:a="http://schemas.openxmlformats.org/drawingml/2006/main">
             <a:pPr algn="l">
+              <a:buNone/>
               <a:defRPr sz="1650" b="0">
                 <a:solidFill>
                   <a:srgbClr val="5A5E55"/>
@@ -12866,6 +12973,7 @@
           <a:lstStyle xmlns:a="http://schemas.openxmlformats.org/drawingml/2006/main"/>
           <a:p xmlns:a="http://schemas.openxmlformats.org/drawingml/2006/main">
             <a:pPr algn="l">
+              <a:buNone/>
               <a:defRPr sz="1650" b="1">
                 <a:solidFill>
                   <a:srgbClr val="FFFFFF"/>
@@ -12924,6 +13032,7 @@
           <a:lstStyle xmlns:a="http://schemas.openxmlformats.org/drawingml/2006/main"/>
           <a:p xmlns:a="http://schemas.openxmlformats.org/drawingml/2006/main">
             <a:pPr algn="l">
+              <a:buNone/>
               <a:defRPr sz="5850" b="1">
                 <a:solidFill>
                   <a:srgbClr val="FFFFFF"/>
@@ -12982,6 +13091,7 @@
           <a:lstStyle xmlns:a="http://schemas.openxmlformats.org/drawingml/2006/main"/>
           <a:p xmlns:a="http://schemas.openxmlformats.org/drawingml/2006/main">
             <a:pPr algn="l">
+              <a:buNone/>
               <a:defRPr sz="2400" b="1">
                 <a:solidFill>
                   <a:srgbClr val="F6F2EA"/>
@@ -13040,6 +13150,7 @@
           <a:lstStyle xmlns:a="http://schemas.openxmlformats.org/drawingml/2006/main"/>
           <a:p xmlns:a="http://schemas.openxmlformats.org/drawingml/2006/main">
             <a:pPr algn="l">
+              <a:buNone/>
               <a:defRPr sz="1650" b="0">
                 <a:solidFill>
                   <a:srgbClr val="FFFFFF"/>
@@ -13129,6 +13240,7 @@
           <a:lstStyle xmlns:a="http://schemas.openxmlformats.org/drawingml/2006/main"/>
           <a:p xmlns:a="http://schemas.openxmlformats.org/drawingml/2006/main">
             <a:pPr algn="l">
+              <a:buNone/>
               <a:defRPr sz="1650" b="1">
                 <a:solidFill>
                   <a:srgbClr val="D9DDD5"/>
@@ -13187,6 +13299,7 @@
           <a:lstStyle xmlns:a="http://schemas.openxmlformats.org/drawingml/2006/main"/>
           <a:p xmlns:a="http://schemas.openxmlformats.org/drawingml/2006/main">
             <a:pPr algn="ctr">
+              <a:buNone/>
               <a:defRPr sz="1650" b="0">
                 <a:solidFill>
                   <a:srgbClr val="D9DDD5"/>
@@ -13245,6 +13358,7 @@
           <a:lstStyle xmlns:a="http://schemas.openxmlformats.org/drawingml/2006/main"/>
           <a:p xmlns:a="http://schemas.openxmlformats.org/drawingml/2006/main">
             <a:pPr algn="r">
+              <a:buNone/>
               <a:defRPr sz="1650" b="1">
                 <a:solidFill>
                   <a:srgbClr val="D9DDD5"/>
@@ -13299,14 +13413,14 @@
       </p:grpSpPr>
       <p:pic>
         <p:nvPicPr>
-          <p:cNvPr id="8" name=""/>
+          <p:cNvPr id="10" name=""/>
           <p:cNvPicPr>
             <a:picLocks xmlns:a="http://schemas.openxmlformats.org/drawingml/2006/main" noChangeAspect="1"/>
           </p:cNvPicPr>
           <p:nvPr/>
         </p:nvPicPr>
         <p:blipFill>
-          <a:blip xmlns:r="http://schemas.openxmlformats.org/officeDocument/2006/relationships" xmlns:a="http://schemas.openxmlformats.org/drawingml/2006/main" r:embed="R6e166425cb274e65"/>
+          <a:blip xmlns:r="http://schemas.openxmlformats.org/officeDocument/2006/relationships" xmlns:a="http://schemas.openxmlformats.org/drawingml/2006/main" r:embed="R70ce8cf11ff14ae6"/>
           <a:stretch xmlns:a="http://schemas.openxmlformats.org/drawingml/2006/main"/>
         </p:blipFill>
         <p:spPr>
@@ -13321,14 +13435,14 @@
       </p:pic>
       <p:pic>
         <p:nvPicPr>
-          <p:cNvPr id="9" name=""/>
+          <p:cNvPr id="11" name=""/>
           <p:cNvPicPr>
             <a:picLocks xmlns:a="http://schemas.openxmlformats.org/drawingml/2006/main" noChangeAspect="1"/>
           </p:cNvPicPr>
           <p:nvPr/>
         </p:nvPicPr>
         <p:blipFill>
-          <a:blip xmlns:r="http://schemas.openxmlformats.org/officeDocument/2006/relationships" xmlns:a="http://schemas.openxmlformats.org/drawingml/2006/main" r:embed="R8c90a57095454b0f"/>
+          <a:blip xmlns:r="http://schemas.openxmlformats.org/officeDocument/2006/relationships" xmlns:a="http://schemas.openxmlformats.org/drawingml/2006/main" r:embed="Ra7d2266f011b436d"/>
           <a:stretch xmlns:a="http://schemas.openxmlformats.org/drawingml/2006/main"/>
         </p:blipFill>
         <p:spPr>
@@ -13376,6 +13490,7 @@
           <a:lstStyle xmlns:a="http://schemas.openxmlformats.org/drawingml/2006/main"/>
           <a:p xmlns:a="http://schemas.openxmlformats.org/drawingml/2006/main">
             <a:pPr algn="l">
+              <a:buNone/>
               <a:defRPr sz="3600" b="1">
                 <a:solidFill>
                   <a:srgbClr val="F6F2EA"/>
@@ -13434,6 +13549,7 @@
           <a:lstStyle xmlns:a="http://schemas.openxmlformats.org/drawingml/2006/main"/>
           <a:p xmlns:a="http://schemas.openxmlformats.org/drawingml/2006/main">
             <a:pPr algn="l">
+              <a:buNone/>
               <a:defRPr sz="3300" b="1">
                 <a:solidFill>
                   <a:srgbClr val="F6F2EA"/>
@@ -13492,6 +13608,7 @@
           <a:lstStyle xmlns:a="http://schemas.openxmlformats.org/drawingml/2006/main"/>
           <a:p xmlns:a="http://schemas.openxmlformats.org/drawingml/2006/main">
             <a:pPr algn="l">
+              <a:buNone/>
               <a:defRPr sz="1650" b="0">
                 <a:solidFill>
                   <a:srgbClr val="D9DDD5"/>
@@ -13515,6 +13632,7 @@
           </a:p>
           <a:p xmlns:a="http://schemas.openxmlformats.org/drawingml/2006/main">
             <a:pPr algn="l">
+              <a:buNone/>
               <a:defRPr sz="1650" b="0">
                 <a:solidFill>
                   <a:srgbClr val="D9DDD5"/>
@@ -13538,6 +13656,7 @@
           </a:p>
           <a:p xmlns:a="http://schemas.openxmlformats.org/drawingml/2006/main">
             <a:pPr algn="l">
+              <a:buNone/>
               <a:defRPr sz="1650" b="0">
                 <a:solidFill>
                   <a:srgbClr val="D9DDD5"/>
@@ -13627,6 +13746,7 @@
           <a:lstStyle xmlns:a="http://schemas.openxmlformats.org/drawingml/2006/main"/>
           <a:p xmlns:a="http://schemas.openxmlformats.org/drawingml/2006/main">
             <a:pPr algn="l">
+              <a:buNone/>
               <a:defRPr sz="2400" b="1">
                 <a:solidFill>
                   <a:srgbClr val="FFFFFF"/>
@@ -13681,14 +13801,14 @@
       </p:grpSpPr>
       <p:pic>
         <p:nvPicPr>
-          <p:cNvPr id="8" name=""/>
+          <p:cNvPr id="10" name=""/>
           <p:cNvPicPr>
             <a:picLocks xmlns:a="http://schemas.openxmlformats.org/drawingml/2006/main" noChangeAspect="1"/>
           </p:cNvPicPr>
           <p:nvPr/>
         </p:nvPicPr>
         <p:blipFill>
-          <a:blip xmlns:r="http://schemas.openxmlformats.org/officeDocument/2006/relationships" xmlns:a="http://schemas.openxmlformats.org/drawingml/2006/main" r:embed="R2c938ce4638d4583"/>
+          <a:blip xmlns:r="http://schemas.openxmlformats.org/officeDocument/2006/relationships" xmlns:a="http://schemas.openxmlformats.org/drawingml/2006/main" r:embed="R9faf68bc420a4183"/>
           <a:stretch xmlns:a="http://schemas.openxmlformats.org/drawingml/2006/main"/>
         </p:blipFill>
         <p:spPr>
@@ -13703,14 +13823,14 @@
       </p:pic>
       <p:pic>
         <p:nvPicPr>
-          <p:cNvPr id="9" name=""/>
+          <p:cNvPr id="11" name=""/>
           <p:cNvPicPr>
             <a:picLocks xmlns:a="http://schemas.openxmlformats.org/drawingml/2006/main" noChangeAspect="1"/>
           </p:cNvPicPr>
           <p:nvPr/>
         </p:nvPicPr>
         <p:blipFill>
-          <a:blip xmlns:r="http://schemas.openxmlformats.org/officeDocument/2006/relationships" xmlns:a="http://schemas.openxmlformats.org/drawingml/2006/main" r:embed="R5a838229e3ea4ca1"/>
+          <a:blip xmlns:r="http://schemas.openxmlformats.org/officeDocument/2006/relationships" xmlns:a="http://schemas.openxmlformats.org/drawingml/2006/main" r:embed="R6bec0bc8168641b6"/>
           <a:stretch xmlns:a="http://schemas.openxmlformats.org/drawingml/2006/main"/>
         </p:blipFill>
         <p:spPr>
@@ -13758,6 +13878,7 @@
           <a:lstStyle xmlns:a="http://schemas.openxmlformats.org/drawingml/2006/main"/>
           <a:p xmlns:a="http://schemas.openxmlformats.org/drawingml/2006/main">
             <a:pPr algn="l">
+              <a:buNone/>
               <a:defRPr sz="3600" b="1">
                 <a:solidFill>
                   <a:srgbClr val="F6F2EA"/>
@@ -13816,6 +13937,7 @@
           <a:lstStyle xmlns:a="http://schemas.openxmlformats.org/drawingml/2006/main"/>
           <a:p xmlns:a="http://schemas.openxmlformats.org/drawingml/2006/main">
             <a:pPr algn="l">
+              <a:buNone/>
               <a:defRPr sz="3300" b="1">
                 <a:solidFill>
                   <a:srgbClr val="F6F2EA"/>
@@ -13874,6 +13996,7 @@
           <a:lstStyle xmlns:a="http://schemas.openxmlformats.org/drawingml/2006/main"/>
           <a:p xmlns:a="http://schemas.openxmlformats.org/drawingml/2006/main">
             <a:pPr algn="l">
+              <a:buNone/>
               <a:defRPr sz="1650" b="0">
                 <a:solidFill>
                   <a:srgbClr val="D9DDD5"/>
@@ -13897,6 +14020,7 @@
           </a:p>
           <a:p xmlns:a="http://schemas.openxmlformats.org/drawingml/2006/main">
             <a:pPr algn="l">
+              <a:buNone/>
               <a:defRPr sz="1650" b="0">
                 <a:solidFill>
                   <a:srgbClr val="D9DDD5"/>
@@ -13920,6 +14044,7 @@
           </a:p>
           <a:p xmlns:a="http://schemas.openxmlformats.org/drawingml/2006/main">
             <a:pPr algn="l">
+              <a:buNone/>
               <a:defRPr sz="1650" b="0">
                 <a:solidFill>
                   <a:srgbClr val="D9DDD5"/>
@@ -13943,6 +14068,7 @@
           </a:p>
           <a:p xmlns:a="http://schemas.openxmlformats.org/drawingml/2006/main">
             <a:pPr algn="l">
+              <a:buNone/>
               <a:defRPr sz="1650" b="0">
                 <a:solidFill>
                   <a:srgbClr val="D9DDD5"/>
@@ -13966,6 +14092,7 @@
           </a:p>
           <a:p xmlns:a="http://schemas.openxmlformats.org/drawingml/2006/main">
             <a:pPr algn="l">
+              <a:buNone/>
               <a:defRPr sz="1650" b="0">
                 <a:solidFill>
                   <a:srgbClr val="D9DDD5"/>
@@ -14055,6 +14182,7 @@
           <a:lstStyle xmlns:a="http://schemas.openxmlformats.org/drawingml/2006/main"/>
           <a:p xmlns:a="http://schemas.openxmlformats.org/drawingml/2006/main">
             <a:pPr algn="l">
+              <a:buNone/>
               <a:defRPr sz="2400" b="1">
                 <a:solidFill>
                   <a:srgbClr val="FFFFFF"/>
@@ -14109,14 +14237,14 @@
       </p:grpSpPr>
       <p:pic>
         <p:nvPicPr>
-          <p:cNvPr id="14" name=""/>
+          <p:cNvPr id="16" name=""/>
           <p:cNvPicPr>
             <a:picLocks xmlns:a="http://schemas.openxmlformats.org/drawingml/2006/main" noChangeAspect="1"/>
           </p:cNvPicPr>
           <p:nvPr/>
         </p:nvPicPr>
         <p:blipFill>
-          <a:blip xmlns:r="http://schemas.openxmlformats.org/officeDocument/2006/relationships" xmlns:a="http://schemas.openxmlformats.org/drawingml/2006/main" r:embed="Raa9550e4c7cd418c"/>
+          <a:blip xmlns:r="http://schemas.openxmlformats.org/officeDocument/2006/relationships" xmlns:a="http://schemas.openxmlformats.org/drawingml/2006/main" r:embed="R798afb45f2fb4cb0"/>
           <a:stretch xmlns:a="http://schemas.openxmlformats.org/drawingml/2006/main"/>
         </p:blipFill>
         <p:spPr>
@@ -14131,14 +14259,14 @@
       </p:pic>
       <p:pic>
         <p:nvPicPr>
-          <p:cNvPr id="15" name=""/>
+          <p:cNvPr id="17" name=""/>
           <p:cNvPicPr>
             <a:picLocks xmlns:a="http://schemas.openxmlformats.org/drawingml/2006/main" noChangeAspect="1"/>
           </p:cNvPicPr>
           <p:nvPr/>
         </p:nvPicPr>
         <p:blipFill>
-          <a:blip xmlns:r="http://schemas.openxmlformats.org/officeDocument/2006/relationships" xmlns:a="http://schemas.openxmlformats.org/drawingml/2006/main" r:embed="R66e1f7d398334723"/>
+          <a:blip xmlns:r="http://schemas.openxmlformats.org/officeDocument/2006/relationships" xmlns:a="http://schemas.openxmlformats.org/drawingml/2006/main" r:embed="R5d19369792df40fe"/>
           <a:stretch xmlns:a="http://schemas.openxmlformats.org/drawingml/2006/main"/>
         </p:blipFill>
         <p:spPr>
@@ -14186,6 +14314,7 @@
           <a:lstStyle xmlns:a="http://schemas.openxmlformats.org/drawingml/2006/main"/>
           <a:p xmlns:a="http://schemas.openxmlformats.org/drawingml/2006/main">
             <a:pPr algn="l">
+              <a:buNone/>
               <a:defRPr sz="3600" b="1">
                 <a:solidFill>
                   <a:srgbClr val="1F2A2A"/>
@@ -14244,6 +14373,7 @@
           <a:lstStyle xmlns:a="http://schemas.openxmlformats.org/drawingml/2006/main"/>
           <a:p xmlns:a="http://schemas.openxmlformats.org/drawingml/2006/main">
             <a:pPr algn="l">
+              <a:buNone/>
               <a:defRPr sz="2400" b="1">
                 <a:solidFill>
                   <a:srgbClr val="5A5E55"/>
@@ -14306,6 +14436,7 @@
           <a:lstStyle xmlns:a="http://schemas.openxmlformats.org/drawingml/2006/main"/>
           <a:p xmlns:a="http://schemas.openxmlformats.org/drawingml/2006/main">
             <a:pPr algn="ctr">
+              <a:buNone/>
               <a:defRPr sz="2400" b="1">
                 <a:solidFill>
                   <a:srgbClr val="1F2A2A"/>
@@ -14364,6 +14495,7 @@
           <a:lstStyle xmlns:a="http://schemas.openxmlformats.org/drawingml/2006/main"/>
           <a:p xmlns:a="http://schemas.openxmlformats.org/drawingml/2006/main">
             <a:pPr algn="ctr">
+              <a:buNone/>
               <a:defRPr sz="2400" b="1">
                 <a:solidFill>
                   <a:srgbClr val="1F2A2A"/>
@@ -14422,6 +14554,7 @@
           <a:lstStyle xmlns:a="http://schemas.openxmlformats.org/drawingml/2006/main"/>
           <a:p xmlns:a="http://schemas.openxmlformats.org/drawingml/2006/main">
             <a:pPr algn="ctr">
+              <a:buNone/>
               <a:defRPr sz="1650" b="0">
                 <a:solidFill>
                   <a:srgbClr val="5A5E55"/>
@@ -14484,6 +14617,7 @@
           <a:lstStyle xmlns:a="http://schemas.openxmlformats.org/drawingml/2006/main"/>
           <a:p xmlns:a="http://schemas.openxmlformats.org/drawingml/2006/main">
             <a:pPr algn="ctr">
+              <a:buNone/>
               <a:defRPr sz="2400" b="1">
                 <a:solidFill>
                   <a:srgbClr val="1F2A2A"/>
@@ -14542,6 +14676,7 @@
           <a:lstStyle xmlns:a="http://schemas.openxmlformats.org/drawingml/2006/main"/>
           <a:p xmlns:a="http://schemas.openxmlformats.org/drawingml/2006/main">
             <a:pPr algn="ctr">
+              <a:buNone/>
               <a:defRPr sz="2400" b="1">
                 <a:solidFill>
                   <a:srgbClr val="1F2A2A"/>
@@ -14600,6 +14735,7 @@
           <a:lstStyle xmlns:a="http://schemas.openxmlformats.org/drawingml/2006/main"/>
           <a:p xmlns:a="http://schemas.openxmlformats.org/drawingml/2006/main">
             <a:pPr algn="ctr">
+              <a:buNone/>
               <a:defRPr sz="1650" b="0">
                 <a:solidFill>
                   <a:srgbClr val="5A5E55"/>
@@ -14662,6 +14798,7 @@
           <a:lstStyle xmlns:a="http://schemas.openxmlformats.org/drawingml/2006/main"/>
           <a:p xmlns:a="http://schemas.openxmlformats.org/drawingml/2006/main">
             <a:pPr algn="ctr">
+              <a:buNone/>
               <a:defRPr sz="2400" b="1">
                 <a:solidFill>
                   <a:srgbClr val="1F2A2A"/>
@@ -14720,6 +14857,7 @@
           <a:lstStyle xmlns:a="http://schemas.openxmlformats.org/drawingml/2006/main"/>
           <a:p xmlns:a="http://schemas.openxmlformats.org/drawingml/2006/main">
             <a:pPr algn="ctr">
+              <a:buNone/>
               <a:defRPr sz="2400" b="1">
                 <a:solidFill>
                   <a:srgbClr val="1F2A2A"/>
@@ -14778,6 +14916,7 @@
           <a:lstStyle xmlns:a="http://schemas.openxmlformats.org/drawingml/2006/main"/>
           <a:p xmlns:a="http://schemas.openxmlformats.org/drawingml/2006/main">
             <a:pPr algn="ctr">
+              <a:buNone/>
               <a:defRPr sz="1650" b="0">
                 <a:solidFill>
                   <a:srgbClr val="5A5E55"/>
@@ -14832,14 +14971,14 @@
       </p:grpSpPr>
       <p:pic>
         <p:nvPicPr>
-          <p:cNvPr id="20" name=""/>
+          <p:cNvPr id="22" name=""/>
           <p:cNvPicPr>
             <a:picLocks xmlns:a="http://schemas.openxmlformats.org/drawingml/2006/main" noChangeAspect="1"/>
           </p:cNvPicPr>
           <p:nvPr/>
         </p:nvPicPr>
         <p:blipFill>
-          <a:blip xmlns:r="http://schemas.openxmlformats.org/officeDocument/2006/relationships" xmlns:a="http://schemas.openxmlformats.org/drawingml/2006/main" r:embed="Rf017de1eb1b14cab"/>
+          <a:blip xmlns:r="http://schemas.openxmlformats.org/officeDocument/2006/relationships" xmlns:a="http://schemas.openxmlformats.org/drawingml/2006/main" r:embed="R2f65444e44a1487a"/>
           <a:stretch xmlns:a="http://schemas.openxmlformats.org/drawingml/2006/main"/>
         </p:blipFill>
         <p:spPr>
@@ -14854,14 +14993,14 @@
       </p:pic>
       <p:pic>
         <p:nvPicPr>
-          <p:cNvPr id="21" name=""/>
+          <p:cNvPr id="23" name=""/>
           <p:cNvPicPr>
             <a:picLocks xmlns:a="http://schemas.openxmlformats.org/drawingml/2006/main" noChangeAspect="1"/>
           </p:cNvPicPr>
           <p:nvPr/>
         </p:nvPicPr>
         <p:blipFill>
-          <a:blip xmlns:r="http://schemas.openxmlformats.org/officeDocument/2006/relationships" xmlns:a="http://schemas.openxmlformats.org/drawingml/2006/main" r:embed="Rbcaea500182d441c"/>
+          <a:blip xmlns:r="http://schemas.openxmlformats.org/officeDocument/2006/relationships" xmlns:a="http://schemas.openxmlformats.org/drawingml/2006/main" r:embed="Ra2525c0a4cd34588"/>
           <a:stretch xmlns:a="http://schemas.openxmlformats.org/drawingml/2006/main"/>
         </p:blipFill>
         <p:spPr>
@@ -14909,6 +15048,7 @@
           <a:lstStyle xmlns:a="http://schemas.openxmlformats.org/drawingml/2006/main"/>
           <a:p xmlns:a="http://schemas.openxmlformats.org/drawingml/2006/main">
             <a:pPr algn="l">
+              <a:buNone/>
               <a:defRPr sz="3600" b="1">
                 <a:solidFill>
                   <a:srgbClr val="1F2A2A"/>
@@ -14967,6 +15107,7 @@
           <a:lstStyle xmlns:a="http://schemas.openxmlformats.org/drawingml/2006/main"/>
           <a:p xmlns:a="http://schemas.openxmlformats.org/drawingml/2006/main">
             <a:pPr algn="l">
+              <a:buNone/>
               <a:defRPr sz="2400" b="1">
                 <a:solidFill>
                   <a:srgbClr val="5A5E55"/>
@@ -15025,6 +15166,7 @@
           <a:lstStyle xmlns:a="http://schemas.openxmlformats.org/drawingml/2006/main"/>
           <a:p xmlns:a="http://schemas.openxmlformats.org/drawingml/2006/main">
             <a:pPr algn="l">
+              <a:buNone/>
               <a:defRPr sz="1650" b="1">
                 <a:solidFill>
                   <a:srgbClr val="1F4FC9"/>
@@ -15114,6 +15256,7 @@
           <a:lstStyle xmlns:a="http://schemas.openxmlformats.org/drawingml/2006/main"/>
           <a:p xmlns:a="http://schemas.openxmlformats.org/drawingml/2006/main">
             <a:pPr algn="l">
+              <a:buNone/>
               <a:defRPr sz="1650" b="1">
                 <a:solidFill>
                   <a:srgbClr val="1F2A2A"/>
@@ -15172,6 +15315,7 @@
           <a:lstStyle xmlns:a="http://schemas.openxmlformats.org/drawingml/2006/main"/>
           <a:p xmlns:a="http://schemas.openxmlformats.org/drawingml/2006/main">
             <a:pPr algn="l">
+              <a:buNone/>
               <a:defRPr sz="1650" b="1">
                 <a:solidFill>
                   <a:srgbClr val="1F4FC9"/>
@@ -15261,6 +15405,7 @@
           <a:lstStyle xmlns:a="http://schemas.openxmlformats.org/drawingml/2006/main"/>
           <a:p xmlns:a="http://schemas.openxmlformats.org/drawingml/2006/main">
             <a:pPr algn="l">
+              <a:buNone/>
               <a:defRPr sz="1650" b="1">
                 <a:solidFill>
                   <a:srgbClr val="1F2A2A"/>
@@ -15319,6 +15464,7 @@
           <a:lstStyle xmlns:a="http://schemas.openxmlformats.org/drawingml/2006/main"/>
           <a:p xmlns:a="http://schemas.openxmlformats.org/drawingml/2006/main">
             <a:pPr algn="l">
+              <a:buNone/>
               <a:defRPr sz="1650" b="1">
                 <a:solidFill>
                   <a:srgbClr val="1F4FC9"/>
@@ -15408,6 +15554,7 @@
           <a:lstStyle xmlns:a="http://schemas.openxmlformats.org/drawingml/2006/main"/>
           <a:p xmlns:a="http://schemas.openxmlformats.org/drawingml/2006/main">
             <a:pPr algn="l">
+              <a:buNone/>
               <a:defRPr sz="1650" b="1">
                 <a:solidFill>
                   <a:srgbClr val="1F2A2A"/>
@@ -15466,6 +15613,7 @@
           <a:lstStyle xmlns:a="http://schemas.openxmlformats.org/drawingml/2006/main"/>
           <a:p xmlns:a="http://schemas.openxmlformats.org/drawingml/2006/main">
             <a:pPr algn="l">
+              <a:buNone/>
               <a:defRPr sz="1650" b="1">
                 <a:solidFill>
                   <a:srgbClr val="1F4FC9"/>
@@ -15555,6 +15703,7 @@
           <a:lstStyle xmlns:a="http://schemas.openxmlformats.org/drawingml/2006/main"/>
           <a:p xmlns:a="http://schemas.openxmlformats.org/drawingml/2006/main">
             <a:pPr algn="l">
+              <a:buNone/>
               <a:defRPr sz="1650" b="1">
                 <a:solidFill>
                   <a:srgbClr val="1F2A2A"/>
@@ -15613,6 +15762,7 @@
           <a:lstStyle xmlns:a="http://schemas.openxmlformats.org/drawingml/2006/main"/>
           <a:p xmlns:a="http://schemas.openxmlformats.org/drawingml/2006/main">
             <a:pPr algn="l">
+              <a:buNone/>
               <a:defRPr sz="1650" b="1">
                 <a:solidFill>
                   <a:srgbClr val="1F4FC9"/>
@@ -15702,6 +15852,7 @@
           <a:lstStyle xmlns:a="http://schemas.openxmlformats.org/drawingml/2006/main"/>
           <a:p xmlns:a="http://schemas.openxmlformats.org/drawingml/2006/main">
             <a:pPr algn="l">
+              <a:buNone/>
               <a:defRPr sz="1650" b="0">
                 <a:solidFill>
                   <a:srgbClr val="1F2A2A"/>
@@ -15756,14 +15907,14 @@
       </p:grpSpPr>
       <p:pic>
         <p:nvPicPr>
-          <p:cNvPr id="8" name=""/>
+          <p:cNvPr id="10" name=""/>
           <p:cNvPicPr>
             <a:picLocks xmlns:a="http://schemas.openxmlformats.org/drawingml/2006/main" noChangeAspect="1"/>
           </p:cNvPicPr>
           <p:nvPr/>
         </p:nvPicPr>
         <p:blipFill>
-          <a:blip xmlns:r="http://schemas.openxmlformats.org/officeDocument/2006/relationships" xmlns:a="http://schemas.openxmlformats.org/drawingml/2006/main" r:embed="Rb12bef2422f2455f"/>
+          <a:blip xmlns:r="http://schemas.openxmlformats.org/officeDocument/2006/relationships" xmlns:a="http://schemas.openxmlformats.org/drawingml/2006/main" r:embed="Rb4ca71a6b7df41bd"/>
           <a:stretch xmlns:a="http://schemas.openxmlformats.org/drawingml/2006/main"/>
         </p:blipFill>
         <p:spPr>
@@ -15778,14 +15929,14 @@
       </p:pic>
       <p:pic>
         <p:nvPicPr>
-          <p:cNvPr id="9" name=""/>
+          <p:cNvPr id="11" name=""/>
           <p:cNvPicPr>
             <a:picLocks xmlns:a="http://schemas.openxmlformats.org/drawingml/2006/main" noChangeAspect="1"/>
           </p:cNvPicPr>
           <p:nvPr/>
         </p:nvPicPr>
         <p:blipFill>
-          <a:blip xmlns:r="http://schemas.openxmlformats.org/officeDocument/2006/relationships" xmlns:a="http://schemas.openxmlformats.org/drawingml/2006/main" r:embed="Rd3ace96eecc94fb9"/>
+          <a:blip xmlns:r="http://schemas.openxmlformats.org/officeDocument/2006/relationships" xmlns:a="http://schemas.openxmlformats.org/drawingml/2006/main" r:embed="R6e0e894402134f9d"/>
           <a:stretch xmlns:a="http://schemas.openxmlformats.org/drawingml/2006/main"/>
         </p:blipFill>
         <p:spPr>
@@ -15833,6 +15984,7 @@
           <a:lstStyle xmlns:a="http://schemas.openxmlformats.org/drawingml/2006/main"/>
           <a:p xmlns:a="http://schemas.openxmlformats.org/drawingml/2006/main">
             <a:pPr algn="l">
+              <a:buNone/>
               <a:defRPr sz="3600" b="1">
                 <a:solidFill>
                   <a:srgbClr val="1F2A2A"/>
@@ -15891,6 +16043,7 @@
           <a:lstStyle xmlns:a="http://schemas.openxmlformats.org/drawingml/2006/main"/>
           <a:p xmlns:a="http://schemas.openxmlformats.org/drawingml/2006/main">
             <a:pPr algn="l">
+              <a:buNone/>
               <a:defRPr sz="2400" b="1">
                 <a:solidFill>
                   <a:srgbClr val="5A5E55"/>
@@ -15949,6 +16102,7 @@
           <a:lstStyle xmlns:a="http://schemas.openxmlformats.org/drawingml/2006/main"/>
           <a:p xmlns:a="http://schemas.openxmlformats.org/drawingml/2006/main">
             <a:pPr algn="l">
+              <a:buNone/>
               <a:defRPr sz="1650" b="1">
                 <a:solidFill>
                   <a:srgbClr val="1F4FC9"/>
@@ -16038,6 +16192,7 @@
           <a:lstStyle xmlns:a="http://schemas.openxmlformats.org/drawingml/2006/main"/>
           <a:p xmlns:a="http://schemas.openxmlformats.org/drawingml/2006/main">
             <a:pPr algn="l">
+              <a:buNone/>
               <a:defRPr sz="1650" b="0">
                 <a:solidFill>
                   <a:srgbClr val="1F2A2A"/>
@@ -16092,14 +16247,14 @@
       </p:grpSpPr>
       <p:pic>
         <p:nvPicPr>
-          <p:cNvPr id="8" name=""/>
+          <p:cNvPr id="10" name=""/>
           <p:cNvPicPr>
             <a:picLocks xmlns:a="http://schemas.openxmlformats.org/drawingml/2006/main" noChangeAspect="1"/>
           </p:cNvPicPr>
           <p:nvPr/>
         </p:nvPicPr>
         <p:blipFill>
-          <a:blip xmlns:r="http://schemas.openxmlformats.org/officeDocument/2006/relationships" xmlns:a="http://schemas.openxmlformats.org/drawingml/2006/main" r:embed="R7eb8654aadb046ae"/>
+          <a:blip xmlns:r="http://schemas.openxmlformats.org/officeDocument/2006/relationships" xmlns:a="http://schemas.openxmlformats.org/drawingml/2006/main" r:embed="Rb2acdb156620494e"/>
           <a:stretch xmlns:a="http://schemas.openxmlformats.org/drawingml/2006/main"/>
         </p:blipFill>
         <p:spPr>
@@ -16114,14 +16269,14 @@
       </p:pic>
       <p:pic>
         <p:nvPicPr>
-          <p:cNvPr id="9" name=""/>
+          <p:cNvPr id="11" name=""/>
           <p:cNvPicPr>
             <a:picLocks xmlns:a="http://schemas.openxmlformats.org/drawingml/2006/main" noChangeAspect="1"/>
           </p:cNvPicPr>
           <p:nvPr/>
         </p:nvPicPr>
         <p:blipFill>
-          <a:blip xmlns:r="http://schemas.openxmlformats.org/officeDocument/2006/relationships" xmlns:a="http://schemas.openxmlformats.org/drawingml/2006/main" r:embed="R205b7a6f8047499d"/>
+          <a:blip xmlns:r="http://schemas.openxmlformats.org/officeDocument/2006/relationships" xmlns:a="http://schemas.openxmlformats.org/drawingml/2006/main" r:embed="R18c682526bc240cf"/>
           <a:stretch xmlns:a="http://schemas.openxmlformats.org/drawingml/2006/main"/>
         </p:blipFill>
         <p:spPr>
@@ -16169,6 +16324,7 @@
           <a:lstStyle xmlns:a="http://schemas.openxmlformats.org/drawingml/2006/main"/>
           <a:p xmlns:a="http://schemas.openxmlformats.org/drawingml/2006/main">
             <a:pPr algn="l">
+              <a:buNone/>
               <a:defRPr sz="3600" b="1">
                 <a:solidFill>
                   <a:srgbClr val="F6F2EA"/>
@@ -16227,6 +16383,7 @@
           <a:lstStyle xmlns:a="http://schemas.openxmlformats.org/drawingml/2006/main"/>
           <a:p xmlns:a="http://schemas.openxmlformats.org/drawingml/2006/main">
             <a:pPr algn="l">
+              <a:buNone/>
               <a:defRPr sz="3300" b="1">
                 <a:solidFill>
                   <a:srgbClr val="F6F2EA"/>
@@ -16285,6 +16442,7 @@
           <a:lstStyle xmlns:a="http://schemas.openxmlformats.org/drawingml/2006/main"/>
           <a:p xmlns:a="http://schemas.openxmlformats.org/drawingml/2006/main">
             <a:pPr algn="l">
+              <a:buNone/>
               <a:defRPr sz="1650" b="0">
                 <a:solidFill>
                   <a:srgbClr val="D9DDD5"/>
@@ -16308,6 +16466,7 @@
           </a:p>
           <a:p xmlns:a="http://schemas.openxmlformats.org/drawingml/2006/main">
             <a:pPr algn="l">
+              <a:buNone/>
               <a:defRPr sz="1650" b="0">
                 <a:solidFill>
                   <a:srgbClr val="D9DDD5"/>
@@ -16331,6 +16490,7 @@
           </a:p>
           <a:p xmlns:a="http://schemas.openxmlformats.org/drawingml/2006/main">
             <a:pPr algn="l">
+              <a:buNone/>
               <a:defRPr sz="1650" b="0">
                 <a:solidFill>
                   <a:srgbClr val="D9DDD5"/>
@@ -16354,6 +16514,7 @@
           </a:p>
           <a:p xmlns:a="http://schemas.openxmlformats.org/drawingml/2006/main">
             <a:pPr algn="l">
+              <a:buNone/>
               <a:defRPr sz="1650" b="0">
                 <a:solidFill>
                   <a:srgbClr val="D9DDD5"/>
@@ -16377,6 +16538,7 @@
           </a:p>
           <a:p xmlns:a="http://schemas.openxmlformats.org/drawingml/2006/main">
             <a:pPr algn="l">
+              <a:buNone/>
               <a:defRPr sz="1650" b="0">
                 <a:solidFill>
                   <a:srgbClr val="D9DDD5"/>
@@ -16466,6 +16628,7 @@
           <a:lstStyle xmlns:a="http://schemas.openxmlformats.org/drawingml/2006/main"/>
           <a:p xmlns:a="http://schemas.openxmlformats.org/drawingml/2006/main">
             <a:pPr algn="l">
+              <a:buNone/>
               <a:defRPr sz="2400" b="1">
                 <a:solidFill>
                   <a:srgbClr val="FFFFFF"/>
@@ -16520,14 +16683,14 @@
       </p:grpSpPr>
       <p:pic>
         <p:nvPicPr>
-          <p:cNvPr id="29" name=""/>
+          <p:cNvPr id="31" name=""/>
           <p:cNvPicPr>
             <a:picLocks xmlns:a="http://schemas.openxmlformats.org/drawingml/2006/main" noChangeAspect="1"/>
           </p:cNvPicPr>
           <p:nvPr/>
         </p:nvPicPr>
         <p:blipFill>
-          <a:blip xmlns:r="http://schemas.openxmlformats.org/officeDocument/2006/relationships" xmlns:a="http://schemas.openxmlformats.org/drawingml/2006/main" r:embed="R2ddf7c1477e245c7"/>
+          <a:blip xmlns:r="http://schemas.openxmlformats.org/officeDocument/2006/relationships" xmlns:a="http://schemas.openxmlformats.org/drawingml/2006/main" r:embed="Rb2287d6e83944388"/>
           <a:stretch xmlns:a="http://schemas.openxmlformats.org/drawingml/2006/main"/>
         </p:blipFill>
         <p:spPr>
@@ -16542,14 +16705,14 @@
       </p:pic>
       <p:pic>
         <p:nvPicPr>
-          <p:cNvPr id="30" name=""/>
+          <p:cNvPr id="32" name=""/>
           <p:cNvPicPr>
             <a:picLocks xmlns:a="http://schemas.openxmlformats.org/drawingml/2006/main" noChangeAspect="1"/>
           </p:cNvPicPr>
           <p:nvPr/>
         </p:nvPicPr>
         <p:blipFill>
-          <a:blip xmlns:r="http://schemas.openxmlformats.org/officeDocument/2006/relationships" xmlns:a="http://schemas.openxmlformats.org/drawingml/2006/main" r:embed="R8f42cd3b7d874be7"/>
+          <a:blip xmlns:r="http://schemas.openxmlformats.org/officeDocument/2006/relationships" xmlns:a="http://schemas.openxmlformats.org/drawingml/2006/main" r:embed="R0377234873c743ab"/>
           <a:stretch xmlns:a="http://schemas.openxmlformats.org/drawingml/2006/main"/>
         </p:blipFill>
         <p:spPr>
@@ -16597,6 +16760,7 @@
           <a:lstStyle xmlns:a="http://schemas.openxmlformats.org/drawingml/2006/main"/>
           <a:p xmlns:a="http://schemas.openxmlformats.org/drawingml/2006/main">
             <a:pPr algn="l">
+              <a:buNone/>
               <a:defRPr sz="3600" b="1">
                 <a:solidFill>
                   <a:srgbClr val="1F2A2A"/>
@@ -16655,6 +16819,7 @@
           <a:lstStyle xmlns:a="http://schemas.openxmlformats.org/drawingml/2006/main"/>
           <a:p xmlns:a="http://schemas.openxmlformats.org/drawingml/2006/main">
             <a:pPr algn="l">
+              <a:buNone/>
               <a:defRPr sz="2400" b="1">
                 <a:solidFill>
                   <a:srgbClr val="5A5E55"/>
@@ -16713,6 +16878,7 @@
           <a:lstStyle xmlns:a="http://schemas.openxmlformats.org/drawingml/2006/main"/>
           <a:p xmlns:a="http://schemas.openxmlformats.org/drawingml/2006/main">
             <a:pPr algn="l">
+              <a:buNone/>
               <a:defRPr sz="1650" b="1">
                 <a:solidFill>
                   <a:srgbClr val="1F4FC9"/>
@@ -16802,6 +16968,7 @@
           <a:lstStyle xmlns:a="http://schemas.openxmlformats.org/drawingml/2006/main"/>
           <a:p xmlns:a="http://schemas.openxmlformats.org/drawingml/2006/main">
             <a:pPr algn="l">
+              <a:buNone/>
               <a:defRPr sz="1650" b="1">
                 <a:solidFill>
                   <a:srgbClr val="1F2A2A"/>
@@ -16860,6 +17027,7 @@
           <a:lstStyle xmlns:a="http://schemas.openxmlformats.org/drawingml/2006/main"/>
           <a:p xmlns:a="http://schemas.openxmlformats.org/drawingml/2006/main">
             <a:pPr algn="l">
+              <a:buNone/>
               <a:defRPr sz="1650" b="1">
                 <a:solidFill>
                   <a:srgbClr val="1F4FC9"/>
@@ -16949,6 +17117,7 @@
           <a:lstStyle xmlns:a="http://schemas.openxmlformats.org/drawingml/2006/main"/>
           <a:p xmlns:a="http://schemas.openxmlformats.org/drawingml/2006/main">
             <a:pPr algn="l">
+              <a:buNone/>
               <a:defRPr sz="1650" b="1">
                 <a:solidFill>
                   <a:srgbClr val="1F2A2A"/>
@@ -17007,6 +17176,7 @@
           <a:lstStyle xmlns:a="http://schemas.openxmlformats.org/drawingml/2006/main"/>
           <a:p xmlns:a="http://schemas.openxmlformats.org/drawingml/2006/main">
             <a:pPr algn="l">
+              <a:buNone/>
               <a:defRPr sz="1650" b="1">
                 <a:solidFill>
                   <a:srgbClr val="1F4FC9"/>
@@ -17096,6 +17266,7 @@
           <a:lstStyle xmlns:a="http://schemas.openxmlformats.org/drawingml/2006/main"/>
           <a:p xmlns:a="http://schemas.openxmlformats.org/drawingml/2006/main">
             <a:pPr algn="l">
+              <a:buNone/>
               <a:defRPr sz="1650" b="1">
                 <a:solidFill>
                   <a:srgbClr val="1F2A2A"/>
@@ -17154,6 +17325,7 @@
           <a:lstStyle xmlns:a="http://schemas.openxmlformats.org/drawingml/2006/main"/>
           <a:p xmlns:a="http://schemas.openxmlformats.org/drawingml/2006/main">
             <a:pPr algn="l">
+              <a:buNone/>
               <a:defRPr sz="1650" b="1">
                 <a:solidFill>
                   <a:srgbClr val="1F4FC9"/>
@@ -17243,6 +17415,7 @@
           <a:lstStyle xmlns:a="http://schemas.openxmlformats.org/drawingml/2006/main"/>
           <a:p xmlns:a="http://schemas.openxmlformats.org/drawingml/2006/main">
             <a:pPr algn="l">
+              <a:buNone/>
               <a:defRPr sz="1650" b="1">
                 <a:solidFill>
                   <a:srgbClr val="1F2A2A"/>
@@ -17301,6 +17474,7 @@
           <a:lstStyle xmlns:a="http://schemas.openxmlformats.org/drawingml/2006/main"/>
           <a:p xmlns:a="http://schemas.openxmlformats.org/drawingml/2006/main">
             <a:pPr algn="l">
+              <a:buNone/>
               <a:defRPr sz="1650" b="1">
                 <a:solidFill>
                   <a:srgbClr val="1F4FC9"/>
@@ -17390,6 +17564,7 @@
           <a:lstStyle xmlns:a="http://schemas.openxmlformats.org/drawingml/2006/main"/>
           <a:p xmlns:a="http://schemas.openxmlformats.org/drawingml/2006/main">
             <a:pPr algn="l">
+              <a:buNone/>
               <a:defRPr sz="1650" b="1">
                 <a:solidFill>
                   <a:srgbClr val="1F2A2A"/>
@@ -17448,6 +17623,7 @@
           <a:lstStyle xmlns:a="http://schemas.openxmlformats.org/drawingml/2006/main"/>
           <a:p xmlns:a="http://schemas.openxmlformats.org/drawingml/2006/main">
             <a:pPr algn="l">
+              <a:buNone/>
               <a:defRPr sz="1650" b="1">
                 <a:solidFill>
                   <a:srgbClr val="1F4FC9"/>
@@ -17537,6 +17713,7 @@
           <a:lstStyle xmlns:a="http://schemas.openxmlformats.org/drawingml/2006/main"/>
           <a:p xmlns:a="http://schemas.openxmlformats.org/drawingml/2006/main">
             <a:pPr algn="l">
+              <a:buNone/>
               <a:defRPr sz="1650" b="1">
                 <a:solidFill>
                   <a:srgbClr val="1F2A2A"/>
@@ -17595,6 +17772,7 @@
           <a:lstStyle xmlns:a="http://schemas.openxmlformats.org/drawingml/2006/main"/>
           <a:p xmlns:a="http://schemas.openxmlformats.org/drawingml/2006/main">
             <a:pPr algn="l">
+              <a:buNone/>
               <a:defRPr sz="1650" b="1">
                 <a:solidFill>
                   <a:srgbClr val="1F4FC9"/>
@@ -17684,6 +17862,7 @@
           <a:lstStyle xmlns:a="http://schemas.openxmlformats.org/drawingml/2006/main"/>
           <a:p xmlns:a="http://schemas.openxmlformats.org/drawingml/2006/main">
             <a:pPr algn="l">
+              <a:buNone/>
               <a:defRPr sz="1650" b="1">
                 <a:solidFill>
                   <a:srgbClr val="1F2A2A"/>
@@ -17742,6 +17921,7 @@
           <a:lstStyle xmlns:a="http://schemas.openxmlformats.org/drawingml/2006/main"/>
           <a:p xmlns:a="http://schemas.openxmlformats.org/drawingml/2006/main">
             <a:pPr algn="l">
+              <a:buNone/>
               <a:defRPr sz="1650" b="1">
                 <a:solidFill>
                   <a:srgbClr val="1F4FC9"/>
@@ -17831,6 +18011,7 @@
           <a:lstStyle xmlns:a="http://schemas.openxmlformats.org/drawingml/2006/main"/>
           <a:p xmlns:a="http://schemas.openxmlformats.org/drawingml/2006/main">
             <a:pPr algn="l">
+              <a:buNone/>
               <a:defRPr sz="1650" b="1">
                 <a:solidFill>
                   <a:srgbClr val="1F2A2A"/>
@@ -17885,14 +18066,14 @@
       </p:grpSpPr>
       <p:pic>
         <p:nvPicPr>
-          <p:cNvPr id="8" name=""/>
+          <p:cNvPr id="10" name=""/>
           <p:cNvPicPr>
             <a:picLocks xmlns:a="http://schemas.openxmlformats.org/drawingml/2006/main" noChangeAspect="1"/>
           </p:cNvPicPr>
           <p:nvPr/>
         </p:nvPicPr>
         <p:blipFill>
-          <a:blip xmlns:r="http://schemas.openxmlformats.org/officeDocument/2006/relationships" xmlns:a="http://schemas.openxmlformats.org/drawingml/2006/main" r:embed="R5f8adde17de54370"/>
+          <a:blip xmlns:r="http://schemas.openxmlformats.org/officeDocument/2006/relationships" xmlns:a="http://schemas.openxmlformats.org/drawingml/2006/main" r:embed="R6045b89ccea94a42"/>
           <a:stretch xmlns:a="http://schemas.openxmlformats.org/drawingml/2006/main"/>
         </p:blipFill>
         <p:spPr>
@@ -17907,14 +18088,14 @@
       </p:pic>
       <p:pic>
         <p:nvPicPr>
-          <p:cNvPr id="9" name=""/>
+          <p:cNvPr id="11" name=""/>
           <p:cNvPicPr>
             <a:picLocks xmlns:a="http://schemas.openxmlformats.org/drawingml/2006/main" noChangeAspect="1"/>
           </p:cNvPicPr>
           <p:nvPr/>
         </p:nvPicPr>
         <p:blipFill>
-          <a:blip xmlns:r="http://schemas.openxmlformats.org/officeDocument/2006/relationships" xmlns:a="http://schemas.openxmlformats.org/drawingml/2006/main" r:embed="R4e2753e0448041e6"/>
+          <a:blip xmlns:r="http://schemas.openxmlformats.org/officeDocument/2006/relationships" xmlns:a="http://schemas.openxmlformats.org/drawingml/2006/main" r:embed="Rab52a77737b04f17"/>
           <a:stretch xmlns:a="http://schemas.openxmlformats.org/drawingml/2006/main"/>
         </p:blipFill>
         <p:spPr>
@@ -17962,6 +18143,7 @@
           <a:lstStyle xmlns:a="http://schemas.openxmlformats.org/drawingml/2006/main"/>
           <a:p xmlns:a="http://schemas.openxmlformats.org/drawingml/2006/main">
             <a:pPr algn="l">
+              <a:buNone/>
               <a:defRPr sz="3600" b="1">
                 <a:solidFill>
                   <a:srgbClr val="F6F2EA"/>
@@ -18020,6 +18202,7 @@
           <a:lstStyle xmlns:a="http://schemas.openxmlformats.org/drawingml/2006/main"/>
           <a:p xmlns:a="http://schemas.openxmlformats.org/drawingml/2006/main">
             <a:pPr algn="l">
+              <a:buNone/>
               <a:defRPr sz="3300" b="1">
                 <a:solidFill>
                   <a:srgbClr val="F6F2EA"/>
@@ -18078,6 +18261,7 @@
           <a:lstStyle xmlns:a="http://schemas.openxmlformats.org/drawingml/2006/main"/>
           <a:p xmlns:a="http://schemas.openxmlformats.org/drawingml/2006/main">
             <a:pPr algn="l">
+              <a:buNone/>
               <a:defRPr sz="1650" b="0">
                 <a:solidFill>
                   <a:srgbClr val="D9DDD5"/>
@@ -18101,6 +18285,7 @@
           </a:p>
           <a:p xmlns:a="http://schemas.openxmlformats.org/drawingml/2006/main">
             <a:pPr algn="l">
+              <a:buNone/>
               <a:defRPr sz="1650" b="0">
                 <a:solidFill>
                   <a:srgbClr val="D9DDD5"/>
@@ -18124,6 +18309,7 @@
           </a:p>
           <a:p xmlns:a="http://schemas.openxmlformats.org/drawingml/2006/main">
             <a:pPr algn="l">
+              <a:buNone/>
               <a:defRPr sz="1650" b="0">
                 <a:solidFill>
                   <a:srgbClr val="D9DDD5"/>
@@ -18147,6 +18333,7 @@
           </a:p>
           <a:p xmlns:a="http://schemas.openxmlformats.org/drawingml/2006/main">
             <a:pPr algn="l">
+              <a:buNone/>
               <a:defRPr sz="1650" b="0">
                 <a:solidFill>
                   <a:srgbClr val="D9DDD5"/>
@@ -18170,6 +18357,7 @@
           </a:p>
           <a:p xmlns:a="http://schemas.openxmlformats.org/drawingml/2006/main">
             <a:pPr algn="l">
+              <a:buNone/>
               <a:defRPr sz="1650" b="0">
                 <a:solidFill>
                   <a:srgbClr val="D9DDD5"/>
@@ -18193,6 +18381,7 @@
           </a:p>
           <a:p xmlns:a="http://schemas.openxmlformats.org/drawingml/2006/main">
             <a:pPr algn="l">
+              <a:buNone/>
               <a:defRPr sz="1650" b="0">
                 <a:solidFill>
                   <a:srgbClr val="D9DDD5"/>
@@ -18282,6 +18471,7 @@
           <a:lstStyle xmlns:a="http://schemas.openxmlformats.org/drawingml/2006/main"/>
           <a:p xmlns:a="http://schemas.openxmlformats.org/drawingml/2006/main">
             <a:pPr algn="l">
+              <a:buNone/>
               <a:defRPr sz="2400" b="1">
                 <a:solidFill>
                   <a:srgbClr val="FFFFFF"/>
@@ -18336,14 +18526,14 @@
       </p:grpSpPr>
       <p:pic>
         <p:nvPicPr>
-          <p:cNvPr id="8" name=""/>
+          <p:cNvPr id="10" name=""/>
           <p:cNvPicPr>
             <a:picLocks xmlns:a="http://schemas.openxmlformats.org/drawingml/2006/main" noChangeAspect="1"/>
           </p:cNvPicPr>
           <p:nvPr/>
         </p:nvPicPr>
         <p:blipFill>
-          <a:blip xmlns:r="http://schemas.openxmlformats.org/officeDocument/2006/relationships" xmlns:a="http://schemas.openxmlformats.org/drawingml/2006/main" r:embed="R0c630884bbe04219"/>
+          <a:blip xmlns:r="http://schemas.openxmlformats.org/officeDocument/2006/relationships" xmlns:a="http://schemas.openxmlformats.org/drawingml/2006/main" r:embed="R850de714ff394dae"/>
           <a:stretch xmlns:a="http://schemas.openxmlformats.org/drawingml/2006/main"/>
         </p:blipFill>
         <p:spPr>
@@ -18358,14 +18548,14 @@
       </p:pic>
       <p:pic>
         <p:nvPicPr>
-          <p:cNvPr id="9" name=""/>
+          <p:cNvPr id="11" name=""/>
           <p:cNvPicPr>
             <a:picLocks xmlns:a="http://schemas.openxmlformats.org/drawingml/2006/main" noChangeAspect="1"/>
           </p:cNvPicPr>
           <p:nvPr/>
         </p:nvPicPr>
         <p:blipFill>
-          <a:blip xmlns:r="http://schemas.openxmlformats.org/officeDocument/2006/relationships" xmlns:a="http://schemas.openxmlformats.org/drawingml/2006/main" r:embed="R7c14eebbfef343d4"/>
+          <a:blip xmlns:r="http://schemas.openxmlformats.org/officeDocument/2006/relationships" xmlns:a="http://schemas.openxmlformats.org/drawingml/2006/main" r:embed="R625d6ec8bf334215"/>
           <a:stretch xmlns:a="http://schemas.openxmlformats.org/drawingml/2006/main"/>
         </p:blipFill>
         <p:spPr>
@@ -18413,6 +18603,7 @@
           <a:lstStyle xmlns:a="http://schemas.openxmlformats.org/drawingml/2006/main"/>
           <a:p xmlns:a="http://schemas.openxmlformats.org/drawingml/2006/main">
             <a:pPr algn="l">
+              <a:buNone/>
               <a:defRPr sz="3600" b="1">
                 <a:solidFill>
                   <a:srgbClr val="1F2A2A"/>
@@ -18471,6 +18662,7 @@
           <a:lstStyle xmlns:a="http://schemas.openxmlformats.org/drawingml/2006/main"/>
           <a:p xmlns:a="http://schemas.openxmlformats.org/drawingml/2006/main">
             <a:pPr algn="l">
+              <a:buNone/>
               <a:defRPr sz="3300" b="1">
                 <a:solidFill>
                   <a:srgbClr val="1F2A2A"/>
@@ -18529,6 +18721,7 @@
           <a:lstStyle xmlns:a="http://schemas.openxmlformats.org/drawingml/2006/main"/>
           <a:p xmlns:a="http://schemas.openxmlformats.org/drawingml/2006/main">
             <a:pPr algn="l">
+              <a:buNone/>
               <a:defRPr sz="1650" b="0">
                 <a:solidFill>
                   <a:srgbClr val="5A5E55"/>
@@ -18618,6 +18811,7 @@
           <a:lstStyle xmlns:a="http://schemas.openxmlformats.org/drawingml/2006/main"/>
           <a:p xmlns:a="http://schemas.openxmlformats.org/drawingml/2006/main">
             <a:pPr algn="l">
+              <a:buNone/>
               <a:defRPr sz="2400" b="1">
                 <a:solidFill>
                   <a:srgbClr val="1F2A2A"/>
@@ -18672,14 +18866,14 @@
       </p:grpSpPr>
       <p:pic>
         <p:nvPicPr>
-          <p:cNvPr id="19" name=""/>
+          <p:cNvPr id="21" name=""/>
           <p:cNvPicPr>
             <a:picLocks xmlns:a="http://schemas.openxmlformats.org/drawingml/2006/main" noChangeAspect="1"/>
           </p:cNvPicPr>
           <p:nvPr/>
         </p:nvPicPr>
         <p:blipFill>
-          <a:blip xmlns:r="http://schemas.openxmlformats.org/officeDocument/2006/relationships" xmlns:a="http://schemas.openxmlformats.org/drawingml/2006/main" r:embed="R11330bd87b2043ce"/>
+          <a:blip xmlns:r="http://schemas.openxmlformats.org/officeDocument/2006/relationships" xmlns:a="http://schemas.openxmlformats.org/drawingml/2006/main" r:embed="Radf9b38867f64f7f"/>
           <a:stretch xmlns:a="http://schemas.openxmlformats.org/drawingml/2006/main"/>
         </p:blipFill>
         <p:spPr>
@@ -18694,14 +18888,14 @@
       </p:pic>
       <p:pic>
         <p:nvPicPr>
-          <p:cNvPr id="20" name=""/>
+          <p:cNvPr id="22" name=""/>
           <p:cNvPicPr>
             <a:picLocks xmlns:a="http://schemas.openxmlformats.org/drawingml/2006/main" noChangeAspect="1"/>
           </p:cNvPicPr>
           <p:nvPr/>
         </p:nvPicPr>
         <p:blipFill>
-          <a:blip xmlns:r="http://schemas.openxmlformats.org/officeDocument/2006/relationships" xmlns:a="http://schemas.openxmlformats.org/drawingml/2006/main" r:embed="R054ab9ff5093485b"/>
+          <a:blip xmlns:r="http://schemas.openxmlformats.org/officeDocument/2006/relationships" xmlns:a="http://schemas.openxmlformats.org/drawingml/2006/main" r:embed="R81403cde3fb44ebf"/>
           <a:stretch xmlns:a="http://schemas.openxmlformats.org/drawingml/2006/main"/>
         </p:blipFill>
         <p:spPr>
@@ -18749,6 +18943,7 @@
           <a:lstStyle xmlns:a="http://schemas.openxmlformats.org/drawingml/2006/main"/>
           <a:p xmlns:a="http://schemas.openxmlformats.org/drawingml/2006/main">
             <a:pPr algn="l">
+              <a:buNone/>
               <a:defRPr sz="3600" b="1">
                 <a:solidFill>
                   <a:srgbClr val="1F2A2A"/>
@@ -18807,6 +19002,7 @@
           <a:lstStyle xmlns:a="http://schemas.openxmlformats.org/drawingml/2006/main"/>
           <a:p xmlns:a="http://schemas.openxmlformats.org/drawingml/2006/main">
             <a:pPr algn="l">
+              <a:buNone/>
               <a:defRPr sz="2400" b="1">
                 <a:solidFill>
                   <a:srgbClr val="5A5E55"/>
@@ -18865,6 +19061,7 @@
           <a:lstStyle xmlns:a="http://schemas.openxmlformats.org/drawingml/2006/main"/>
           <a:p xmlns:a="http://schemas.openxmlformats.org/drawingml/2006/main">
             <a:pPr algn="ctr">
+              <a:buNone/>
               <a:defRPr sz="1650" b="1">
                 <a:solidFill>
                   <a:srgbClr val="1F4FC9"/>
@@ -18923,6 +19120,7 @@
           <a:lstStyle xmlns:a="http://schemas.openxmlformats.org/drawingml/2006/main"/>
           <a:p xmlns:a="http://schemas.openxmlformats.org/drawingml/2006/main">
             <a:pPr algn="l">
+              <a:buNone/>
               <a:defRPr sz="1650" b="1">
                 <a:solidFill>
                   <a:srgbClr val="1F2A2A"/>
@@ -19012,6 +19210,7 @@
           <a:lstStyle xmlns:a="http://schemas.openxmlformats.org/drawingml/2006/main"/>
           <a:p xmlns:a="http://schemas.openxmlformats.org/drawingml/2006/main">
             <a:pPr algn="ctr">
+              <a:buNone/>
               <a:defRPr sz="1650" b="1">
                 <a:solidFill>
                   <a:srgbClr val="1F4FC9"/>
@@ -19070,6 +19269,7 @@
           <a:lstStyle xmlns:a="http://schemas.openxmlformats.org/drawingml/2006/main"/>
           <a:p xmlns:a="http://schemas.openxmlformats.org/drawingml/2006/main">
             <a:pPr algn="l">
+              <a:buNone/>
               <a:defRPr sz="1650" b="1">
                 <a:solidFill>
                   <a:srgbClr val="1F2A2A"/>
@@ -19159,6 +19359,7 @@
           <a:lstStyle xmlns:a="http://schemas.openxmlformats.org/drawingml/2006/main"/>
           <a:p xmlns:a="http://schemas.openxmlformats.org/drawingml/2006/main">
             <a:pPr algn="ctr">
+              <a:buNone/>
               <a:defRPr sz="1650" b="1">
                 <a:solidFill>
                   <a:srgbClr val="1F4FC9"/>
@@ -19217,6 +19418,7 @@
           <a:lstStyle xmlns:a="http://schemas.openxmlformats.org/drawingml/2006/main"/>
           <a:p xmlns:a="http://schemas.openxmlformats.org/drawingml/2006/main">
             <a:pPr algn="l">
+              <a:buNone/>
               <a:defRPr sz="1650" b="1">
                 <a:solidFill>
                   <a:srgbClr val="1F2A2A"/>
@@ -19306,6 +19508,7 @@
           <a:lstStyle xmlns:a="http://schemas.openxmlformats.org/drawingml/2006/main"/>
           <a:p xmlns:a="http://schemas.openxmlformats.org/drawingml/2006/main">
             <a:pPr algn="ctr">
+              <a:buNone/>
               <a:defRPr sz="1650" b="1">
                 <a:solidFill>
                   <a:srgbClr val="1F4FC9"/>
@@ -19364,6 +19567,7 @@
           <a:lstStyle xmlns:a="http://schemas.openxmlformats.org/drawingml/2006/main"/>
           <a:p xmlns:a="http://schemas.openxmlformats.org/drawingml/2006/main">
             <a:pPr algn="l">
+              <a:buNone/>
               <a:defRPr sz="1650" b="1">
                 <a:solidFill>
                   <a:srgbClr val="1F2A2A"/>
@@ -19453,6 +19657,7 @@
           <a:lstStyle xmlns:a="http://schemas.openxmlformats.org/drawingml/2006/main"/>
           <a:p xmlns:a="http://schemas.openxmlformats.org/drawingml/2006/main">
             <a:pPr algn="ctr">
+              <a:buNone/>
               <a:defRPr sz="1650" b="1">
                 <a:solidFill>
                   <a:srgbClr val="1F4FC9"/>
@@ -19511,6 +19716,7 @@
           <a:lstStyle xmlns:a="http://schemas.openxmlformats.org/drawingml/2006/main"/>
           <a:p xmlns:a="http://schemas.openxmlformats.org/drawingml/2006/main">
             <a:pPr algn="l">
+              <a:buNone/>
               <a:defRPr sz="1650" b="1">
                 <a:solidFill>
                   <a:srgbClr val="1F2A2A"/>
@@ -19565,14 +19771,14 @@
       </p:grpSpPr>
       <p:pic>
         <p:nvPicPr>
-          <p:cNvPr id="8" name=""/>
+          <p:cNvPr id="10" name=""/>
           <p:cNvPicPr>
             <a:picLocks xmlns:a="http://schemas.openxmlformats.org/drawingml/2006/main" noChangeAspect="1"/>
           </p:cNvPicPr>
           <p:nvPr/>
         </p:nvPicPr>
         <p:blipFill>
-          <a:blip xmlns:r="http://schemas.openxmlformats.org/officeDocument/2006/relationships" xmlns:a="http://schemas.openxmlformats.org/drawingml/2006/main" r:embed="R3369322367cf4afa"/>
+          <a:blip xmlns:r="http://schemas.openxmlformats.org/officeDocument/2006/relationships" xmlns:a="http://schemas.openxmlformats.org/drawingml/2006/main" r:embed="Rf3823ee275fc4bf5"/>
           <a:stretch xmlns:a="http://schemas.openxmlformats.org/drawingml/2006/main"/>
         </p:blipFill>
         <p:spPr>
@@ -19587,14 +19793,14 @@
       </p:pic>
       <p:pic>
         <p:nvPicPr>
-          <p:cNvPr id="9" name=""/>
+          <p:cNvPr id="11" name=""/>
           <p:cNvPicPr>
             <a:picLocks xmlns:a="http://schemas.openxmlformats.org/drawingml/2006/main" noChangeAspect="1"/>
           </p:cNvPicPr>
           <p:nvPr/>
         </p:nvPicPr>
         <p:blipFill>
-          <a:blip xmlns:r="http://schemas.openxmlformats.org/officeDocument/2006/relationships" xmlns:a="http://schemas.openxmlformats.org/drawingml/2006/main" r:embed="R2cf4546477f543fb"/>
+          <a:blip xmlns:r="http://schemas.openxmlformats.org/officeDocument/2006/relationships" xmlns:a="http://schemas.openxmlformats.org/drawingml/2006/main" r:embed="Rcfb28dc5ac2b4fd0"/>
           <a:stretch xmlns:a="http://schemas.openxmlformats.org/drawingml/2006/main"/>
         </p:blipFill>
         <p:spPr>
@@ -19642,6 +19848,7 @@
           <a:lstStyle xmlns:a="http://schemas.openxmlformats.org/drawingml/2006/main"/>
           <a:p xmlns:a="http://schemas.openxmlformats.org/drawingml/2006/main">
             <a:pPr algn="l">
+              <a:buNone/>
               <a:defRPr sz="3600" b="1">
                 <a:solidFill>
                   <a:srgbClr val="1F2A2A"/>
@@ -19731,6 +19938,7 @@
           <a:lstStyle xmlns:a="http://schemas.openxmlformats.org/drawingml/2006/main"/>
           <a:p xmlns:a="http://schemas.openxmlformats.org/drawingml/2006/main">
             <a:pPr algn="l">
+              <a:buNone/>
               <a:defRPr sz="1650" b="1">
                 <a:solidFill>
                   <a:srgbClr val="1F4FC9"/>
@@ -19789,6 +19997,7 @@
           <a:lstStyle xmlns:a="http://schemas.openxmlformats.org/drawingml/2006/main"/>
           <a:p xmlns:a="http://schemas.openxmlformats.org/drawingml/2006/main">
             <a:pPr algn="l">
+              <a:buNone/>
               <a:defRPr sz="3300" b="1">
                 <a:solidFill>
                   <a:srgbClr val="1F2A2A"/>
@@ -19847,6 +20056,7 @@
           <a:lstStyle xmlns:a="http://schemas.openxmlformats.org/drawingml/2006/main"/>
           <a:p xmlns:a="http://schemas.openxmlformats.org/drawingml/2006/main">
             <a:pPr algn="l">
+              <a:buNone/>
               <a:defRPr sz="1650" b="0">
                 <a:solidFill>
                   <a:srgbClr val="5A5E55"/>
@@ -19870,6 +20080,7 @@
           </a:p>
           <a:p xmlns:a="http://schemas.openxmlformats.org/drawingml/2006/main">
             <a:pPr algn="l">
+              <a:buNone/>
               <a:defRPr sz="1650" b="0">
                 <a:solidFill>
                   <a:srgbClr val="5A5E55"/>
@@ -19893,6 +20104,7 @@
           </a:p>
           <a:p xmlns:a="http://schemas.openxmlformats.org/drawingml/2006/main">
             <a:pPr algn="l">
+              <a:buNone/>
               <a:defRPr sz="1650" b="0">
                 <a:solidFill>
                   <a:srgbClr val="5A5E55"/>
@@ -19947,14 +20159,14 @@
       </p:grpSpPr>
       <p:pic>
         <p:nvPicPr>
-          <p:cNvPr id="8" name=""/>
+          <p:cNvPr id="10" name=""/>
           <p:cNvPicPr>
             <a:picLocks xmlns:a="http://schemas.openxmlformats.org/drawingml/2006/main" noChangeAspect="1"/>
           </p:cNvPicPr>
           <p:nvPr/>
         </p:nvPicPr>
         <p:blipFill>
-          <a:blip xmlns:r="http://schemas.openxmlformats.org/officeDocument/2006/relationships" xmlns:a="http://schemas.openxmlformats.org/drawingml/2006/main" r:embed="R1ba2b08880cc42f4"/>
+          <a:blip xmlns:r="http://schemas.openxmlformats.org/officeDocument/2006/relationships" xmlns:a="http://schemas.openxmlformats.org/drawingml/2006/main" r:embed="Rcb78eb116374412e"/>
           <a:stretch xmlns:a="http://schemas.openxmlformats.org/drawingml/2006/main"/>
         </p:blipFill>
         <p:spPr>
@@ -19969,14 +20181,14 @@
       </p:pic>
       <p:pic>
         <p:nvPicPr>
-          <p:cNvPr id="9" name=""/>
+          <p:cNvPr id="11" name=""/>
           <p:cNvPicPr>
             <a:picLocks xmlns:a="http://schemas.openxmlformats.org/drawingml/2006/main" noChangeAspect="1"/>
           </p:cNvPicPr>
           <p:nvPr/>
         </p:nvPicPr>
         <p:blipFill>
-          <a:blip xmlns:r="http://schemas.openxmlformats.org/officeDocument/2006/relationships" xmlns:a="http://schemas.openxmlformats.org/drawingml/2006/main" r:embed="R210f2b0e24eb471f"/>
+          <a:blip xmlns:r="http://schemas.openxmlformats.org/officeDocument/2006/relationships" xmlns:a="http://schemas.openxmlformats.org/drawingml/2006/main" r:embed="Refc2b034b04847a2"/>
           <a:stretch xmlns:a="http://schemas.openxmlformats.org/drawingml/2006/main"/>
         </p:blipFill>
         <p:spPr>
@@ -20024,6 +20236,7 @@
           <a:lstStyle xmlns:a="http://schemas.openxmlformats.org/drawingml/2006/main"/>
           <a:p xmlns:a="http://schemas.openxmlformats.org/drawingml/2006/main">
             <a:pPr algn="l">
+              <a:buNone/>
               <a:defRPr sz="3600" b="1">
                 <a:solidFill>
                   <a:srgbClr val="1F2A2A"/>
@@ -20113,6 +20326,7 @@
           <a:lstStyle xmlns:a="http://schemas.openxmlformats.org/drawingml/2006/main"/>
           <a:p xmlns:a="http://schemas.openxmlformats.org/drawingml/2006/main">
             <a:pPr algn="l">
+              <a:buNone/>
               <a:defRPr sz="1650" b="1">
                 <a:solidFill>
                   <a:srgbClr val="1F4FC9"/>
@@ -20171,6 +20385,7 @@
           <a:lstStyle xmlns:a="http://schemas.openxmlformats.org/drawingml/2006/main"/>
           <a:p xmlns:a="http://schemas.openxmlformats.org/drawingml/2006/main">
             <a:pPr algn="l">
+              <a:buNone/>
               <a:defRPr sz="3300" b="1">
                 <a:solidFill>
                   <a:srgbClr val="1F2A2A"/>
@@ -20229,6 +20444,7 @@
           <a:lstStyle xmlns:a="http://schemas.openxmlformats.org/drawingml/2006/main"/>
           <a:p xmlns:a="http://schemas.openxmlformats.org/drawingml/2006/main">
             <a:pPr algn="l">
+              <a:buNone/>
               <a:defRPr sz="1650" b="0">
                 <a:solidFill>
                   <a:srgbClr val="5A5E55"/>
@@ -20283,14 +20499,14 @@
       </p:grpSpPr>
       <p:pic>
         <p:nvPicPr>
-          <p:cNvPr id="8" name=""/>
+          <p:cNvPr id="10" name=""/>
           <p:cNvPicPr>
             <a:picLocks xmlns:a="http://schemas.openxmlformats.org/drawingml/2006/main" noChangeAspect="1"/>
           </p:cNvPicPr>
           <p:nvPr/>
         </p:nvPicPr>
         <p:blipFill>
-          <a:blip xmlns:r="http://schemas.openxmlformats.org/officeDocument/2006/relationships" xmlns:a="http://schemas.openxmlformats.org/drawingml/2006/main" r:embed="Rc8bc7be7ab7c4510"/>
+          <a:blip xmlns:r="http://schemas.openxmlformats.org/officeDocument/2006/relationships" xmlns:a="http://schemas.openxmlformats.org/drawingml/2006/main" r:embed="Rd873417b96854e25"/>
           <a:stretch xmlns:a="http://schemas.openxmlformats.org/drawingml/2006/main"/>
         </p:blipFill>
         <p:spPr>
@@ -20305,14 +20521,14 @@
       </p:pic>
       <p:pic>
         <p:nvPicPr>
-          <p:cNvPr id="9" name=""/>
+          <p:cNvPr id="11" name=""/>
           <p:cNvPicPr>
             <a:picLocks xmlns:a="http://schemas.openxmlformats.org/drawingml/2006/main" noChangeAspect="1"/>
           </p:cNvPicPr>
           <p:nvPr/>
         </p:nvPicPr>
         <p:blipFill>
-          <a:blip xmlns:r="http://schemas.openxmlformats.org/officeDocument/2006/relationships" xmlns:a="http://schemas.openxmlformats.org/drawingml/2006/main" r:embed="Rd3268c2a410f43c2"/>
+          <a:blip xmlns:r="http://schemas.openxmlformats.org/officeDocument/2006/relationships" xmlns:a="http://schemas.openxmlformats.org/drawingml/2006/main" r:embed="R7c291bec100f4ee9"/>
           <a:stretch xmlns:a="http://schemas.openxmlformats.org/drawingml/2006/main"/>
         </p:blipFill>
         <p:spPr>
@@ -20360,6 +20576,7 @@
           <a:lstStyle xmlns:a="http://schemas.openxmlformats.org/drawingml/2006/main"/>
           <a:p xmlns:a="http://schemas.openxmlformats.org/drawingml/2006/main">
             <a:pPr algn="l">
+              <a:buNone/>
               <a:defRPr sz="3600" b="1">
                 <a:solidFill>
                   <a:srgbClr val="1F2A2A"/>
@@ -20449,6 +20666,7 @@
           <a:lstStyle xmlns:a="http://schemas.openxmlformats.org/drawingml/2006/main"/>
           <a:p xmlns:a="http://schemas.openxmlformats.org/drawingml/2006/main">
             <a:pPr algn="l">
+              <a:buNone/>
               <a:defRPr sz="1650" b="1">
                 <a:solidFill>
                   <a:srgbClr val="1F4FC9"/>
@@ -20507,6 +20725,7 @@
           <a:lstStyle xmlns:a="http://schemas.openxmlformats.org/drawingml/2006/main"/>
           <a:p xmlns:a="http://schemas.openxmlformats.org/drawingml/2006/main">
             <a:pPr algn="l">
+              <a:buNone/>
               <a:defRPr sz="3300" b="1">
                 <a:solidFill>
                   <a:srgbClr val="1F2A2A"/>
@@ -20565,6 +20784,7 @@
           <a:lstStyle xmlns:a="http://schemas.openxmlformats.org/drawingml/2006/main"/>
           <a:p xmlns:a="http://schemas.openxmlformats.org/drawingml/2006/main">
             <a:pPr algn="l">
+              <a:buNone/>
               <a:defRPr sz="1650" b="0">
                 <a:solidFill>
                   <a:srgbClr val="5A5E55"/>
@@ -20588,6 +20808,7 @@
           </a:p>
           <a:p xmlns:a="http://schemas.openxmlformats.org/drawingml/2006/main">
             <a:pPr algn="l">
+              <a:buNone/>
               <a:defRPr sz="1650" b="0">
                 <a:solidFill>
                   <a:srgbClr val="5A5E55"/>
@@ -20611,6 +20832,7 @@
           </a:p>
           <a:p xmlns:a="http://schemas.openxmlformats.org/drawingml/2006/main">
             <a:pPr algn="l">
+              <a:buNone/>
               <a:defRPr sz="1650" b="0">
                 <a:solidFill>
                   <a:srgbClr val="5A5E55"/>
@@ -20665,14 +20887,14 @@
       </p:grpSpPr>
       <p:pic>
         <p:nvPicPr>
-          <p:cNvPr id="8" name=""/>
+          <p:cNvPr id="10" name=""/>
           <p:cNvPicPr>
             <a:picLocks xmlns:a="http://schemas.openxmlformats.org/drawingml/2006/main" noChangeAspect="1"/>
           </p:cNvPicPr>
           <p:nvPr/>
         </p:nvPicPr>
         <p:blipFill>
-          <a:blip xmlns:r="http://schemas.openxmlformats.org/officeDocument/2006/relationships" xmlns:a="http://schemas.openxmlformats.org/drawingml/2006/main" r:embed="Re5301947fa2646c9"/>
+          <a:blip xmlns:r="http://schemas.openxmlformats.org/officeDocument/2006/relationships" xmlns:a="http://schemas.openxmlformats.org/drawingml/2006/main" r:embed="R747527ef045540cb"/>
           <a:stretch xmlns:a="http://schemas.openxmlformats.org/drawingml/2006/main"/>
         </p:blipFill>
         <p:spPr>
@@ -20687,14 +20909,14 @@
       </p:pic>
       <p:pic>
         <p:nvPicPr>
-          <p:cNvPr id="9" name=""/>
+          <p:cNvPr id="11" name=""/>
           <p:cNvPicPr>
             <a:picLocks xmlns:a="http://schemas.openxmlformats.org/drawingml/2006/main" noChangeAspect="1"/>
           </p:cNvPicPr>
           <p:nvPr/>
         </p:nvPicPr>
         <p:blipFill>
-          <a:blip xmlns:r="http://schemas.openxmlformats.org/officeDocument/2006/relationships" xmlns:a="http://schemas.openxmlformats.org/drawingml/2006/main" r:embed="R90b32fe42a9e4e70"/>
+          <a:blip xmlns:r="http://schemas.openxmlformats.org/officeDocument/2006/relationships" xmlns:a="http://schemas.openxmlformats.org/drawingml/2006/main" r:embed="R332024dd5e784fa4"/>
           <a:stretch xmlns:a="http://schemas.openxmlformats.org/drawingml/2006/main"/>
         </p:blipFill>
         <p:spPr>
@@ -20742,6 +20964,7 @@
           <a:lstStyle xmlns:a="http://schemas.openxmlformats.org/drawingml/2006/main"/>
           <a:p xmlns:a="http://schemas.openxmlformats.org/drawingml/2006/main">
             <a:pPr algn="l">
+              <a:buNone/>
               <a:defRPr sz="3600" b="1">
                 <a:solidFill>
                   <a:srgbClr val="1F2A2A"/>
@@ -20831,6 +21054,7 @@
           <a:lstStyle xmlns:a="http://schemas.openxmlformats.org/drawingml/2006/main"/>
           <a:p xmlns:a="http://schemas.openxmlformats.org/drawingml/2006/main">
             <a:pPr algn="l">
+              <a:buNone/>
               <a:defRPr sz="1650" b="1">
                 <a:solidFill>
                   <a:srgbClr val="1F4FC9"/>
@@ -20889,6 +21113,7 @@
           <a:lstStyle xmlns:a="http://schemas.openxmlformats.org/drawingml/2006/main"/>
           <a:p xmlns:a="http://schemas.openxmlformats.org/drawingml/2006/main">
             <a:pPr algn="l">
+              <a:buNone/>
               <a:defRPr sz="3300" b="1">
                 <a:solidFill>
                   <a:srgbClr val="1F2A2A"/>
@@ -20947,6 +21172,7 @@
           <a:lstStyle xmlns:a="http://schemas.openxmlformats.org/drawingml/2006/main"/>
           <a:p xmlns:a="http://schemas.openxmlformats.org/drawingml/2006/main">
             <a:pPr algn="l">
+              <a:buNone/>
               <a:defRPr sz="1650" b="0">
                 <a:solidFill>
                   <a:srgbClr val="5A5E55"/>
@@ -20970,6 +21196,7 @@
           </a:p>
           <a:p xmlns:a="http://schemas.openxmlformats.org/drawingml/2006/main">
             <a:pPr algn="l">
+              <a:buNone/>
               <a:defRPr sz="1650" b="0">
                 <a:solidFill>
                   <a:srgbClr val="5A5E55"/>
@@ -20993,6 +21220,7 @@
           </a:p>
           <a:p xmlns:a="http://schemas.openxmlformats.org/drawingml/2006/main">
             <a:pPr algn="l">
+              <a:buNone/>
               <a:defRPr sz="1650" b="0">
                 <a:solidFill>
                   <a:srgbClr val="5A5E55"/>
@@ -21016,6 +21244,7 @@
           </a:p>
           <a:p xmlns:a="http://schemas.openxmlformats.org/drawingml/2006/main">
             <a:pPr algn="l">
+              <a:buNone/>
               <a:defRPr sz="1650" b="0">
                 <a:solidFill>
                   <a:srgbClr val="5A5E55"/>
@@ -21039,6 +21268,7 @@
           </a:p>
           <a:p xmlns:a="http://schemas.openxmlformats.org/drawingml/2006/main">
             <a:pPr algn="l">
+              <a:buNone/>
               <a:defRPr sz="1650" b="0">
                 <a:solidFill>
                   <a:srgbClr val="5A5E55"/>
@@ -21062,6 +21292,7 @@
           </a:p>
           <a:p xmlns:a="http://schemas.openxmlformats.org/drawingml/2006/main">
             <a:pPr algn="l">
+              <a:buNone/>
               <a:defRPr sz="1650" b="0">
                 <a:solidFill>
                   <a:srgbClr val="5A5E55"/>
@@ -21116,14 +21347,14 @@
       </p:grpSpPr>
       <p:pic>
         <p:nvPicPr>
-          <p:cNvPr id="8" name=""/>
+          <p:cNvPr id="10" name=""/>
           <p:cNvPicPr>
             <a:picLocks xmlns:a="http://schemas.openxmlformats.org/drawingml/2006/main" noChangeAspect="1"/>
           </p:cNvPicPr>
           <p:nvPr/>
         </p:nvPicPr>
         <p:blipFill>
-          <a:blip xmlns:r="http://schemas.openxmlformats.org/officeDocument/2006/relationships" xmlns:a="http://schemas.openxmlformats.org/drawingml/2006/main" r:embed="Rea36a8b70e534448"/>
+          <a:blip xmlns:r="http://schemas.openxmlformats.org/officeDocument/2006/relationships" xmlns:a="http://schemas.openxmlformats.org/drawingml/2006/main" r:embed="Rea6147da9b324d37"/>
           <a:stretch xmlns:a="http://schemas.openxmlformats.org/drawingml/2006/main"/>
         </p:blipFill>
         <p:spPr>
@@ -21138,14 +21369,14 @@
       </p:pic>
       <p:pic>
         <p:nvPicPr>
-          <p:cNvPr id="9" name=""/>
+          <p:cNvPr id="11" name=""/>
           <p:cNvPicPr>
             <a:picLocks xmlns:a="http://schemas.openxmlformats.org/drawingml/2006/main" noChangeAspect="1"/>
           </p:cNvPicPr>
           <p:nvPr/>
         </p:nvPicPr>
         <p:blipFill>
-          <a:blip xmlns:r="http://schemas.openxmlformats.org/officeDocument/2006/relationships" xmlns:a="http://schemas.openxmlformats.org/drawingml/2006/main" r:embed="R9ee9de6e3ff2483b"/>
+          <a:blip xmlns:r="http://schemas.openxmlformats.org/officeDocument/2006/relationships" xmlns:a="http://schemas.openxmlformats.org/drawingml/2006/main" r:embed="R22a721f16cd3426f"/>
           <a:stretch xmlns:a="http://schemas.openxmlformats.org/drawingml/2006/main"/>
         </p:blipFill>
         <p:spPr>
@@ -21193,6 +21424,7 @@
           <a:lstStyle xmlns:a="http://schemas.openxmlformats.org/drawingml/2006/main"/>
           <a:p xmlns:a="http://schemas.openxmlformats.org/drawingml/2006/main">
             <a:pPr algn="l">
+              <a:buNone/>
               <a:defRPr sz="3600" b="1">
                 <a:solidFill>
                   <a:srgbClr val="1F2A2A"/>
@@ -21282,6 +21514,7 @@
           <a:lstStyle xmlns:a="http://schemas.openxmlformats.org/drawingml/2006/main"/>
           <a:p xmlns:a="http://schemas.openxmlformats.org/drawingml/2006/main">
             <a:pPr algn="l">
+              <a:buNone/>
               <a:defRPr sz="1650" b="1">
                 <a:solidFill>
                   <a:srgbClr val="1F4FC9"/>
@@ -21340,6 +21573,7 @@
           <a:lstStyle xmlns:a="http://schemas.openxmlformats.org/drawingml/2006/main"/>
           <a:p xmlns:a="http://schemas.openxmlformats.org/drawingml/2006/main">
             <a:pPr algn="l">
+              <a:buNone/>
               <a:defRPr sz="3300" b="1">
                 <a:solidFill>
                   <a:srgbClr val="1F2A2A"/>
@@ -21398,6 +21632,7 @@
           <a:lstStyle xmlns:a="http://schemas.openxmlformats.org/drawingml/2006/main"/>
           <a:p xmlns:a="http://schemas.openxmlformats.org/drawingml/2006/main">
             <a:pPr algn="l">
+              <a:buNone/>
               <a:defRPr sz="1650" b="0">
                 <a:solidFill>
                   <a:srgbClr val="5A5E55"/>
@@ -21421,6 +21656,7 @@
           </a:p>
           <a:p xmlns:a="http://schemas.openxmlformats.org/drawingml/2006/main">
             <a:pPr algn="l">
+              <a:buNone/>
               <a:defRPr sz="1650" b="0">
                 <a:solidFill>
                   <a:srgbClr val="5A5E55"/>
@@ -21444,6 +21680,7 @@
           </a:p>
           <a:p xmlns:a="http://schemas.openxmlformats.org/drawingml/2006/main">
             <a:pPr algn="l">
+              <a:buNone/>
               <a:defRPr sz="1650" b="0">
                 <a:solidFill>
                   <a:srgbClr val="5A5E55"/>
@@ -21467,6 +21704,7 @@
           </a:p>
           <a:p xmlns:a="http://schemas.openxmlformats.org/drawingml/2006/main">
             <a:pPr algn="l">
+              <a:buNone/>
               <a:defRPr sz="1650" b="0">
                 <a:solidFill>
                   <a:srgbClr val="5A5E55"/>
@@ -21490,6 +21728,7 @@
           </a:p>
           <a:p xmlns:a="http://schemas.openxmlformats.org/drawingml/2006/main">
             <a:pPr algn="l">
+              <a:buNone/>
               <a:defRPr sz="1650" b="0">
                 <a:solidFill>
                   <a:srgbClr val="5A5E55"/>
@@ -21513,6 +21752,7 @@
           </a:p>
           <a:p xmlns:a="http://schemas.openxmlformats.org/drawingml/2006/main">
             <a:pPr algn="l">
+              <a:buNone/>
               <a:defRPr sz="1650" b="0">
                 <a:solidFill>
                   <a:srgbClr val="5A5E55"/>
@@ -21567,14 +21807,14 @@
       </p:grpSpPr>
       <p:pic>
         <p:nvPicPr>
-          <p:cNvPr id="21" name=""/>
+          <p:cNvPr id="23" name=""/>
           <p:cNvPicPr>
             <a:picLocks xmlns:a="http://schemas.openxmlformats.org/drawingml/2006/main" noChangeAspect="1"/>
           </p:cNvPicPr>
           <p:nvPr/>
         </p:nvPicPr>
         <p:blipFill>
-          <a:blip xmlns:r="http://schemas.openxmlformats.org/officeDocument/2006/relationships" xmlns:a="http://schemas.openxmlformats.org/drawingml/2006/main" r:embed="R5a8dd95f06364f7b"/>
+          <a:blip xmlns:r="http://schemas.openxmlformats.org/officeDocument/2006/relationships" xmlns:a="http://schemas.openxmlformats.org/drawingml/2006/main" r:embed="R9936ab8e44f5409f"/>
           <a:stretch xmlns:a="http://schemas.openxmlformats.org/drawingml/2006/main"/>
         </p:blipFill>
         <p:spPr>
@@ -21589,14 +21829,14 @@
       </p:pic>
       <p:pic>
         <p:nvPicPr>
-          <p:cNvPr id="22" name=""/>
+          <p:cNvPr id="24" name=""/>
           <p:cNvPicPr>
             <a:picLocks xmlns:a="http://schemas.openxmlformats.org/drawingml/2006/main" noChangeAspect="1"/>
           </p:cNvPicPr>
           <p:nvPr/>
         </p:nvPicPr>
         <p:blipFill>
-          <a:blip xmlns:r="http://schemas.openxmlformats.org/officeDocument/2006/relationships" xmlns:a="http://schemas.openxmlformats.org/drawingml/2006/main" r:embed="R65a19da756af4466"/>
+          <a:blip xmlns:r="http://schemas.openxmlformats.org/officeDocument/2006/relationships" xmlns:a="http://schemas.openxmlformats.org/drawingml/2006/main" r:embed="R51a2b139f5eb490a"/>
           <a:stretch xmlns:a="http://schemas.openxmlformats.org/drawingml/2006/main"/>
         </p:blipFill>
         <p:spPr>
@@ -21644,6 +21884,7 @@
           <a:lstStyle xmlns:a="http://schemas.openxmlformats.org/drawingml/2006/main"/>
           <a:p xmlns:a="http://schemas.openxmlformats.org/drawingml/2006/main">
             <a:pPr algn="l">
+              <a:buNone/>
               <a:defRPr sz="3600" b="1">
                 <a:solidFill>
                   <a:srgbClr val="1F2A2A"/>
@@ -21702,6 +21943,7 @@
           <a:lstStyle xmlns:a="http://schemas.openxmlformats.org/drawingml/2006/main"/>
           <a:p xmlns:a="http://schemas.openxmlformats.org/drawingml/2006/main">
             <a:pPr algn="l">
+              <a:buNone/>
               <a:defRPr sz="2400" b="1">
                 <a:solidFill>
                   <a:srgbClr val="5A5E55"/>
@@ -21795,6 +22037,7 @@
           <a:lstStyle xmlns:a="http://schemas.openxmlformats.org/drawingml/2006/main"/>
           <a:p xmlns:a="http://schemas.openxmlformats.org/drawingml/2006/main">
             <a:pPr algn="ctr">
+              <a:buNone/>
               <a:defRPr sz="1650" b="1">
                 <a:solidFill>
                   <a:srgbClr val="FFFFFF"/>
@@ -21853,6 +22096,7 @@
           <a:lstStyle xmlns:a="http://schemas.openxmlformats.org/drawingml/2006/main"/>
           <a:p xmlns:a="http://schemas.openxmlformats.org/drawingml/2006/main">
             <a:pPr algn="l">
+              <a:buNone/>
               <a:defRPr sz="2400" b="1">
                 <a:solidFill>
                   <a:srgbClr val="1F2A2A"/>
@@ -21915,6 +22159,7 @@
           <a:lstStyle xmlns:a="http://schemas.openxmlformats.org/drawingml/2006/main"/>
           <a:p xmlns:a="http://schemas.openxmlformats.org/drawingml/2006/main">
             <a:pPr algn="ctr">
+              <a:buNone/>
               <a:defRPr sz="1650" b="1">
                 <a:solidFill>
                   <a:srgbClr val="FFFFFF"/>
@@ -21973,6 +22218,7 @@
           <a:lstStyle xmlns:a="http://schemas.openxmlformats.org/drawingml/2006/main"/>
           <a:p xmlns:a="http://schemas.openxmlformats.org/drawingml/2006/main">
             <a:pPr algn="l">
+              <a:buNone/>
               <a:defRPr sz="2400" b="1">
                 <a:solidFill>
                   <a:srgbClr val="1F2A2A"/>
@@ -22035,6 +22281,7 @@
           <a:lstStyle xmlns:a="http://schemas.openxmlformats.org/drawingml/2006/main"/>
           <a:p xmlns:a="http://schemas.openxmlformats.org/drawingml/2006/main">
             <a:pPr algn="ctr">
+              <a:buNone/>
               <a:defRPr sz="1650" b="1">
                 <a:solidFill>
                   <a:srgbClr val="FFFFFF"/>
@@ -22093,6 +22340,7 @@
           <a:lstStyle xmlns:a="http://schemas.openxmlformats.org/drawingml/2006/main"/>
           <a:p xmlns:a="http://schemas.openxmlformats.org/drawingml/2006/main">
             <a:pPr algn="l">
+              <a:buNone/>
               <a:defRPr sz="2400" b="1">
                 <a:solidFill>
                   <a:srgbClr val="1F2A2A"/>
@@ -22155,6 +22403,7 @@
           <a:lstStyle xmlns:a="http://schemas.openxmlformats.org/drawingml/2006/main"/>
           <a:p xmlns:a="http://schemas.openxmlformats.org/drawingml/2006/main">
             <a:pPr algn="ctr">
+              <a:buNone/>
               <a:defRPr sz="1650" b="1">
                 <a:solidFill>
                   <a:srgbClr val="FFFFFF"/>
@@ -22213,6 +22462,7 @@
           <a:lstStyle xmlns:a="http://schemas.openxmlformats.org/drawingml/2006/main"/>
           <a:p xmlns:a="http://schemas.openxmlformats.org/drawingml/2006/main">
             <a:pPr algn="l">
+              <a:buNone/>
               <a:defRPr sz="2400" b="1">
                 <a:solidFill>
                   <a:srgbClr val="1F2A2A"/>
@@ -22275,6 +22525,7 @@
           <a:lstStyle xmlns:a="http://schemas.openxmlformats.org/drawingml/2006/main"/>
           <a:p xmlns:a="http://schemas.openxmlformats.org/drawingml/2006/main">
             <a:pPr algn="ctr">
+              <a:buNone/>
               <a:defRPr sz="1650" b="1">
                 <a:solidFill>
                   <a:srgbClr val="FFFFFF"/>
@@ -22333,6 +22584,7 @@
           <a:lstStyle xmlns:a="http://schemas.openxmlformats.org/drawingml/2006/main"/>
           <a:p xmlns:a="http://schemas.openxmlformats.org/drawingml/2006/main">
             <a:pPr algn="l">
+              <a:buNone/>
               <a:defRPr sz="2400" b="1">
                 <a:solidFill>
                   <a:srgbClr val="1F2A2A"/>
@@ -22395,6 +22647,7 @@
           <a:lstStyle xmlns:a="http://schemas.openxmlformats.org/drawingml/2006/main"/>
           <a:p xmlns:a="http://schemas.openxmlformats.org/drawingml/2006/main">
             <a:pPr algn="ctr">
+              <a:buNone/>
               <a:defRPr sz="1650" b="1">
                 <a:solidFill>
                   <a:srgbClr val="FFFFFF"/>
@@ -22453,6 +22706,7 @@
           <a:lstStyle xmlns:a="http://schemas.openxmlformats.org/drawingml/2006/main"/>
           <a:p xmlns:a="http://schemas.openxmlformats.org/drawingml/2006/main">
             <a:pPr algn="l">
+              <a:buNone/>
               <a:defRPr sz="2400" b="1">
                 <a:solidFill>
                   <a:srgbClr val="1F2A2A"/>
@@ -22515,6 +22769,7 @@
           <a:lstStyle xmlns:a="http://schemas.openxmlformats.org/drawingml/2006/main"/>
           <a:p xmlns:a="http://schemas.openxmlformats.org/drawingml/2006/main">
             <a:pPr algn="ctr">
+              <a:buNone/>
               <a:defRPr sz="1650" b="1">
                 <a:solidFill>
                   <a:srgbClr val="FFFFFF"/>
@@ -22573,6 +22828,7 @@
           <a:lstStyle xmlns:a="http://schemas.openxmlformats.org/drawingml/2006/main"/>
           <a:p xmlns:a="http://schemas.openxmlformats.org/drawingml/2006/main">
             <a:pPr algn="l">
+              <a:buNone/>
               <a:defRPr sz="2400" b="1">
                 <a:solidFill>
                   <a:srgbClr val="1F2A2A"/>
@@ -22633,6 +22889,7 @@
           <a:lstStyle xmlns:a="http://schemas.openxmlformats.org/drawingml/2006/main"/>
           <a:p xmlns:a="http://schemas.openxmlformats.org/drawingml/2006/main">
             <a:pPr algn="ctr">
+              <a:buNone/>
               <a:defRPr sz="1650" b="1">
                 <a:solidFill>
                   <a:srgbClr val="1F4FC9"/>
@@ -22687,14 +22944,14 @@
       </p:grpSpPr>
       <p:pic>
         <p:nvPicPr>
-          <p:cNvPr id="8" name=""/>
+          <p:cNvPr id="10" name=""/>
           <p:cNvPicPr>
             <a:picLocks xmlns:a="http://schemas.openxmlformats.org/drawingml/2006/main" noChangeAspect="1"/>
           </p:cNvPicPr>
           <p:nvPr/>
         </p:nvPicPr>
         <p:blipFill>
-          <a:blip xmlns:r="http://schemas.openxmlformats.org/officeDocument/2006/relationships" xmlns:a="http://schemas.openxmlformats.org/drawingml/2006/main" r:embed="R0ceab68d2ac84232"/>
+          <a:blip xmlns:r="http://schemas.openxmlformats.org/officeDocument/2006/relationships" xmlns:a="http://schemas.openxmlformats.org/drawingml/2006/main" r:embed="Re4199244ee9c47d3"/>
           <a:stretch xmlns:a="http://schemas.openxmlformats.org/drawingml/2006/main"/>
         </p:blipFill>
         <p:spPr>
@@ -22709,14 +22966,14 @@
       </p:pic>
       <p:pic>
         <p:nvPicPr>
-          <p:cNvPr id="9" name=""/>
+          <p:cNvPr id="11" name=""/>
           <p:cNvPicPr>
             <a:picLocks xmlns:a="http://schemas.openxmlformats.org/drawingml/2006/main" noChangeAspect="1"/>
           </p:cNvPicPr>
           <p:nvPr/>
         </p:nvPicPr>
         <p:blipFill>
-          <a:blip xmlns:r="http://schemas.openxmlformats.org/officeDocument/2006/relationships" xmlns:a="http://schemas.openxmlformats.org/drawingml/2006/main" r:embed="R0f178eba76fe47cf"/>
+          <a:blip xmlns:r="http://schemas.openxmlformats.org/officeDocument/2006/relationships" xmlns:a="http://schemas.openxmlformats.org/drawingml/2006/main" r:embed="Rfdaffbfa5ea14613"/>
           <a:stretch xmlns:a="http://schemas.openxmlformats.org/drawingml/2006/main"/>
         </p:blipFill>
         <p:spPr>
@@ -22764,6 +23021,7 @@
           <a:lstStyle xmlns:a="http://schemas.openxmlformats.org/drawingml/2006/main"/>
           <a:p xmlns:a="http://schemas.openxmlformats.org/drawingml/2006/main">
             <a:pPr algn="l">
+              <a:buNone/>
               <a:defRPr sz="3600" b="1">
                 <a:solidFill>
                   <a:srgbClr val="1F2A2A"/>
@@ -22853,6 +23111,7 @@
           <a:lstStyle xmlns:a="http://schemas.openxmlformats.org/drawingml/2006/main"/>
           <a:p xmlns:a="http://schemas.openxmlformats.org/drawingml/2006/main">
             <a:pPr algn="l">
+              <a:buNone/>
               <a:defRPr sz="1650" b="1">
                 <a:solidFill>
                   <a:srgbClr val="1F4FC9"/>
@@ -22911,6 +23170,7 @@
           <a:lstStyle xmlns:a="http://schemas.openxmlformats.org/drawingml/2006/main"/>
           <a:p xmlns:a="http://schemas.openxmlformats.org/drawingml/2006/main">
             <a:pPr algn="l">
+              <a:buNone/>
               <a:defRPr sz="3300" b="1">
                 <a:solidFill>
                   <a:srgbClr val="1F2A2A"/>
@@ -22969,6 +23229,7 @@
           <a:lstStyle xmlns:a="http://schemas.openxmlformats.org/drawingml/2006/main"/>
           <a:p xmlns:a="http://schemas.openxmlformats.org/drawingml/2006/main">
             <a:pPr algn="l">
+              <a:buNone/>
               <a:defRPr sz="1650" b="0">
                 <a:solidFill>
                   <a:srgbClr val="5A5E55"/>
@@ -22992,6 +23253,7 @@
           </a:p>
           <a:p xmlns:a="http://schemas.openxmlformats.org/drawingml/2006/main">
             <a:pPr algn="l">
+              <a:buNone/>
               <a:defRPr sz="1650" b="0">
                 <a:solidFill>
                   <a:srgbClr val="5A5E55"/>
@@ -23015,6 +23277,7 @@
           </a:p>
           <a:p xmlns:a="http://schemas.openxmlformats.org/drawingml/2006/main">
             <a:pPr algn="l">
+              <a:buNone/>
               <a:defRPr sz="1650" b="0">
                 <a:solidFill>
                   <a:srgbClr val="5A5E55"/>
@@ -23038,6 +23301,7 @@
           </a:p>
           <a:p xmlns:a="http://schemas.openxmlformats.org/drawingml/2006/main">
             <a:pPr algn="l">
+              <a:buNone/>
               <a:defRPr sz="1650" b="0">
                 <a:solidFill>
                   <a:srgbClr val="5A5E55"/>
@@ -23061,6 +23325,7 @@
           </a:p>
           <a:p xmlns:a="http://schemas.openxmlformats.org/drawingml/2006/main">
             <a:pPr algn="l">
+              <a:buNone/>
               <a:defRPr sz="1650" b="0">
                 <a:solidFill>
                   <a:srgbClr val="5A5E55"/>
@@ -23084,6 +23349,7 @@
           </a:p>
           <a:p xmlns:a="http://schemas.openxmlformats.org/drawingml/2006/main">
             <a:pPr algn="l">
+              <a:buNone/>
               <a:defRPr sz="1650" b="0">
                 <a:solidFill>
                   <a:srgbClr val="5A5E55"/>
@@ -23107,6 +23373,7 @@
           </a:p>
           <a:p xmlns:a="http://schemas.openxmlformats.org/drawingml/2006/main">
             <a:pPr algn="l">
+              <a:buNone/>
               <a:defRPr sz="1650" b="0">
                 <a:solidFill>
                   <a:srgbClr val="5A5E55"/>
@@ -23130,6 +23397,7 @@
           </a:p>
           <a:p xmlns:a="http://schemas.openxmlformats.org/drawingml/2006/main">
             <a:pPr algn="l">
+              <a:buNone/>
               <a:defRPr sz="1650" b="0">
                 <a:solidFill>
                   <a:srgbClr val="5A5E55"/>
@@ -23184,14 +23452,14 @@
       </p:grpSpPr>
       <p:pic>
         <p:nvPicPr>
-          <p:cNvPr id="8" name=""/>
+          <p:cNvPr id="10" name=""/>
           <p:cNvPicPr>
             <a:picLocks xmlns:a="http://schemas.openxmlformats.org/drawingml/2006/main" noChangeAspect="1"/>
           </p:cNvPicPr>
           <p:nvPr/>
         </p:nvPicPr>
         <p:blipFill>
-          <a:blip xmlns:r="http://schemas.openxmlformats.org/officeDocument/2006/relationships" xmlns:a="http://schemas.openxmlformats.org/drawingml/2006/main" r:embed="R3edd1542ef054474"/>
+          <a:blip xmlns:r="http://schemas.openxmlformats.org/officeDocument/2006/relationships" xmlns:a="http://schemas.openxmlformats.org/drawingml/2006/main" r:embed="Rfc27ae1266a14def"/>
           <a:stretch xmlns:a="http://schemas.openxmlformats.org/drawingml/2006/main"/>
         </p:blipFill>
         <p:spPr>
@@ -23206,14 +23474,14 @@
       </p:pic>
       <p:pic>
         <p:nvPicPr>
-          <p:cNvPr id="9" name=""/>
+          <p:cNvPr id="11" name=""/>
           <p:cNvPicPr>
             <a:picLocks xmlns:a="http://schemas.openxmlformats.org/drawingml/2006/main" noChangeAspect="1"/>
           </p:cNvPicPr>
           <p:nvPr/>
         </p:nvPicPr>
         <p:blipFill>
-          <a:blip xmlns:r="http://schemas.openxmlformats.org/officeDocument/2006/relationships" xmlns:a="http://schemas.openxmlformats.org/drawingml/2006/main" r:embed="R08aef1d2743344a1"/>
+          <a:blip xmlns:r="http://schemas.openxmlformats.org/officeDocument/2006/relationships" xmlns:a="http://schemas.openxmlformats.org/drawingml/2006/main" r:embed="R8a915f9ed4b545e7"/>
           <a:stretch xmlns:a="http://schemas.openxmlformats.org/drawingml/2006/main"/>
         </p:blipFill>
         <p:spPr>
@@ -23261,6 +23529,7 @@
           <a:lstStyle xmlns:a="http://schemas.openxmlformats.org/drawingml/2006/main"/>
           <a:p xmlns:a="http://schemas.openxmlformats.org/drawingml/2006/main">
             <a:pPr algn="l">
+              <a:buNone/>
               <a:defRPr sz="3600" b="1">
                 <a:solidFill>
                   <a:srgbClr val="F6F2EA"/>
@@ -23319,6 +23588,7 @@
           <a:lstStyle xmlns:a="http://schemas.openxmlformats.org/drawingml/2006/main"/>
           <a:p xmlns:a="http://schemas.openxmlformats.org/drawingml/2006/main">
             <a:pPr algn="l">
+              <a:buNone/>
               <a:defRPr sz="3300" b="1">
                 <a:solidFill>
                   <a:srgbClr val="F6F2EA"/>
@@ -23377,6 +23647,7 @@
           <a:lstStyle xmlns:a="http://schemas.openxmlformats.org/drawingml/2006/main"/>
           <a:p xmlns:a="http://schemas.openxmlformats.org/drawingml/2006/main">
             <a:pPr algn="l">
+              <a:buNone/>
               <a:defRPr sz="1650" b="0">
                 <a:solidFill>
                   <a:srgbClr val="D9DDD5"/>
@@ -23400,6 +23671,7 @@
           </a:p>
           <a:p xmlns:a="http://schemas.openxmlformats.org/drawingml/2006/main">
             <a:pPr algn="l">
+              <a:buNone/>
               <a:defRPr sz="1650" b="0">
                 <a:solidFill>
                   <a:srgbClr val="D9DDD5"/>
@@ -23423,6 +23695,7 @@
           </a:p>
           <a:p xmlns:a="http://schemas.openxmlformats.org/drawingml/2006/main">
             <a:pPr algn="l">
+              <a:buNone/>
               <a:defRPr sz="1650" b="0">
                 <a:solidFill>
                   <a:srgbClr val="D9DDD5"/>
@@ -23446,6 +23719,7 @@
           </a:p>
           <a:p xmlns:a="http://schemas.openxmlformats.org/drawingml/2006/main">
             <a:pPr algn="l">
+              <a:buNone/>
               <a:defRPr sz="1650" b="0">
                 <a:solidFill>
                   <a:srgbClr val="D9DDD5"/>
@@ -23535,6 +23809,7 @@
           <a:lstStyle xmlns:a="http://schemas.openxmlformats.org/drawingml/2006/main"/>
           <a:p xmlns:a="http://schemas.openxmlformats.org/drawingml/2006/main">
             <a:pPr algn="l">
+              <a:buNone/>
               <a:defRPr sz="2400" b="1">
                 <a:solidFill>
                   <a:srgbClr val="FFFFFF"/>
@@ -23589,14 +23864,14 @@
       </p:grpSpPr>
       <p:pic>
         <p:nvPicPr>
-          <p:cNvPr id="17" name=""/>
+          <p:cNvPr id="19" name=""/>
           <p:cNvPicPr>
             <a:picLocks xmlns:a="http://schemas.openxmlformats.org/drawingml/2006/main" noChangeAspect="1"/>
           </p:cNvPicPr>
           <p:nvPr/>
         </p:nvPicPr>
         <p:blipFill>
-          <a:blip xmlns:r="http://schemas.openxmlformats.org/officeDocument/2006/relationships" xmlns:a="http://schemas.openxmlformats.org/drawingml/2006/main" r:embed="R1dc2181b541b43db"/>
+          <a:blip xmlns:r="http://schemas.openxmlformats.org/officeDocument/2006/relationships" xmlns:a="http://schemas.openxmlformats.org/drawingml/2006/main" r:embed="R85191b624cf443e2"/>
           <a:stretch xmlns:a="http://schemas.openxmlformats.org/drawingml/2006/main"/>
         </p:blipFill>
         <p:spPr>
@@ -23611,14 +23886,14 @@
       </p:pic>
       <p:pic>
         <p:nvPicPr>
-          <p:cNvPr id="18" name=""/>
+          <p:cNvPr id="20" name=""/>
           <p:cNvPicPr>
             <a:picLocks xmlns:a="http://schemas.openxmlformats.org/drawingml/2006/main" noChangeAspect="1"/>
           </p:cNvPicPr>
           <p:nvPr/>
         </p:nvPicPr>
         <p:blipFill>
-          <a:blip xmlns:r="http://schemas.openxmlformats.org/officeDocument/2006/relationships" xmlns:a="http://schemas.openxmlformats.org/drawingml/2006/main" r:embed="R5fb59ececdc84880"/>
+          <a:blip xmlns:r="http://schemas.openxmlformats.org/officeDocument/2006/relationships" xmlns:a="http://schemas.openxmlformats.org/drawingml/2006/main" r:embed="R72af174a6e9e4d0b"/>
           <a:stretch xmlns:a="http://schemas.openxmlformats.org/drawingml/2006/main"/>
         </p:blipFill>
         <p:spPr>
@@ -23666,6 +23941,7 @@
           <a:lstStyle xmlns:a="http://schemas.openxmlformats.org/drawingml/2006/main"/>
           <a:p xmlns:a="http://schemas.openxmlformats.org/drawingml/2006/main">
             <a:pPr algn="l">
+              <a:buNone/>
               <a:defRPr sz="3600" b="1">
                 <a:solidFill>
                   <a:srgbClr val="F6F2EA"/>
@@ -23724,6 +24000,7 @@
           <a:lstStyle xmlns:a="http://schemas.openxmlformats.org/drawingml/2006/main"/>
           <a:p xmlns:a="http://schemas.openxmlformats.org/drawingml/2006/main">
             <a:pPr algn="l">
+              <a:buNone/>
               <a:defRPr sz="3300" b="1">
                 <a:solidFill>
                   <a:srgbClr val="F6F2EA"/>
@@ -23782,6 +24059,7 @@
           <a:lstStyle xmlns:a="http://schemas.openxmlformats.org/drawingml/2006/main"/>
           <a:p xmlns:a="http://schemas.openxmlformats.org/drawingml/2006/main">
             <a:pPr algn="l">
+              <a:buNone/>
               <a:defRPr sz="2400" b="1">
                 <a:solidFill>
                   <a:srgbClr val="D9DDD5"/>
@@ -23840,6 +24118,7 @@
           <a:lstStyle xmlns:a="http://schemas.openxmlformats.org/drawingml/2006/main"/>
           <a:p xmlns:a="http://schemas.openxmlformats.org/drawingml/2006/main">
             <a:pPr algn="l">
+              <a:buNone/>
               <a:defRPr sz="1650" b="0">
                 <a:solidFill>
                   <a:srgbClr val="F6F2EA"/>
@@ -23898,6 +24177,7 @@
           <a:lstStyle xmlns:a="http://schemas.openxmlformats.org/drawingml/2006/main"/>
           <a:p xmlns:a="http://schemas.openxmlformats.org/drawingml/2006/main">
             <a:pPr algn="l">
+              <a:buNone/>
               <a:defRPr sz="2400" b="1">
                 <a:solidFill>
                   <a:srgbClr val="D9DDD5"/>
@@ -23956,6 +24236,7 @@
           <a:lstStyle xmlns:a="http://schemas.openxmlformats.org/drawingml/2006/main"/>
           <a:p xmlns:a="http://schemas.openxmlformats.org/drawingml/2006/main">
             <a:pPr algn="l">
+              <a:buNone/>
               <a:defRPr sz="1650" b="0">
                 <a:solidFill>
                   <a:srgbClr val="F6F2EA"/>
@@ -24014,6 +24295,7 @@
           <a:lstStyle xmlns:a="http://schemas.openxmlformats.org/drawingml/2006/main"/>
           <a:p xmlns:a="http://schemas.openxmlformats.org/drawingml/2006/main">
             <a:pPr algn="l">
+              <a:buNone/>
               <a:defRPr sz="2400" b="1">
                 <a:solidFill>
                   <a:srgbClr val="D9DDD5"/>
@@ -24072,6 +24354,7 @@
           <a:lstStyle xmlns:a="http://schemas.openxmlformats.org/drawingml/2006/main"/>
           <a:p xmlns:a="http://schemas.openxmlformats.org/drawingml/2006/main">
             <a:pPr algn="l">
+              <a:buNone/>
               <a:defRPr sz="1650" b="0">
                 <a:solidFill>
                   <a:srgbClr val="F6F2EA"/>
@@ -24130,6 +24413,7 @@
           <a:lstStyle xmlns:a="http://schemas.openxmlformats.org/drawingml/2006/main"/>
           <a:p xmlns:a="http://schemas.openxmlformats.org/drawingml/2006/main">
             <a:pPr algn="l">
+              <a:buNone/>
               <a:defRPr sz="2400" b="1">
                 <a:solidFill>
                   <a:srgbClr val="D9DDD5"/>
@@ -24188,6 +24472,7 @@
           <a:lstStyle xmlns:a="http://schemas.openxmlformats.org/drawingml/2006/main"/>
           <a:p xmlns:a="http://schemas.openxmlformats.org/drawingml/2006/main">
             <a:pPr algn="l">
+              <a:buNone/>
               <a:defRPr sz="1650" b="0">
                 <a:solidFill>
                   <a:srgbClr val="F6F2EA"/>
@@ -24246,6 +24531,7 @@
           <a:lstStyle xmlns:a="http://schemas.openxmlformats.org/drawingml/2006/main"/>
           <a:p xmlns:a="http://schemas.openxmlformats.org/drawingml/2006/main">
             <a:pPr algn="l">
+              <a:buNone/>
               <a:defRPr sz="2400" b="1">
                 <a:solidFill>
                   <a:srgbClr val="D9DDD5"/>
@@ -24304,6 +24590,7 @@
           <a:lstStyle xmlns:a="http://schemas.openxmlformats.org/drawingml/2006/main"/>
           <a:p xmlns:a="http://schemas.openxmlformats.org/drawingml/2006/main">
             <a:pPr algn="l">
+              <a:buNone/>
               <a:defRPr sz="1650" b="0">
                 <a:solidFill>
                   <a:srgbClr val="F6F2EA"/>
@@ -24362,6 +24649,7 @@
           <a:lstStyle xmlns:a="http://schemas.openxmlformats.org/drawingml/2006/main"/>
           <a:p xmlns:a="http://schemas.openxmlformats.org/drawingml/2006/main">
             <a:pPr algn="l">
+              <a:buNone/>
               <a:defRPr sz="2400" b="1">
                 <a:solidFill>
                   <a:srgbClr val="D9DDD5"/>
@@ -24420,6 +24708,7 @@
           <a:lstStyle xmlns:a="http://schemas.openxmlformats.org/drawingml/2006/main"/>
           <a:p xmlns:a="http://schemas.openxmlformats.org/drawingml/2006/main">
             <a:pPr algn="l">
+              <a:buNone/>
               <a:defRPr sz="1650" b="0">
                 <a:solidFill>
                   <a:srgbClr val="F6F2EA"/>
@@ -24474,14 +24763,14 @@
       </p:grpSpPr>
       <p:pic>
         <p:nvPicPr>
-          <p:cNvPr id="8" name=""/>
+          <p:cNvPr id="10" name=""/>
           <p:cNvPicPr>
             <a:picLocks xmlns:a="http://schemas.openxmlformats.org/drawingml/2006/main" noChangeAspect="1"/>
           </p:cNvPicPr>
           <p:nvPr/>
         </p:nvPicPr>
         <p:blipFill>
-          <a:blip xmlns:r="http://schemas.openxmlformats.org/officeDocument/2006/relationships" xmlns:a="http://schemas.openxmlformats.org/drawingml/2006/main" r:embed="R2f0aa8e39126404c"/>
+          <a:blip xmlns:r="http://schemas.openxmlformats.org/officeDocument/2006/relationships" xmlns:a="http://schemas.openxmlformats.org/drawingml/2006/main" r:embed="R462ab552fc0c4a8a"/>
           <a:stretch xmlns:a="http://schemas.openxmlformats.org/drawingml/2006/main"/>
         </p:blipFill>
         <p:spPr>
@@ -24496,14 +24785,14 @@
       </p:pic>
       <p:pic>
         <p:nvPicPr>
-          <p:cNvPr id="9" name=""/>
+          <p:cNvPr id="11" name=""/>
           <p:cNvPicPr>
             <a:picLocks xmlns:a="http://schemas.openxmlformats.org/drawingml/2006/main" noChangeAspect="1"/>
           </p:cNvPicPr>
           <p:nvPr/>
         </p:nvPicPr>
         <p:blipFill>
-          <a:blip xmlns:r="http://schemas.openxmlformats.org/officeDocument/2006/relationships" xmlns:a="http://schemas.openxmlformats.org/drawingml/2006/main" r:embed="Rdff598ee077845fa"/>
+          <a:blip xmlns:r="http://schemas.openxmlformats.org/officeDocument/2006/relationships" xmlns:a="http://schemas.openxmlformats.org/drawingml/2006/main" r:embed="Rfc7c92ca46774cc5"/>
           <a:stretch xmlns:a="http://schemas.openxmlformats.org/drawingml/2006/main"/>
         </p:blipFill>
         <p:spPr>
@@ -24551,6 +24840,7 @@
           <a:lstStyle xmlns:a="http://schemas.openxmlformats.org/drawingml/2006/main"/>
           <a:p xmlns:a="http://schemas.openxmlformats.org/drawingml/2006/main">
             <a:pPr algn="l">
+              <a:buNone/>
               <a:defRPr sz="3600" b="1">
                 <a:solidFill>
                   <a:srgbClr val="1F2A2A"/>
@@ -24640,6 +24930,7 @@
           <a:lstStyle xmlns:a="http://schemas.openxmlformats.org/drawingml/2006/main"/>
           <a:p xmlns:a="http://schemas.openxmlformats.org/drawingml/2006/main">
             <a:pPr algn="l">
+              <a:buNone/>
               <a:defRPr sz="1650" b="1">
                 <a:solidFill>
                   <a:srgbClr val="1F4FC9"/>
@@ -24698,6 +24989,7 @@
           <a:lstStyle xmlns:a="http://schemas.openxmlformats.org/drawingml/2006/main"/>
           <a:p xmlns:a="http://schemas.openxmlformats.org/drawingml/2006/main">
             <a:pPr algn="l">
+              <a:buNone/>
               <a:defRPr sz="3300" b="1">
                 <a:solidFill>
                   <a:srgbClr val="1F2A2A"/>
@@ -24756,6 +25048,7 @@
           <a:lstStyle xmlns:a="http://schemas.openxmlformats.org/drawingml/2006/main"/>
           <a:p xmlns:a="http://schemas.openxmlformats.org/drawingml/2006/main">
             <a:pPr algn="l">
+              <a:buNone/>
               <a:defRPr sz="1650" b="0">
                 <a:solidFill>
                   <a:srgbClr val="5A5E55"/>
@@ -24779,6 +25072,7 @@
           </a:p>
           <a:p xmlns:a="http://schemas.openxmlformats.org/drawingml/2006/main">
             <a:pPr algn="l">
+              <a:buNone/>
               <a:defRPr sz="1650" b="0">
                 <a:solidFill>
                   <a:srgbClr val="5A5E55"/>
@@ -24802,6 +25096,7 @@
           </a:p>
           <a:p xmlns:a="http://schemas.openxmlformats.org/drawingml/2006/main">
             <a:pPr algn="l">
+              <a:buNone/>
               <a:defRPr sz="1650" b="0">
                 <a:solidFill>
                   <a:srgbClr val="5A5E55"/>
@@ -24856,14 +25151,14 @@
       </p:grpSpPr>
       <p:pic>
         <p:nvPicPr>
-          <p:cNvPr id="8" name=""/>
+          <p:cNvPr id="10" name=""/>
           <p:cNvPicPr>
             <a:picLocks xmlns:a="http://schemas.openxmlformats.org/drawingml/2006/main" noChangeAspect="1"/>
           </p:cNvPicPr>
           <p:nvPr/>
         </p:nvPicPr>
         <p:blipFill>
-          <a:blip xmlns:r="http://schemas.openxmlformats.org/officeDocument/2006/relationships" xmlns:a="http://schemas.openxmlformats.org/drawingml/2006/main" r:embed="Rad6a59ae16c54997"/>
+          <a:blip xmlns:r="http://schemas.openxmlformats.org/officeDocument/2006/relationships" xmlns:a="http://schemas.openxmlformats.org/drawingml/2006/main" r:embed="R96efead14035414c"/>
           <a:stretch xmlns:a="http://schemas.openxmlformats.org/drawingml/2006/main"/>
         </p:blipFill>
         <p:spPr>
@@ -24878,14 +25173,14 @@
       </p:pic>
       <p:pic>
         <p:nvPicPr>
-          <p:cNvPr id="9" name=""/>
+          <p:cNvPr id="11" name=""/>
           <p:cNvPicPr>
             <a:picLocks xmlns:a="http://schemas.openxmlformats.org/drawingml/2006/main" noChangeAspect="1"/>
           </p:cNvPicPr>
           <p:nvPr/>
         </p:nvPicPr>
         <p:blipFill>
-          <a:blip xmlns:r="http://schemas.openxmlformats.org/officeDocument/2006/relationships" xmlns:a="http://schemas.openxmlformats.org/drawingml/2006/main" r:embed="R20d33bcafa574fea"/>
+          <a:blip xmlns:r="http://schemas.openxmlformats.org/officeDocument/2006/relationships" xmlns:a="http://schemas.openxmlformats.org/drawingml/2006/main" r:embed="R9a2705a6b60a4549"/>
           <a:stretch xmlns:a="http://schemas.openxmlformats.org/drawingml/2006/main"/>
         </p:blipFill>
         <p:spPr>
@@ -24933,6 +25228,7 @@
           <a:lstStyle xmlns:a="http://schemas.openxmlformats.org/drawingml/2006/main"/>
           <a:p xmlns:a="http://schemas.openxmlformats.org/drawingml/2006/main">
             <a:pPr algn="l">
+              <a:buNone/>
               <a:defRPr sz="3600" b="1">
                 <a:solidFill>
                   <a:srgbClr val="1F2A2A"/>
@@ -24991,6 +25287,7 @@
           <a:lstStyle xmlns:a="http://schemas.openxmlformats.org/drawingml/2006/main"/>
           <a:p xmlns:a="http://schemas.openxmlformats.org/drawingml/2006/main">
             <a:pPr algn="l">
+              <a:buNone/>
               <a:defRPr sz="3300" b="1">
                 <a:solidFill>
                   <a:srgbClr val="1F2A2A"/>
@@ -25049,6 +25346,7 @@
           <a:lstStyle xmlns:a="http://schemas.openxmlformats.org/drawingml/2006/main"/>
           <a:p xmlns:a="http://schemas.openxmlformats.org/drawingml/2006/main">
             <a:pPr algn="l">
+              <a:buNone/>
               <a:defRPr sz="1650" b="0">
                 <a:solidFill>
                   <a:srgbClr val="5A5E55"/>
@@ -25138,6 +25436,7 @@
           <a:lstStyle xmlns:a="http://schemas.openxmlformats.org/drawingml/2006/main"/>
           <a:p xmlns:a="http://schemas.openxmlformats.org/drawingml/2006/main">
             <a:pPr algn="l">
+              <a:buNone/>
               <a:defRPr sz="2400" b="1">
                 <a:solidFill>
                   <a:srgbClr val="1F2A2A"/>
@@ -25192,14 +25491,14 @@
       </p:grpSpPr>
       <p:pic>
         <p:nvPicPr>
-          <p:cNvPr id="14" name=""/>
+          <p:cNvPr id="16" name=""/>
           <p:cNvPicPr>
             <a:picLocks xmlns:a="http://schemas.openxmlformats.org/drawingml/2006/main" noChangeAspect="1"/>
           </p:cNvPicPr>
           <p:nvPr/>
         </p:nvPicPr>
         <p:blipFill>
-          <a:blip xmlns:r="http://schemas.openxmlformats.org/officeDocument/2006/relationships" xmlns:a="http://schemas.openxmlformats.org/drawingml/2006/main" r:embed="R613b655e366d4fb8"/>
+          <a:blip xmlns:r="http://schemas.openxmlformats.org/officeDocument/2006/relationships" xmlns:a="http://schemas.openxmlformats.org/drawingml/2006/main" r:embed="R64726d3b370e4cff"/>
           <a:stretch xmlns:a="http://schemas.openxmlformats.org/drawingml/2006/main"/>
         </p:blipFill>
         <p:spPr>
@@ -25214,14 +25513,14 @@
       </p:pic>
       <p:pic>
         <p:nvPicPr>
-          <p:cNvPr id="15" name=""/>
+          <p:cNvPr id="17" name=""/>
           <p:cNvPicPr>
             <a:picLocks xmlns:a="http://schemas.openxmlformats.org/drawingml/2006/main" noChangeAspect="1"/>
           </p:cNvPicPr>
           <p:nvPr/>
         </p:nvPicPr>
         <p:blipFill>
-          <a:blip xmlns:r="http://schemas.openxmlformats.org/officeDocument/2006/relationships" xmlns:a="http://schemas.openxmlformats.org/drawingml/2006/main" r:embed="Rbf995e79ce824b85"/>
+          <a:blip xmlns:r="http://schemas.openxmlformats.org/officeDocument/2006/relationships" xmlns:a="http://schemas.openxmlformats.org/drawingml/2006/main" r:embed="R42be97aaec67435f"/>
           <a:stretch xmlns:a="http://schemas.openxmlformats.org/drawingml/2006/main"/>
         </p:blipFill>
         <p:spPr>
@@ -25269,6 +25568,7 @@
           <a:lstStyle xmlns:a="http://schemas.openxmlformats.org/drawingml/2006/main"/>
           <a:p xmlns:a="http://schemas.openxmlformats.org/drawingml/2006/main">
             <a:pPr algn="l">
+              <a:buNone/>
               <a:defRPr sz="3600" b="1">
                 <a:solidFill>
                   <a:srgbClr val="1F2A2A"/>
@@ -25327,6 +25627,7 @@
           <a:lstStyle xmlns:a="http://schemas.openxmlformats.org/drawingml/2006/main"/>
           <a:p xmlns:a="http://schemas.openxmlformats.org/drawingml/2006/main">
             <a:pPr algn="l">
+              <a:buNone/>
               <a:defRPr sz="2400" b="1">
                 <a:solidFill>
                   <a:srgbClr val="5A5E55"/>
@@ -25385,6 +25686,7 @@
           <a:lstStyle xmlns:a="http://schemas.openxmlformats.org/drawingml/2006/main"/>
           <a:p xmlns:a="http://schemas.openxmlformats.org/drawingml/2006/main">
             <a:pPr algn="l">
+              <a:buNone/>
               <a:defRPr sz="1650" b="1">
                 <a:solidFill>
                   <a:srgbClr val="1F4FC9"/>
@@ -25474,6 +25776,7 @@
           <a:lstStyle xmlns:a="http://schemas.openxmlformats.org/drawingml/2006/main"/>
           <a:p xmlns:a="http://schemas.openxmlformats.org/drawingml/2006/main">
             <a:pPr algn="l">
+              <a:buNone/>
               <a:defRPr sz="1650" b="1">
                 <a:solidFill>
                   <a:srgbClr val="1F2A2A"/>
@@ -25532,6 +25835,7 @@
           <a:lstStyle xmlns:a="http://schemas.openxmlformats.org/drawingml/2006/main"/>
           <a:p xmlns:a="http://schemas.openxmlformats.org/drawingml/2006/main">
             <a:pPr algn="l">
+              <a:buNone/>
               <a:defRPr sz="1650" b="1">
                 <a:solidFill>
                   <a:srgbClr val="1F4FC9"/>
@@ -25621,6 +25925,7 @@
           <a:lstStyle xmlns:a="http://schemas.openxmlformats.org/drawingml/2006/main"/>
           <a:p xmlns:a="http://schemas.openxmlformats.org/drawingml/2006/main">
             <a:pPr algn="l">
+              <a:buNone/>
               <a:defRPr sz="1650" b="1">
                 <a:solidFill>
                   <a:srgbClr val="1F2A2A"/>
@@ -25679,6 +25984,7 @@
           <a:lstStyle xmlns:a="http://schemas.openxmlformats.org/drawingml/2006/main"/>
           <a:p xmlns:a="http://schemas.openxmlformats.org/drawingml/2006/main">
             <a:pPr algn="l">
+              <a:buNone/>
               <a:defRPr sz="1650" b="1">
                 <a:solidFill>
                   <a:srgbClr val="1F4FC9"/>
@@ -25768,6 +26074,7 @@
           <a:lstStyle xmlns:a="http://schemas.openxmlformats.org/drawingml/2006/main"/>
           <a:p xmlns:a="http://schemas.openxmlformats.org/drawingml/2006/main">
             <a:pPr algn="l">
+              <a:buNone/>
               <a:defRPr sz="1650" b="0">
                 <a:solidFill>
                   <a:srgbClr val="1F2A2A"/>
@@ -25822,14 +26129,14 @@
       </p:grpSpPr>
       <p:pic>
         <p:nvPicPr>
-          <p:cNvPr id="16" name=""/>
+          <p:cNvPr id="18" name=""/>
           <p:cNvPicPr>
             <a:picLocks xmlns:a="http://schemas.openxmlformats.org/drawingml/2006/main" noChangeAspect="1"/>
           </p:cNvPicPr>
           <p:nvPr/>
         </p:nvPicPr>
         <p:blipFill>
-          <a:blip xmlns:r="http://schemas.openxmlformats.org/officeDocument/2006/relationships" xmlns:a="http://schemas.openxmlformats.org/drawingml/2006/main" r:embed="R59bd3ff4693447f0"/>
+          <a:blip xmlns:r="http://schemas.openxmlformats.org/officeDocument/2006/relationships" xmlns:a="http://schemas.openxmlformats.org/drawingml/2006/main" r:embed="R1483c9f927904c44"/>
           <a:stretch xmlns:a="http://schemas.openxmlformats.org/drawingml/2006/main"/>
         </p:blipFill>
         <p:spPr>
@@ -25844,14 +26151,14 @@
       </p:pic>
       <p:pic>
         <p:nvPicPr>
-          <p:cNvPr id="17" name=""/>
+          <p:cNvPr id="19" name=""/>
           <p:cNvPicPr>
             <a:picLocks xmlns:a="http://schemas.openxmlformats.org/drawingml/2006/main" noChangeAspect="1"/>
           </p:cNvPicPr>
           <p:nvPr/>
         </p:nvPicPr>
         <p:blipFill>
-          <a:blip xmlns:r="http://schemas.openxmlformats.org/officeDocument/2006/relationships" xmlns:a="http://schemas.openxmlformats.org/drawingml/2006/main" r:embed="Re7af129c9ce1423e"/>
+          <a:blip xmlns:r="http://schemas.openxmlformats.org/officeDocument/2006/relationships" xmlns:a="http://schemas.openxmlformats.org/drawingml/2006/main" r:embed="R7b9bc13e33fc445b"/>
           <a:stretch xmlns:a="http://schemas.openxmlformats.org/drawingml/2006/main"/>
         </p:blipFill>
         <p:spPr>
@@ -25899,6 +26206,7 @@
           <a:lstStyle xmlns:a="http://schemas.openxmlformats.org/drawingml/2006/main"/>
           <a:p xmlns:a="http://schemas.openxmlformats.org/drawingml/2006/main">
             <a:pPr algn="l">
+              <a:buNone/>
               <a:defRPr sz="3600" b="1">
                 <a:solidFill>
                   <a:srgbClr val="1F2A2A"/>
@@ -25957,6 +26265,7 @@
           <a:lstStyle xmlns:a="http://schemas.openxmlformats.org/drawingml/2006/main"/>
           <a:p xmlns:a="http://schemas.openxmlformats.org/drawingml/2006/main">
             <a:pPr algn="l">
+              <a:buNone/>
               <a:defRPr sz="2400" b="1">
                 <a:solidFill>
                   <a:srgbClr val="5A5E55"/>
@@ -26046,6 +26355,7 @@
           <a:lstStyle xmlns:a="http://schemas.openxmlformats.org/drawingml/2006/main"/>
           <a:p xmlns:a="http://schemas.openxmlformats.org/drawingml/2006/main">
             <a:pPr algn="ctr">
+              <a:buNone/>
               <a:defRPr sz="2400" b="1">
                 <a:solidFill>
                   <a:srgbClr val="1F4FC9"/>
@@ -26135,6 +26445,7 @@
           <a:lstStyle xmlns:a="http://schemas.openxmlformats.org/drawingml/2006/main"/>
           <a:p xmlns:a="http://schemas.openxmlformats.org/drawingml/2006/main">
             <a:pPr algn="ctr">
+              <a:buNone/>
               <a:defRPr sz="2400" b="1">
                 <a:solidFill>
                   <a:srgbClr val="1F4FC9"/>
@@ -26224,6 +26535,7 @@
           <a:lstStyle xmlns:a="http://schemas.openxmlformats.org/drawingml/2006/main"/>
           <a:p xmlns:a="http://schemas.openxmlformats.org/drawingml/2006/main">
             <a:pPr algn="ctr">
+              <a:buNone/>
               <a:defRPr sz="2400" b="1">
                 <a:solidFill>
                   <a:srgbClr val="1F4FC9"/>
@@ -26288,6 +26600,7 @@
           <a:lstStyle xmlns:a="http://schemas.openxmlformats.org/drawingml/2006/main"/>
           <a:p xmlns:a="http://schemas.openxmlformats.org/drawingml/2006/main">
             <a:pPr algn="ctr">
+              <a:buNone/>
               <a:defRPr sz="2400" b="1">
                 <a:solidFill>
                   <a:srgbClr val="1F2A2A"/>
@@ -26311,6 +26624,7 @@
           </a:p>
           <a:p xmlns:a="http://schemas.openxmlformats.org/drawingml/2006/main">
             <a:pPr algn="ctr">
+              <a:buNone/>
               <a:defRPr sz="2400" b="1">
                 <a:solidFill>
                   <a:srgbClr val="1F2A2A"/>
@@ -26375,6 +26689,7 @@
           <a:lstStyle xmlns:a="http://schemas.openxmlformats.org/drawingml/2006/main"/>
           <a:p xmlns:a="http://schemas.openxmlformats.org/drawingml/2006/main">
             <a:pPr algn="ctr">
+              <a:buNone/>
               <a:defRPr sz="2400" b="1">
                 <a:solidFill>
                   <a:srgbClr val="1F2A2A"/>
@@ -26398,6 +26713,7 @@
           </a:p>
           <a:p xmlns:a="http://schemas.openxmlformats.org/drawingml/2006/main">
             <a:pPr algn="ctr">
+              <a:buNone/>
               <a:defRPr sz="2400" b="1">
                 <a:solidFill>
                   <a:srgbClr val="1F2A2A"/>
@@ -26462,6 +26778,7 @@
           <a:lstStyle xmlns:a="http://schemas.openxmlformats.org/drawingml/2006/main"/>
           <a:p xmlns:a="http://schemas.openxmlformats.org/drawingml/2006/main">
             <a:pPr algn="ctr">
+              <a:buNone/>
               <a:defRPr sz="2400" b="1">
                 <a:solidFill>
                   <a:srgbClr val="1F2A2A"/>
@@ -26526,6 +26843,7 @@
           <a:lstStyle xmlns:a="http://schemas.openxmlformats.org/drawingml/2006/main"/>
           <a:p xmlns:a="http://schemas.openxmlformats.org/drawingml/2006/main">
             <a:pPr algn="ctr">
+              <a:buNone/>
               <a:defRPr sz="2400" b="1">
                 <a:solidFill>
                   <a:srgbClr val="FFFFFF"/>
@@ -26549,6 +26867,7 @@
           </a:p>
           <a:p xmlns:a="http://schemas.openxmlformats.org/drawingml/2006/main">
             <a:pPr algn="ctr">
+              <a:buNone/>
               <a:defRPr sz="2400" b="1">
                 <a:solidFill>
                   <a:srgbClr val="FFFFFF"/>
@@ -26607,6 +26926,7 @@
           <a:lstStyle xmlns:a="http://schemas.openxmlformats.org/drawingml/2006/main"/>
           <a:p xmlns:a="http://schemas.openxmlformats.org/drawingml/2006/main">
             <a:pPr algn="ctr">
+              <a:buNone/>
               <a:defRPr sz="1650" b="1">
                 <a:solidFill>
                   <a:srgbClr val="1F4FC9"/>
@@ -26661,14 +26981,14 @@
       </p:grpSpPr>
       <p:pic>
         <p:nvPicPr>
-          <p:cNvPr id="8" name=""/>
+          <p:cNvPr id="10" name=""/>
           <p:cNvPicPr>
             <a:picLocks xmlns:a="http://schemas.openxmlformats.org/drawingml/2006/main" noChangeAspect="1"/>
           </p:cNvPicPr>
           <p:nvPr/>
         </p:nvPicPr>
         <p:blipFill>
-          <a:blip xmlns:r="http://schemas.openxmlformats.org/officeDocument/2006/relationships" xmlns:a="http://schemas.openxmlformats.org/drawingml/2006/main" r:embed="R444e9a1960014ec1"/>
+          <a:blip xmlns:r="http://schemas.openxmlformats.org/officeDocument/2006/relationships" xmlns:a="http://schemas.openxmlformats.org/drawingml/2006/main" r:embed="R106137055ba4488e"/>
           <a:stretch xmlns:a="http://schemas.openxmlformats.org/drawingml/2006/main"/>
         </p:blipFill>
         <p:spPr>
@@ -26683,14 +27003,14 @@
       </p:pic>
       <p:pic>
         <p:nvPicPr>
-          <p:cNvPr id="9" name=""/>
+          <p:cNvPr id="11" name=""/>
           <p:cNvPicPr>
             <a:picLocks xmlns:a="http://schemas.openxmlformats.org/drawingml/2006/main" noChangeAspect="1"/>
           </p:cNvPicPr>
           <p:nvPr/>
         </p:nvPicPr>
         <p:blipFill>
-          <a:blip xmlns:r="http://schemas.openxmlformats.org/officeDocument/2006/relationships" xmlns:a="http://schemas.openxmlformats.org/drawingml/2006/main" r:embed="R0e49eb58f234406f"/>
+          <a:blip xmlns:r="http://schemas.openxmlformats.org/officeDocument/2006/relationships" xmlns:a="http://schemas.openxmlformats.org/drawingml/2006/main" r:embed="Rf6b299303aec4247"/>
           <a:stretch xmlns:a="http://schemas.openxmlformats.org/drawingml/2006/main"/>
         </p:blipFill>
         <p:spPr>
@@ -26738,6 +27058,7 @@
           <a:lstStyle xmlns:a="http://schemas.openxmlformats.org/drawingml/2006/main"/>
           <a:p xmlns:a="http://schemas.openxmlformats.org/drawingml/2006/main">
             <a:pPr algn="l">
+              <a:buNone/>
               <a:defRPr sz="3600" b="1">
                 <a:solidFill>
                   <a:srgbClr val="1F2A2A"/>
@@ -26796,6 +27117,7 @@
           <a:lstStyle xmlns:a="http://schemas.openxmlformats.org/drawingml/2006/main"/>
           <a:p xmlns:a="http://schemas.openxmlformats.org/drawingml/2006/main">
             <a:pPr algn="l">
+              <a:buNone/>
               <a:defRPr sz="2400" b="1">
                 <a:solidFill>
                   <a:srgbClr val="5A5E55"/>
@@ -26854,6 +27176,7 @@
           <a:lstStyle xmlns:a="http://schemas.openxmlformats.org/drawingml/2006/main"/>
           <a:p xmlns:a="http://schemas.openxmlformats.org/drawingml/2006/main">
             <a:pPr algn="l">
+              <a:buNone/>
               <a:defRPr sz="1650" b="1">
                 <a:solidFill>
                   <a:srgbClr val="1F4FC9"/>
@@ -26943,6 +27266,7 @@
           <a:lstStyle xmlns:a="http://schemas.openxmlformats.org/drawingml/2006/main"/>
           <a:p xmlns:a="http://schemas.openxmlformats.org/drawingml/2006/main">
             <a:pPr algn="l">
+              <a:buNone/>
               <a:defRPr sz="1650" b="0">
                 <a:solidFill>
                   <a:srgbClr val="1F2A2A"/>

</xml_diff>